<commit_message>
Update report: larger fonts, detailed withdrawal reasons
Co-Authored-By: Claude Sonnet 4.6 <noreply@anthropic.com>
Claude-Session: https://claude.ai/code/session_013nk1DEsSGa4nKpUoythx1H
</commit_message>
<xml_diff>
--- a/上位校採用分析レポート_2026.pptx
+++ b/上位校採用分析レポート_2026.pptx
@@ -3147,7 +3147,7 @@
         <p:spPr>
           <a:xfrm>
             <a:off x="0" y="0"/>
-            <a:ext cx="12188952" cy="109728"/>
+            <a:ext cx="12188952" cy="128016"/>
           </a:xfrm>
           <a:prstGeom prst="rect">
             <a:avLst/>
@@ -3189,8 +3189,8 @@
         </p:nvSpPr>
         <p:spPr>
           <a:xfrm>
-            <a:off x="0" y="6748272"/>
-            <a:ext cx="12188952" cy="109728"/>
+            <a:off x="0" y="6729984"/>
+            <a:ext cx="12188952" cy="128016"/>
           </a:xfrm>
           <a:prstGeom prst="rect">
             <a:avLst/>
@@ -3232,8 +3232,8 @@
         </p:nvSpPr>
         <p:spPr>
           <a:xfrm>
-            <a:off x="8686800" y="109728"/>
-            <a:ext cx="3502152" cy="6638544"/>
+            <a:off x="8686800" y="128016"/>
+            <a:ext cx="3502152" cy="6601968"/>
           </a:xfrm>
           <a:prstGeom prst="rect">
             <a:avLst/>
@@ -3275,8 +3275,8 @@
         </p:nvSpPr>
         <p:spPr>
           <a:xfrm>
-            <a:off x="640080" y="1645920"/>
-            <a:ext cx="8229600" cy="1097280"/>
+            <a:off x="640080" y="1554480"/>
+            <a:ext cx="8229600" cy="1188720"/>
           </a:xfrm>
           <a:prstGeom prst="rect">
             <a:avLst/>
@@ -3291,7 +3291,7 @@
           <a:p>
             <a:pPr algn="l"/>
             <a:r>
-              <a:rPr sz="3400" b="1">
+              <a:rPr sz="3600" b="1">
                 <a:solidFill>
                   <a:srgbClr val="FFFFFF"/>
                 </a:solidFill>
@@ -3311,7 +3311,7 @@
         <p:spPr>
           <a:xfrm>
             <a:off x="640080" y="2743200"/>
-            <a:ext cx="7315200" cy="548640"/>
+            <a:ext cx="7772400" cy="640080"/>
           </a:xfrm>
           <a:prstGeom prst="rect">
             <a:avLst/>
@@ -3326,7 +3326,7 @@
           <a:p>
             <a:pPr algn="l"/>
             <a:r>
-              <a:rPr sz="1800" b="0">
+              <a:rPr sz="2000" b="0">
                 <a:solidFill>
                   <a:srgbClr val="C9A227"/>
                 </a:solidFill>
@@ -3345,8 +3345,8 @@
         </p:nvSpPr>
         <p:spPr>
           <a:xfrm>
-            <a:off x="640080" y="3383280"/>
-            <a:ext cx="7772400" cy="777240"/>
+            <a:off x="640080" y="3429000"/>
+            <a:ext cx="7772400" cy="548640"/>
           </a:xfrm>
           <a:prstGeom prst="rect">
             <a:avLst/>
@@ -3367,8 +3367,7 @@
                 </a:solidFill>
                 <a:latin typeface="IPAGothic"/>
               </a:rPr>
-              <a:t>対象：GMARCH以上の偏差値を有する大学出身者
-（旧帝大・早慶・上智・理科大・ICU・GMARCH・関関同立）</a:t>
+              <a:t>対象：GMARCH以上（旧帝大・早慶・上智・理科大・ICU・GMARCH・関関同立）</a:t>
             </a:r>
           </a:p>
         </p:txBody>
@@ -3381,7 +3380,7 @@
         </p:nvSpPr>
         <p:spPr>
           <a:xfrm>
-            <a:off x="640080" y="5029200"/>
+            <a:off x="640080" y="5120640"/>
             <a:ext cx="3657600" cy="457200"/>
           </a:xfrm>
           <a:prstGeom prst="rect">
@@ -3397,7 +3396,7 @@
           <a:p>
             <a:pPr algn="l"/>
             <a:r>
-              <a:rPr sz="1300" b="0">
+              <a:rPr sz="1400" b="0">
                 <a:solidFill>
                   <a:srgbClr val="99AABB"/>
                 </a:solidFill>
@@ -3417,7 +3416,7 @@
         <p:spPr>
           <a:xfrm>
             <a:off x="8869680" y="1645920"/>
-            <a:ext cx="3017520" cy="411480"/>
+            <a:ext cx="3017520" cy="457200"/>
           </a:xfrm>
           <a:prstGeom prst="rect">
             <a:avLst/>
@@ -3432,7 +3431,7 @@
           <a:p>
             <a:pPr algn="ctr"/>
             <a:r>
-              <a:rPr sz="1300" b="0">
+              <a:rPr sz="1400" b="0">
                 <a:solidFill>
                   <a:srgbClr val="C9A227"/>
                 </a:solidFill>
@@ -3451,8 +3450,8 @@
         </p:nvSpPr>
         <p:spPr>
           <a:xfrm>
-            <a:off x="8869680" y="2011680"/>
-            <a:ext cx="3017520" cy="777240"/>
+            <a:off x="8869680" y="2057400"/>
+            <a:ext cx="3017520" cy="822960"/>
           </a:xfrm>
           <a:prstGeom prst="rect">
             <a:avLst/>
@@ -3467,7 +3466,7 @@
           <a:p>
             <a:pPr algn="ctr"/>
             <a:r>
-              <a:rPr sz="3600" b="1">
+              <a:rPr sz="3800" b="1">
                 <a:solidFill>
                   <a:srgbClr val="FFFFFF"/>
                 </a:solidFill>
@@ -3486,8 +3485,8 @@
         </p:nvSpPr>
         <p:spPr>
           <a:xfrm>
-            <a:off x="9052560" y="2880360"/>
-            <a:ext cx="2743200" cy="45720"/>
+            <a:off x="9052560" y="2926080"/>
+            <a:ext cx="2743200" cy="54864"/>
           </a:xfrm>
           <a:prstGeom prst="rect">
             <a:avLst/>
@@ -3530,7 +3529,7 @@
         <p:spPr>
           <a:xfrm>
             <a:off x="8869680" y="3017520"/>
-            <a:ext cx="3017520" cy="411480"/>
+            <a:ext cx="3017520" cy="457200"/>
           </a:xfrm>
           <a:prstGeom prst="rect">
             <a:avLst/>
@@ -3545,7 +3544,7 @@
           <a:p>
             <a:pPr algn="ctr"/>
             <a:r>
-              <a:rPr sz="1300" b="0">
+              <a:rPr sz="1400" b="0">
                 <a:solidFill>
                   <a:srgbClr val="C9A227"/>
                 </a:solidFill>
@@ -3564,8 +3563,8 @@
         </p:nvSpPr>
         <p:spPr>
           <a:xfrm>
-            <a:off x="8869680" y="3383280"/>
-            <a:ext cx="3017520" cy="777240"/>
+            <a:off x="8869680" y="3429000"/>
+            <a:ext cx="3017520" cy="822960"/>
           </a:xfrm>
           <a:prstGeom prst="rect">
             <a:avLst/>
@@ -3580,7 +3579,7 @@
           <a:p>
             <a:pPr algn="ctr"/>
             <a:r>
-              <a:rPr sz="3600" b="1">
+              <a:rPr sz="3800" b="1">
                 <a:solidFill>
                   <a:srgbClr val="FFFFFF"/>
                 </a:solidFill>
@@ -3599,8 +3598,8 @@
         </p:nvSpPr>
         <p:spPr>
           <a:xfrm>
-            <a:off x="9052560" y="4251960"/>
-            <a:ext cx="2743200" cy="45720"/>
+            <a:off x="9052560" y="4297679"/>
+            <a:ext cx="2743200" cy="54864"/>
           </a:xfrm>
           <a:prstGeom prst="rect">
             <a:avLst/>
@@ -3643,7 +3642,7 @@
         <p:spPr>
           <a:xfrm>
             <a:off x="8869680" y="4389120"/>
-            <a:ext cx="3017520" cy="411480"/>
+            <a:ext cx="3017520" cy="457200"/>
           </a:xfrm>
           <a:prstGeom prst="rect">
             <a:avLst/>
@@ -3658,7 +3657,7 @@
           <a:p>
             <a:pPr algn="ctr"/>
             <a:r>
-              <a:rPr sz="1300" b="0">
+              <a:rPr sz="1400" b="0">
                 <a:solidFill>
                   <a:srgbClr val="C9A227"/>
                 </a:solidFill>
@@ -3677,8 +3676,8 @@
         </p:nvSpPr>
         <p:spPr>
           <a:xfrm>
-            <a:off x="8869680" y="4754880"/>
-            <a:ext cx="3017520" cy="777240"/>
+            <a:off x="8869680" y="4800600"/>
+            <a:ext cx="3017520" cy="822960"/>
           </a:xfrm>
           <a:prstGeom prst="rect">
             <a:avLst/>
@@ -3693,7 +3692,7 @@
           <a:p>
             <a:pPr algn="ctr"/>
             <a:r>
-              <a:rPr sz="3600" b="1">
+              <a:rPr sz="3800" b="1">
                 <a:solidFill>
                   <a:srgbClr val="FFFFFF"/>
                 </a:solidFill>
@@ -3701,6 +3700,49 @@
               </a:rPr>
               <a:t>28名</a:t>
             </a:r>
+          </a:p>
+        </p:txBody>
+      </p:sp>
+      <p:sp>
+        <p:nvSpPr>
+          <p:cNvPr id="18" name="Rectangle 17"/>
+          <p:cNvSpPr/>
+          <p:nvPr/>
+        </p:nvSpPr>
+        <p:spPr>
+          <a:xfrm>
+            <a:off x="9052560" y="5669279"/>
+            <a:ext cx="2743200" cy="54864"/>
+          </a:xfrm>
+          <a:prstGeom prst="rect">
+            <a:avLst/>
+          </a:prstGeom>
+          <a:solidFill>
+            <a:srgbClr val="C9A227"/>
+          </a:solidFill>
+          <a:ln>
+            <a:noFill/>
+          </a:ln>
+        </p:spPr>
+        <p:style>
+          <a:lnRef idx="1">
+            <a:schemeClr val="accent1"/>
+          </a:lnRef>
+          <a:fillRef idx="3">
+            <a:schemeClr val="accent1"/>
+          </a:fillRef>
+          <a:effectRef idx="2">
+            <a:schemeClr val="accent1"/>
+          </a:effectRef>
+          <a:fontRef idx="minor">
+            <a:schemeClr val="lt1"/>
+          </a:fontRef>
+        </p:style>
+        <p:txBody>
+          <a:bodyPr rtlCol="0" anchor="ctr"/>
+          <a:lstStyle/>
+          <a:p>
+            <a:pPr algn="ctr"/>
           </a:p>
         </p:txBody>
       </p:sp>
@@ -3731,7 +3773,50 @@
         <p:spPr>
           <a:xfrm>
             <a:off x="0" y="0"/>
-            <a:ext cx="12188952" cy="1005840"/>
+            <a:ext cx="12188952" cy="6858000"/>
+          </a:xfrm>
+          <a:prstGeom prst="rect">
+            <a:avLst/>
+          </a:prstGeom>
+          <a:solidFill>
+            <a:srgbClr val="F8F9FA"/>
+          </a:solidFill>
+          <a:ln>
+            <a:noFill/>
+          </a:ln>
+        </p:spPr>
+        <p:style>
+          <a:lnRef idx="1">
+            <a:schemeClr val="accent1"/>
+          </a:lnRef>
+          <a:fillRef idx="3">
+            <a:schemeClr val="accent1"/>
+          </a:fillRef>
+          <a:effectRef idx="2">
+            <a:schemeClr val="accent1"/>
+          </a:effectRef>
+          <a:fontRef idx="minor">
+            <a:schemeClr val="lt1"/>
+          </a:fontRef>
+        </p:style>
+        <p:txBody>
+          <a:bodyPr rtlCol="0" anchor="ctr"/>
+          <a:lstStyle/>
+          <a:p>
+            <a:pPr algn="ctr"/>
+          </a:p>
+        </p:txBody>
+      </p:sp>
+      <p:sp>
+        <p:nvSpPr>
+          <p:cNvPr id="3" name="Rectangle 2"/>
+          <p:cNvSpPr/>
+          <p:nvPr/>
+        </p:nvSpPr>
+        <p:spPr>
+          <a:xfrm>
+            <a:off x="0" y="0"/>
+            <a:ext cx="12188952" cy="1051560"/>
           </a:xfrm>
           <a:prstGeom prst="rect">
             <a:avLst/>
@@ -3767,14 +3852,14 @@
       </p:sp>
       <p:sp>
         <p:nvSpPr>
-          <p:cNvPr id="3" name="Rectangle 2"/>
+          <p:cNvPr id="4" name="Rectangle 3"/>
           <p:cNvSpPr/>
           <p:nvPr/>
         </p:nvSpPr>
         <p:spPr>
           <a:xfrm>
-            <a:off x="0" y="914400"/>
-            <a:ext cx="12188952" cy="73152"/>
+            <a:off x="0" y="987552"/>
+            <a:ext cx="12188952" cy="91440"/>
           </a:xfrm>
           <a:prstGeom prst="rect">
             <a:avLst/>
@@ -3810,14 +3895,14 @@
       </p:sp>
       <p:sp>
         <p:nvSpPr>
-          <p:cNvPr id="4" name="TextBox 3"/>
+          <p:cNvPr id="5" name="TextBox 4"/>
           <p:cNvSpPr txBox="1"/>
           <p:nvPr/>
         </p:nvSpPr>
         <p:spPr>
           <a:xfrm>
-            <a:off x="365760" y="91440"/>
-            <a:ext cx="9144000" cy="731520"/>
+            <a:off x="411480" y="91440"/>
+            <a:ext cx="10058400" cy="713232"/>
           </a:xfrm>
           <a:prstGeom prst="rect">
             <a:avLst/>
@@ -3832,7 +3917,7 @@
           <a:p>
             <a:pPr algn="l"/>
             <a:r>
-              <a:rPr sz="2400" b="1">
+              <a:rPr sz="2600" b="1">
                 <a:solidFill>
                   <a:srgbClr val="FFFFFF"/>
                 </a:solidFill>
@@ -3845,14 +3930,14 @@
       </p:sp>
       <p:sp>
         <p:nvSpPr>
-          <p:cNvPr id="5" name="TextBox 4"/>
+          <p:cNvPr id="6" name="TextBox 5"/>
           <p:cNvSpPr txBox="1"/>
           <p:nvPr/>
         </p:nvSpPr>
         <p:spPr>
           <a:xfrm>
-            <a:off x="365760" y="685800"/>
-            <a:ext cx="9144000" cy="320040"/>
+            <a:off x="411480" y="685800"/>
+            <a:ext cx="9144000" cy="347472"/>
           </a:xfrm>
           <a:prstGeom prst="rect">
             <a:avLst/>
@@ -3867,7 +3952,7 @@
           <a:p>
             <a:pPr algn="l"/>
             <a:r>
-              <a:rPr sz="1200" b="0">
+              <a:rPr sz="1300" b="0">
                 <a:solidFill>
                   <a:srgbClr val="CCD6E8"/>
                 </a:solidFill>
@@ -3880,57 +3965,14 @@
       </p:sp>
       <p:sp>
         <p:nvSpPr>
-          <p:cNvPr id="6" name="Rectangle 5"/>
-          <p:cNvSpPr/>
-          <p:nvPr/>
-        </p:nvSpPr>
-        <p:spPr>
-          <a:xfrm>
-            <a:off x="0" y="987552"/>
-            <a:ext cx="12188952" cy="5870448"/>
-          </a:xfrm>
-          <a:prstGeom prst="rect">
-            <a:avLst/>
-          </a:prstGeom>
-          <a:solidFill>
-            <a:srgbClr val="F8F9FA"/>
-          </a:solidFill>
-          <a:ln>
-            <a:noFill/>
-          </a:ln>
-        </p:spPr>
-        <p:style>
-          <a:lnRef idx="1">
-            <a:schemeClr val="accent1"/>
-          </a:lnRef>
-          <a:fillRef idx="3">
-            <a:schemeClr val="accent1"/>
-          </a:fillRef>
-          <a:effectRef idx="2">
-            <a:schemeClr val="accent1"/>
-          </a:effectRef>
-          <a:fontRef idx="minor">
-            <a:schemeClr val="lt1"/>
-          </a:fontRef>
-        </p:style>
-        <p:txBody>
-          <a:bodyPr rtlCol="0" anchor="ctr"/>
-          <a:lstStyle/>
-          <a:p>
-            <a:pPr algn="ctr"/>
-          </a:p>
-        </p:txBody>
-      </p:sp>
-      <p:sp>
-        <p:nvSpPr>
           <p:cNvPr id="7" name="Rectangle 6"/>
           <p:cNvSpPr/>
           <p:nvPr/>
         </p:nvSpPr>
         <p:spPr>
           <a:xfrm>
-            <a:off x="457200" y="1371600"/>
-            <a:ext cx="2560320" cy="1920240"/>
+            <a:off x="365760" y="1325880"/>
+            <a:ext cx="2743200" cy="1920240"/>
           </a:xfrm>
           <a:prstGeom prst="rect">
             <a:avLst/>
@@ -3972,8 +4014,8 @@
         </p:nvSpPr>
         <p:spPr>
           <a:xfrm>
-            <a:off x="457200" y="1371600"/>
-            <a:ext cx="54864" cy="1920240"/>
+            <a:off x="365760" y="1325880"/>
+            <a:ext cx="64008" cy="1920240"/>
           </a:xfrm>
           <a:prstGeom prst="rect">
             <a:avLst/>
@@ -4015,8 +4057,8 @@
         </p:nvSpPr>
         <p:spPr>
           <a:xfrm>
-            <a:off x="594360" y="1508760"/>
-            <a:ext cx="2377439" cy="411480"/>
+            <a:off x="530352" y="1444752"/>
+            <a:ext cx="2468880" cy="411480"/>
           </a:xfrm>
           <a:prstGeom prst="rect">
             <a:avLst/>
@@ -4031,7 +4073,7 @@
           <a:p>
             <a:pPr algn="l"/>
             <a:r>
-              <a:rPr sz="1300" b="0">
+              <a:rPr sz="1400" b="0">
                 <a:solidFill>
                   <a:srgbClr val="4A4A4A"/>
                 </a:solidFill>
@@ -4050,8 +4092,8 @@
         </p:nvSpPr>
         <p:spPr>
           <a:xfrm>
-            <a:off x="594360" y="1828800"/>
-            <a:ext cx="1645920" cy="822960"/>
+            <a:off x="530352" y="1828800"/>
+            <a:ext cx="1737360" cy="822960"/>
           </a:xfrm>
           <a:prstGeom prst="rect">
             <a:avLst/>
@@ -4066,7 +4108,7 @@
           <a:p>
             <a:pPr algn="l"/>
             <a:r>
-              <a:rPr sz="4000" b="1">
+              <a:rPr sz="4200" b="1">
                 <a:solidFill>
                   <a:srgbClr val="1E3A5F"/>
                 </a:solidFill>
@@ -4085,8 +4127,8 @@
         </p:nvSpPr>
         <p:spPr>
           <a:xfrm>
-            <a:off x="1965960" y="2194560"/>
-            <a:ext cx="731520" cy="411480"/>
+            <a:off x="1993392" y="2240280"/>
+            <a:ext cx="731520" cy="365760"/>
           </a:xfrm>
           <a:prstGeom prst="rect">
             <a:avLst/>
@@ -4101,7 +4143,7 @@
           <a:p>
             <a:pPr algn="l"/>
             <a:r>
-              <a:rPr sz="1400" b="0">
+              <a:rPr sz="1600" b="0">
                 <a:solidFill>
                   <a:srgbClr val="4A4A4A"/>
                 </a:solidFill>
@@ -4120,8 +4162,8 @@
         </p:nvSpPr>
         <p:spPr>
           <a:xfrm>
-            <a:off x="594360" y="2788920"/>
-            <a:ext cx="2286000" cy="365760"/>
+            <a:off x="530352" y="2788920"/>
+            <a:ext cx="2468880" cy="365760"/>
           </a:xfrm>
           <a:prstGeom prst="rect">
             <a:avLst/>
@@ -4136,7 +4178,7 @@
           <a:p>
             <a:pPr algn="l"/>
             <a:r>
-              <a:rPr sz="1100" b="0">
+              <a:rPr sz="1300" b="0">
                 <a:solidFill>
                   <a:srgbClr val="7F7F7F"/>
                 </a:solidFill>
@@ -4155,8 +4197,8 @@
         </p:nvSpPr>
         <p:spPr>
           <a:xfrm>
-            <a:off x="3291840" y="1371600"/>
-            <a:ext cx="2560320" cy="1920240"/>
+            <a:off x="3291840" y="1325880"/>
+            <a:ext cx="2743200" cy="1920240"/>
           </a:xfrm>
           <a:prstGeom prst="rect">
             <a:avLst/>
@@ -4198,8 +4240,8 @@
         </p:nvSpPr>
         <p:spPr>
           <a:xfrm>
-            <a:off x="3291840" y="1371600"/>
-            <a:ext cx="54864" cy="1920240"/>
+            <a:off x="3291840" y="1325880"/>
+            <a:ext cx="64008" cy="1920240"/>
           </a:xfrm>
           <a:prstGeom prst="rect">
             <a:avLst/>
@@ -4241,8 +4283,8 @@
         </p:nvSpPr>
         <p:spPr>
           <a:xfrm>
-            <a:off x="3429000" y="1508760"/>
-            <a:ext cx="2377439" cy="411480"/>
+            <a:off x="3456432" y="1444752"/>
+            <a:ext cx="2468880" cy="411480"/>
           </a:xfrm>
           <a:prstGeom prst="rect">
             <a:avLst/>
@@ -4257,7 +4299,7 @@
           <a:p>
             <a:pPr algn="l"/>
             <a:r>
-              <a:rPr sz="1300" b="0">
+              <a:rPr sz="1400" b="0">
                 <a:solidFill>
                   <a:srgbClr val="4A4A4A"/>
                 </a:solidFill>
@@ -4276,8 +4318,8 @@
         </p:nvSpPr>
         <p:spPr>
           <a:xfrm>
-            <a:off x="3429000" y="1828800"/>
-            <a:ext cx="1645920" cy="822960"/>
+            <a:off x="3456432" y="1828800"/>
+            <a:ext cx="1737360" cy="822960"/>
           </a:xfrm>
           <a:prstGeom prst="rect">
             <a:avLst/>
@@ -4292,7 +4334,7 @@
           <a:p>
             <a:pPr algn="l"/>
             <a:r>
-              <a:rPr sz="4000" b="1">
+              <a:rPr sz="4200" b="1">
                 <a:solidFill>
                   <a:srgbClr val="4A90D9"/>
                 </a:solidFill>
@@ -4311,8 +4353,8 @@
         </p:nvSpPr>
         <p:spPr>
           <a:xfrm>
-            <a:off x="4800600" y="2194560"/>
-            <a:ext cx="731520" cy="411480"/>
+            <a:off x="4919472" y="2240280"/>
+            <a:ext cx="731520" cy="365760"/>
           </a:xfrm>
           <a:prstGeom prst="rect">
             <a:avLst/>
@@ -4327,7 +4369,7 @@
           <a:p>
             <a:pPr algn="l"/>
             <a:r>
-              <a:rPr sz="1400" b="0">
+              <a:rPr sz="1600" b="0">
                 <a:solidFill>
                   <a:srgbClr val="4A4A4A"/>
                 </a:solidFill>
@@ -4346,8 +4388,8 @@
         </p:nvSpPr>
         <p:spPr>
           <a:xfrm>
-            <a:off x="3429000" y="2788920"/>
-            <a:ext cx="2286000" cy="365760"/>
+            <a:off x="3456432" y="2788920"/>
+            <a:ext cx="2468880" cy="365760"/>
           </a:xfrm>
           <a:prstGeom prst="rect">
             <a:avLst/>
@@ -4362,7 +4404,7 @@
           <a:p>
             <a:pPr algn="l"/>
             <a:r>
-              <a:rPr sz="1100" b="0">
+              <a:rPr sz="1300" b="0">
                 <a:solidFill>
                   <a:srgbClr val="7F7F7F"/>
                 </a:solidFill>
@@ -4381,8 +4423,8 @@
         </p:nvSpPr>
         <p:spPr>
           <a:xfrm>
-            <a:off x="6126480" y="1371600"/>
-            <a:ext cx="2560320" cy="1920240"/>
+            <a:off x="6217920" y="1325880"/>
+            <a:ext cx="2743200" cy="1920240"/>
           </a:xfrm>
           <a:prstGeom prst="rect">
             <a:avLst/>
@@ -4424,8 +4466,8 @@
         </p:nvSpPr>
         <p:spPr>
           <a:xfrm>
-            <a:off x="6126480" y="1371600"/>
-            <a:ext cx="54864" cy="1920240"/>
+            <a:off x="6217920" y="1325880"/>
+            <a:ext cx="64008" cy="1920240"/>
           </a:xfrm>
           <a:prstGeom prst="rect">
             <a:avLst/>
@@ -4467,8 +4509,8 @@
         </p:nvSpPr>
         <p:spPr>
           <a:xfrm>
-            <a:off x="6263640" y="1508760"/>
-            <a:ext cx="2377439" cy="411480"/>
+            <a:off x="6382512" y="1444752"/>
+            <a:ext cx="2468880" cy="411480"/>
           </a:xfrm>
           <a:prstGeom prst="rect">
             <a:avLst/>
@@ -4483,7 +4525,7 @@
           <a:p>
             <a:pPr algn="l"/>
             <a:r>
-              <a:rPr sz="1300" b="0">
+              <a:rPr sz="1400" b="0">
                 <a:solidFill>
                   <a:srgbClr val="4A4A4A"/>
                 </a:solidFill>
@@ -4502,8 +4544,8 @@
         </p:nvSpPr>
         <p:spPr>
           <a:xfrm>
-            <a:off x="6263640" y="1828800"/>
-            <a:ext cx="1645920" cy="822960"/>
+            <a:off x="6382512" y="1828800"/>
+            <a:ext cx="1737360" cy="822960"/>
           </a:xfrm>
           <a:prstGeom prst="rect">
             <a:avLst/>
@@ -4518,7 +4560,7 @@
           <a:p>
             <a:pPr algn="l"/>
             <a:r>
-              <a:rPr sz="4000" b="1">
+              <a:rPr sz="4200" b="1">
                 <a:solidFill>
                   <a:srgbClr val="C9A227"/>
                 </a:solidFill>
@@ -4537,8 +4579,8 @@
         </p:nvSpPr>
         <p:spPr>
           <a:xfrm>
-            <a:off x="7635240" y="2194560"/>
-            <a:ext cx="731520" cy="411480"/>
+            <a:off x="7845552" y="2240280"/>
+            <a:ext cx="731520" cy="365760"/>
           </a:xfrm>
           <a:prstGeom prst="rect">
             <a:avLst/>
@@ -4553,7 +4595,7 @@
           <a:p>
             <a:pPr algn="l"/>
             <a:r>
-              <a:rPr sz="1400" b="0">
+              <a:rPr sz="1600" b="0">
                 <a:solidFill>
                   <a:srgbClr val="4A4A4A"/>
                 </a:solidFill>
@@ -4572,8 +4614,8 @@
         </p:nvSpPr>
         <p:spPr>
           <a:xfrm>
-            <a:off x="6263640" y="2788920"/>
-            <a:ext cx="2286000" cy="365760"/>
+            <a:off x="6382512" y="2788920"/>
+            <a:ext cx="2468880" cy="365760"/>
           </a:xfrm>
           <a:prstGeom prst="rect">
             <a:avLst/>
@@ -4588,7 +4630,7 @@
           <a:p>
             <a:pPr algn="l"/>
             <a:r>
-              <a:rPr sz="1100" b="0">
+              <a:rPr sz="1300" b="0">
                 <a:solidFill>
                   <a:srgbClr val="7F7F7F"/>
                 </a:solidFill>
@@ -4607,8 +4649,8 @@
         </p:nvSpPr>
         <p:spPr>
           <a:xfrm>
-            <a:off x="8961120" y="1371600"/>
-            <a:ext cx="2560320" cy="1920240"/>
+            <a:off x="9144000" y="1325880"/>
+            <a:ext cx="2743200" cy="1920240"/>
           </a:xfrm>
           <a:prstGeom prst="rect">
             <a:avLst/>
@@ -4650,8 +4692,8 @@
         </p:nvSpPr>
         <p:spPr>
           <a:xfrm>
-            <a:off x="8961120" y="1371600"/>
-            <a:ext cx="54864" cy="1920240"/>
+            <a:off x="9144000" y="1325880"/>
+            <a:ext cx="64008" cy="1920240"/>
           </a:xfrm>
           <a:prstGeom prst="rect">
             <a:avLst/>
@@ -4693,8 +4735,8 @@
         </p:nvSpPr>
         <p:spPr>
           <a:xfrm>
-            <a:off x="9098280" y="1508760"/>
-            <a:ext cx="2377439" cy="411480"/>
+            <a:off x="9308592" y="1444752"/>
+            <a:ext cx="2468880" cy="411480"/>
           </a:xfrm>
           <a:prstGeom prst="rect">
             <a:avLst/>
@@ -4709,7 +4751,7 @@
           <a:p>
             <a:pPr algn="l"/>
             <a:r>
-              <a:rPr sz="1300" b="0">
+              <a:rPr sz="1400" b="0">
                 <a:solidFill>
                   <a:srgbClr val="4A4A4A"/>
                 </a:solidFill>
@@ -4728,8 +4770,8 @@
         </p:nvSpPr>
         <p:spPr>
           <a:xfrm>
-            <a:off x="9098280" y="1828800"/>
-            <a:ext cx="1645920" cy="822960"/>
+            <a:off x="9308592" y="1828800"/>
+            <a:ext cx="1737360" cy="822960"/>
           </a:xfrm>
           <a:prstGeom prst="rect">
             <a:avLst/>
@@ -4744,7 +4786,7 @@
           <a:p>
             <a:pPr algn="l"/>
             <a:r>
-              <a:rPr sz="4000" b="1">
+              <a:rPr sz="4200" b="1">
                 <a:solidFill>
                   <a:srgbClr val="27AE60"/>
                 </a:solidFill>
@@ -4763,8 +4805,8 @@
         </p:nvSpPr>
         <p:spPr>
           <a:xfrm>
-            <a:off x="10469880" y="2194560"/>
-            <a:ext cx="731520" cy="411480"/>
+            <a:off x="10771632" y="2240280"/>
+            <a:ext cx="731520" cy="365760"/>
           </a:xfrm>
           <a:prstGeom prst="rect">
             <a:avLst/>
@@ -4779,7 +4821,7 @@
           <a:p>
             <a:pPr algn="l"/>
             <a:r>
-              <a:rPr sz="1400" b="0">
+              <a:rPr sz="1600" b="0">
                 <a:solidFill>
                   <a:srgbClr val="4A4A4A"/>
                 </a:solidFill>
@@ -4798,8 +4840,8 @@
         </p:nvSpPr>
         <p:spPr>
           <a:xfrm>
-            <a:off x="9098280" y="2788920"/>
-            <a:ext cx="2286000" cy="365760"/>
+            <a:off x="9308592" y="2788920"/>
+            <a:ext cx="2468880" cy="365760"/>
           </a:xfrm>
           <a:prstGeom prst="rect">
             <a:avLst/>
@@ -4814,7 +4856,7 @@
           <a:p>
             <a:pPr algn="l"/>
             <a:r>
-              <a:rPr sz="1100" b="0">
+              <a:rPr sz="1300" b="0">
                 <a:solidFill>
                   <a:srgbClr val="7F7F7F"/>
                 </a:solidFill>
@@ -4833,8 +4875,8 @@
         </p:nvSpPr>
         <p:spPr>
           <a:xfrm>
-            <a:off x="548640" y="3520440"/>
-            <a:ext cx="2377440" cy="457200"/>
+            <a:off x="365760" y="3401568"/>
+            <a:ext cx="2560320" cy="502920"/>
           </a:xfrm>
           <a:prstGeom prst="rect">
             <a:avLst/>
@@ -4849,7 +4891,7 @@
           <a:p>
             <a:pPr algn="ctr"/>
             <a:r>
-              <a:rPr sz="1400" b="1">
+              <a:rPr sz="1500" b="1">
                 <a:solidFill>
                   <a:srgbClr val="1E3A5F"/>
                 </a:solidFill>
@@ -4868,8 +4910,8 @@
         </p:nvSpPr>
         <p:spPr>
           <a:xfrm>
-            <a:off x="2926080" y="3520440"/>
-            <a:ext cx="457200" cy="457200"/>
+            <a:off x="3108960" y="3401568"/>
+            <a:ext cx="548640" cy="502920"/>
           </a:xfrm>
           <a:prstGeom prst="rect">
             <a:avLst/>
@@ -4884,7 +4926,7 @@
           <a:p>
             <a:pPr algn="ctr"/>
             <a:r>
-              <a:rPr sz="2000" b="1">
+              <a:rPr sz="2000" b="0">
                 <a:solidFill>
                   <a:srgbClr val="C9A227"/>
                 </a:solidFill>
@@ -4903,8 +4945,8 @@
         </p:nvSpPr>
         <p:spPr>
           <a:xfrm>
-            <a:off x="5760720" y="3520440"/>
-            <a:ext cx="457200" cy="457200"/>
+            <a:off x="3474720" y="3401568"/>
+            <a:ext cx="2560320" cy="502920"/>
           </a:xfrm>
           <a:prstGeom prst="rect">
             <a:avLst/>
@@ -4919,7 +4961,42 @@
           <a:p>
             <a:pPr algn="ctr"/>
             <a:r>
-              <a:rPr sz="2000" b="1">
+              <a:rPr sz="1500" b="1">
+                <a:solidFill>
+                  <a:srgbClr val="4A90D9"/>
+                </a:solidFill>
+                <a:latin typeface="IPAGothic"/>
+              </a:rPr>
+              <a:t>1次通過</a:t>
+            </a:r>
+          </a:p>
+        </p:txBody>
+      </p:sp>
+      <p:sp>
+        <p:nvSpPr>
+          <p:cNvPr id="34" name="TextBox 33"/>
+          <p:cNvSpPr txBox="1"/>
+          <p:nvPr/>
+        </p:nvSpPr>
+        <p:spPr>
+          <a:xfrm>
+            <a:off x="6035040" y="3401568"/>
+            <a:ext cx="548640" cy="502920"/>
+          </a:xfrm>
+          <a:prstGeom prst="rect">
+            <a:avLst/>
+          </a:prstGeom>
+          <a:noFill/>
+        </p:spPr>
+        <p:txBody>
+          <a:bodyPr wrap="square">
+            <a:spAutoFit/>
+          </a:bodyPr>
+          <a:lstStyle/>
+          <a:p>
+            <a:pPr algn="ctr"/>
+            <a:r>
+              <a:rPr sz="2000" b="0">
                 <a:solidFill>
                   <a:srgbClr val="C9A227"/>
                 </a:solidFill>
@@ -4932,14 +5009,14 @@
       </p:sp>
       <p:sp>
         <p:nvSpPr>
-          <p:cNvPr id="34" name="TextBox 33"/>
+          <p:cNvPr id="35" name="TextBox 34"/>
           <p:cNvSpPr txBox="1"/>
           <p:nvPr/>
         </p:nvSpPr>
         <p:spPr>
           <a:xfrm>
-            <a:off x="8595360" y="3520440"/>
-            <a:ext cx="457200" cy="457200"/>
+            <a:off x="6400800" y="3401568"/>
+            <a:ext cx="2560320" cy="502920"/>
           </a:xfrm>
           <a:prstGeom prst="rect">
             <a:avLst/>
@@ -4954,7 +5031,42 @@
           <a:p>
             <a:pPr algn="ctr"/>
             <a:r>
-              <a:rPr sz="2000" b="1">
+              <a:rPr sz="1500" b="1">
+                <a:solidFill>
+                  <a:srgbClr val="C9A227"/>
+                </a:solidFill>
+                <a:latin typeface="IPAGothic"/>
+              </a:rPr>
+              <a:t>2次通過</a:t>
+            </a:r>
+          </a:p>
+        </p:txBody>
+      </p:sp>
+      <p:sp>
+        <p:nvSpPr>
+          <p:cNvPr id="36" name="TextBox 35"/>
+          <p:cNvSpPr txBox="1"/>
+          <p:nvPr/>
+        </p:nvSpPr>
+        <p:spPr>
+          <a:xfrm>
+            <a:off x="8961120" y="3401568"/>
+            <a:ext cx="548640" cy="502920"/>
+          </a:xfrm>
+          <a:prstGeom prst="rect">
+            <a:avLst/>
+          </a:prstGeom>
+          <a:noFill/>
+        </p:spPr>
+        <p:txBody>
+          <a:bodyPr wrap="square">
+            <a:spAutoFit/>
+          </a:bodyPr>
+          <a:lstStyle/>
+          <a:p>
+            <a:pPr algn="ctr"/>
+            <a:r>
+              <a:rPr sz="2000" b="0">
                 <a:solidFill>
                   <a:srgbClr val="C9A227"/>
                 </a:solidFill>
@@ -4967,14 +5079,14 @@
       </p:sp>
       <p:sp>
         <p:nvSpPr>
-          <p:cNvPr id="35" name="TextBox 34"/>
+          <p:cNvPr id="37" name="TextBox 36"/>
           <p:cNvSpPr txBox="1"/>
           <p:nvPr/>
         </p:nvSpPr>
         <p:spPr>
           <a:xfrm>
-            <a:off x="3383280" y="3520440"/>
-            <a:ext cx="2377440" cy="457200"/>
+            <a:off x="9326880" y="3401568"/>
+            <a:ext cx="2560320" cy="502920"/>
           </a:xfrm>
           <a:prstGeom prst="rect">
             <a:avLst/>
@@ -4989,77 +5101,7 @@
           <a:p>
             <a:pPr algn="ctr"/>
             <a:r>
-              <a:rPr sz="1400" b="1">
-                <a:solidFill>
-                  <a:srgbClr val="4A90D9"/>
-                </a:solidFill>
-                <a:latin typeface="IPAGothic"/>
-              </a:rPr>
-              <a:t>1次通過</a:t>
-            </a:r>
-          </a:p>
-        </p:txBody>
-      </p:sp>
-      <p:sp>
-        <p:nvSpPr>
-          <p:cNvPr id="36" name="TextBox 35"/>
-          <p:cNvSpPr txBox="1"/>
-          <p:nvPr/>
-        </p:nvSpPr>
-        <p:spPr>
-          <a:xfrm>
-            <a:off x="6217920" y="3520440"/>
-            <a:ext cx="2377440" cy="457200"/>
-          </a:xfrm>
-          <a:prstGeom prst="rect">
-            <a:avLst/>
-          </a:prstGeom>
-          <a:noFill/>
-        </p:spPr>
-        <p:txBody>
-          <a:bodyPr wrap="square">
-            <a:spAutoFit/>
-          </a:bodyPr>
-          <a:lstStyle/>
-          <a:p>
-            <a:pPr algn="ctr"/>
-            <a:r>
-              <a:rPr sz="1400" b="1">
-                <a:solidFill>
-                  <a:srgbClr val="C9A227"/>
-                </a:solidFill>
-                <a:latin typeface="IPAGothic"/>
-              </a:rPr>
-              <a:t>2次通過</a:t>
-            </a:r>
-          </a:p>
-        </p:txBody>
-      </p:sp>
-      <p:sp>
-        <p:nvSpPr>
-          <p:cNvPr id="37" name="TextBox 36"/>
-          <p:cNvSpPr txBox="1"/>
-          <p:nvPr/>
-        </p:nvSpPr>
-        <p:spPr>
-          <a:xfrm>
-            <a:off x="9052560" y="3520440"/>
-            <a:ext cx="2377440" cy="457200"/>
-          </a:xfrm>
-          <a:prstGeom prst="rect">
-            <a:avLst/>
-          </a:prstGeom>
-          <a:noFill/>
-        </p:spPr>
-        <p:txBody>
-          <a:bodyPr wrap="square">
-            <a:spAutoFit/>
-          </a:bodyPr>
-          <a:lstStyle/>
-          <a:p>
-            <a:pPr algn="ctr"/>
-            <a:r>
-              <a:rPr sz="1400" b="1">
+              <a:rPr sz="1500" b="1">
                 <a:solidFill>
                   <a:srgbClr val="27AE60"/>
                 </a:solidFill>
@@ -5078,8 +5120,8 @@
         </p:nvSpPr>
         <p:spPr>
           <a:xfrm>
-            <a:off x="457200" y="4206240"/>
-            <a:ext cx="11247120" cy="2331720"/>
+            <a:off x="365760" y="4069080"/>
+            <a:ext cx="11430000" cy="2514600"/>
           </a:xfrm>
           <a:prstGeom prst="rect">
             <a:avLst/>
@@ -5121,8 +5163,8 @@
         </p:nvSpPr>
         <p:spPr>
           <a:xfrm>
-            <a:off x="457200" y="4206240"/>
-            <a:ext cx="73152" cy="2331720"/>
+            <a:off x="365760" y="4069080"/>
+            <a:ext cx="82296" cy="2514600"/>
           </a:xfrm>
           <a:prstGeom prst="rect">
             <a:avLst/>
@@ -5164,8 +5206,8 @@
         </p:nvSpPr>
         <p:spPr>
           <a:xfrm>
-            <a:off x="640080" y="4297680"/>
-            <a:ext cx="10058400" cy="411480"/>
+            <a:off x="566928" y="4187952"/>
+            <a:ext cx="10515600" cy="438912"/>
           </a:xfrm>
           <a:prstGeom prst="rect">
             <a:avLst/>
@@ -5180,7 +5222,7 @@
           <a:p>
             <a:pPr algn="l"/>
             <a:r>
-              <a:rPr sz="1400" b="1">
+              <a:rPr sz="1600" b="1">
                 <a:solidFill>
                   <a:srgbClr val="1E3A5F"/>
                 </a:solidFill>
@@ -5199,8 +5241,8 @@
         </p:nvSpPr>
         <p:spPr>
           <a:xfrm>
-            <a:off x="640080" y="4754880"/>
-            <a:ext cx="10972800" cy="384048"/>
+            <a:off x="566928" y="4681728"/>
+            <a:ext cx="10972800" cy="420624"/>
           </a:xfrm>
           <a:prstGeom prst="rect">
             <a:avLst/>
@@ -5215,13 +5257,13 @@
           <a:p>
             <a:pPr algn="l"/>
             <a:r>
-              <a:rPr sz="1100" b="0">
+              <a:rPr sz="1300" b="0">
                 <a:solidFill>
                   <a:srgbClr val="4A4A4A"/>
                 </a:solidFill>
                 <a:latin typeface="IPAGothic"/>
               </a:rPr>
-              <a:t>・ 上位校からの応募59名のうち、1次通過は27名（通過率46%）</a:t>
+              <a:t>・ 上位校からの応募59名のうち、1次通過は27名（通過率 46%）</a:t>
             </a:r>
           </a:p>
         </p:txBody>
@@ -5234,8 +5276,8 @@
         </p:nvSpPr>
         <p:spPr>
           <a:xfrm>
-            <a:off x="640080" y="5157216"/>
-            <a:ext cx="10972800" cy="384048"/>
+            <a:off x="566928" y="5120640"/>
+            <a:ext cx="10972800" cy="420624"/>
           </a:xfrm>
           <a:prstGeom prst="rect">
             <a:avLst/>
@@ -5250,13 +5292,13 @@
           <a:p>
             <a:pPr algn="l"/>
             <a:r>
-              <a:rPr sz="1100" b="0">
+              <a:rPr sz="1300" b="0">
                 <a:solidFill>
                   <a:srgbClr val="4A4A4A"/>
                 </a:solidFill>
                 <a:latin typeface="IPAGothic"/>
               </a:rPr>
-              <a:t>・ 2次通過は11名（対1次通過比41%）。半数以上が1次〜2次間で離脱</a:t>
+              <a:t>・ 2次通過は11名（1次通過比 41%）。半数近くが1次〜2次間で離脱</a:t>
             </a:r>
           </a:p>
         </p:txBody>
@@ -5269,8 +5311,8 @@
         </p:nvSpPr>
         <p:spPr>
           <a:xfrm>
-            <a:off x="640080" y="5559552"/>
-            <a:ext cx="10972800" cy="384048"/>
+            <a:off x="566928" y="5559552"/>
+            <a:ext cx="10972800" cy="420624"/>
           </a:xfrm>
           <a:prstGeom prst="rect">
             <a:avLst/>
@@ -5285,13 +5327,13 @@
           <a:p>
             <a:pPr algn="l"/>
             <a:r>
-              <a:rPr sz="1100" b="0">
+              <a:rPr sz="1300" b="0">
                 <a:solidFill>
                   <a:srgbClr val="4A4A4A"/>
                 </a:solidFill>
                 <a:latin typeface="IPAGothic"/>
               </a:rPr>
-              <a:t>・ 最終通過（内定）は1名（全体の内定率1.7%）。選考の高い難易度を示す</a:t>
+              <a:t>・ 最終通過（内定）は1名（全体の内定率 1.7%）</a:t>
             </a:r>
           </a:p>
         </p:txBody>
@@ -5304,8 +5346,8 @@
         </p:nvSpPr>
         <p:spPr>
           <a:xfrm>
-            <a:off x="640080" y="5961888"/>
-            <a:ext cx="10972800" cy="384048"/>
+            <a:off x="566928" y="5998464"/>
+            <a:ext cx="10972800" cy="420624"/>
           </a:xfrm>
           <a:prstGeom prst="rect">
             <a:avLst/>
@@ -5320,13 +5362,13 @@
           <a:p>
             <a:pPr algn="l"/>
             <a:r>
-              <a:rPr sz="1100" b="0">
+              <a:rPr sz="1300" b="0">
                 <a:solidFill>
                   <a:srgbClr val="4A4A4A"/>
                 </a:solidFill>
                 <a:latin typeface="IPAGothic"/>
               </a:rPr>
-              <a:t>・ 辞退者28名（47%）が最大離脱要因 ─ 辞退理由の主因は「その他・未分類」</a:t>
+              <a:t>・ 辞退者28名（47.5%）が最大離脱要因 ─ 他社内定・優先が9名と最多</a:t>
             </a:r>
           </a:p>
         </p:txBody>
@@ -5358,7 +5400,50 @@
         <p:spPr>
           <a:xfrm>
             <a:off x="0" y="0"/>
-            <a:ext cx="12188952" cy="1005840"/>
+            <a:ext cx="12188952" cy="6858000"/>
+          </a:xfrm>
+          <a:prstGeom prst="rect">
+            <a:avLst/>
+          </a:prstGeom>
+          <a:solidFill>
+            <a:srgbClr val="F8F9FA"/>
+          </a:solidFill>
+          <a:ln>
+            <a:noFill/>
+          </a:ln>
+        </p:spPr>
+        <p:style>
+          <a:lnRef idx="1">
+            <a:schemeClr val="accent1"/>
+          </a:lnRef>
+          <a:fillRef idx="3">
+            <a:schemeClr val="accent1"/>
+          </a:fillRef>
+          <a:effectRef idx="2">
+            <a:schemeClr val="accent1"/>
+          </a:effectRef>
+          <a:fontRef idx="minor">
+            <a:schemeClr val="lt1"/>
+          </a:fontRef>
+        </p:style>
+        <p:txBody>
+          <a:bodyPr rtlCol="0" anchor="ctr"/>
+          <a:lstStyle/>
+          <a:p>
+            <a:pPr algn="ctr"/>
+          </a:p>
+        </p:txBody>
+      </p:sp>
+      <p:sp>
+        <p:nvSpPr>
+          <p:cNvPr id="3" name="Rectangle 2"/>
+          <p:cNvSpPr/>
+          <p:nvPr/>
+        </p:nvSpPr>
+        <p:spPr>
+          <a:xfrm>
+            <a:off x="0" y="0"/>
+            <a:ext cx="12188952" cy="1051560"/>
           </a:xfrm>
           <a:prstGeom prst="rect">
             <a:avLst/>
@@ -5394,14 +5479,14 @@
       </p:sp>
       <p:sp>
         <p:nvSpPr>
-          <p:cNvPr id="3" name="Rectangle 2"/>
+          <p:cNvPr id="4" name="Rectangle 3"/>
           <p:cNvSpPr/>
           <p:nvPr/>
         </p:nvSpPr>
         <p:spPr>
           <a:xfrm>
-            <a:off x="0" y="914400"/>
-            <a:ext cx="12188952" cy="73152"/>
+            <a:off x="0" y="987552"/>
+            <a:ext cx="12188952" cy="91440"/>
           </a:xfrm>
           <a:prstGeom prst="rect">
             <a:avLst/>
@@ -5437,14 +5522,14 @@
       </p:sp>
       <p:sp>
         <p:nvSpPr>
-          <p:cNvPr id="4" name="TextBox 3"/>
+          <p:cNvPr id="5" name="TextBox 4"/>
           <p:cNvSpPr txBox="1"/>
           <p:nvPr/>
         </p:nvSpPr>
         <p:spPr>
           <a:xfrm>
-            <a:off x="365760" y="91440"/>
-            <a:ext cx="9144000" cy="731520"/>
+            <a:off x="411480" y="91440"/>
+            <a:ext cx="10058400" cy="713232"/>
           </a:xfrm>
           <a:prstGeom prst="rect">
             <a:avLst/>
@@ -5459,7 +5544,7 @@
           <a:p>
             <a:pPr algn="l"/>
             <a:r>
-              <a:rPr sz="2400" b="1">
+              <a:rPr sz="2600" b="1">
                 <a:solidFill>
                   <a:srgbClr val="FFFFFF"/>
                 </a:solidFill>
@@ -5472,14 +5557,14 @@
       </p:sp>
       <p:sp>
         <p:nvSpPr>
-          <p:cNvPr id="5" name="TextBox 4"/>
+          <p:cNvPr id="6" name="TextBox 5"/>
           <p:cNvSpPr txBox="1"/>
           <p:nvPr/>
         </p:nvSpPr>
         <p:spPr>
           <a:xfrm>
-            <a:off x="365760" y="685800"/>
-            <a:ext cx="9144000" cy="320040"/>
+            <a:off x="411480" y="685800"/>
+            <a:ext cx="9144000" cy="347472"/>
           </a:xfrm>
           <a:prstGeom prst="rect">
             <a:avLst/>
@@ -5494,7 +5579,7 @@
           <a:p>
             <a:pPr algn="l"/>
             <a:r>
-              <a:rPr sz="1200" b="0">
+              <a:rPr sz="1300" b="0">
                 <a:solidFill>
                   <a:srgbClr val="CCD6E8"/>
                 </a:solidFill>
@@ -5502,49 +5587,6 @@
               </a:rPr>
               <a:t>応募〜最終選考通過までの人数推移</a:t>
             </a:r>
-          </a:p>
-        </p:txBody>
-      </p:sp>
-      <p:sp>
-        <p:nvSpPr>
-          <p:cNvPr id="6" name="Rectangle 5"/>
-          <p:cNvSpPr/>
-          <p:nvPr/>
-        </p:nvSpPr>
-        <p:spPr>
-          <a:xfrm>
-            <a:off x="0" y="987552"/>
-            <a:ext cx="12188952" cy="5870448"/>
-          </a:xfrm>
-          <a:prstGeom prst="rect">
-            <a:avLst/>
-          </a:prstGeom>
-          <a:solidFill>
-            <a:srgbClr val="F8F9FA"/>
-          </a:solidFill>
-          <a:ln>
-            <a:noFill/>
-          </a:ln>
-        </p:spPr>
-        <p:style>
-          <a:lnRef idx="1">
-            <a:schemeClr val="accent1"/>
-          </a:lnRef>
-          <a:fillRef idx="3">
-            <a:schemeClr val="accent1"/>
-          </a:fillRef>
-          <a:effectRef idx="2">
-            <a:schemeClr val="accent1"/>
-          </a:effectRef>
-          <a:fontRef idx="minor">
-            <a:schemeClr val="lt1"/>
-          </a:fontRef>
-        </p:style>
-        <p:txBody>
-          <a:bodyPr rtlCol="0" anchor="ctr"/>
-          <a:lstStyle/>
-          <a:p>
-            <a:pPr algn="ctr"/>
           </a:p>
         </p:txBody>
       </p:sp>
@@ -5564,8 +5606,8 @@
         </p:blipFill>
         <p:spPr>
           <a:xfrm>
-            <a:off x="1371600" y="1188720"/>
-            <a:ext cx="9144000" cy="5303520"/>
+            <a:off x="914400" y="1143000"/>
+            <a:ext cx="10332720" cy="5486400"/>
           </a:xfrm>
           <a:prstGeom prst="rect">
             <a:avLst/>
@@ -5599,7 +5641,50 @@
         <p:spPr>
           <a:xfrm>
             <a:off x="0" y="0"/>
-            <a:ext cx="12188952" cy="1005840"/>
+            <a:ext cx="12188952" cy="6858000"/>
+          </a:xfrm>
+          <a:prstGeom prst="rect">
+            <a:avLst/>
+          </a:prstGeom>
+          <a:solidFill>
+            <a:srgbClr val="F8F9FA"/>
+          </a:solidFill>
+          <a:ln>
+            <a:noFill/>
+          </a:ln>
+        </p:spPr>
+        <p:style>
+          <a:lnRef idx="1">
+            <a:schemeClr val="accent1"/>
+          </a:lnRef>
+          <a:fillRef idx="3">
+            <a:schemeClr val="accent1"/>
+          </a:fillRef>
+          <a:effectRef idx="2">
+            <a:schemeClr val="accent1"/>
+          </a:effectRef>
+          <a:fontRef idx="minor">
+            <a:schemeClr val="lt1"/>
+          </a:fontRef>
+        </p:style>
+        <p:txBody>
+          <a:bodyPr rtlCol="0" anchor="ctr"/>
+          <a:lstStyle/>
+          <a:p>
+            <a:pPr algn="ctr"/>
+          </a:p>
+        </p:txBody>
+      </p:sp>
+      <p:sp>
+        <p:nvSpPr>
+          <p:cNvPr id="3" name="Rectangle 2"/>
+          <p:cNvSpPr/>
+          <p:nvPr/>
+        </p:nvSpPr>
+        <p:spPr>
+          <a:xfrm>
+            <a:off x="0" y="0"/>
+            <a:ext cx="12188952" cy="1051560"/>
           </a:xfrm>
           <a:prstGeom prst="rect">
             <a:avLst/>
@@ -5635,14 +5720,14 @@
       </p:sp>
       <p:sp>
         <p:nvSpPr>
-          <p:cNvPr id="3" name="Rectangle 2"/>
+          <p:cNvPr id="4" name="Rectangle 3"/>
           <p:cNvSpPr/>
           <p:nvPr/>
         </p:nvSpPr>
         <p:spPr>
           <a:xfrm>
-            <a:off x="0" y="914400"/>
-            <a:ext cx="12188952" cy="73152"/>
+            <a:off x="0" y="987552"/>
+            <a:ext cx="12188952" cy="91440"/>
           </a:xfrm>
           <a:prstGeom prst="rect">
             <a:avLst/>
@@ -5678,14 +5763,14 @@
       </p:sp>
       <p:sp>
         <p:nvSpPr>
-          <p:cNvPr id="4" name="TextBox 3"/>
+          <p:cNvPr id="5" name="TextBox 4"/>
           <p:cNvSpPr txBox="1"/>
           <p:nvPr/>
         </p:nvSpPr>
         <p:spPr>
           <a:xfrm>
-            <a:off x="365760" y="91440"/>
-            <a:ext cx="9144000" cy="731520"/>
+            <a:off x="411480" y="91440"/>
+            <a:ext cx="10058400" cy="713232"/>
           </a:xfrm>
           <a:prstGeom prst="rect">
             <a:avLst/>
@@ -5700,7 +5785,7 @@
           <a:p>
             <a:pPr algn="l"/>
             <a:r>
-              <a:rPr sz="2400" b="1">
+              <a:rPr sz="2600" b="1">
                 <a:solidFill>
                   <a:srgbClr val="FFFFFF"/>
                 </a:solidFill>
@@ -5713,14 +5798,14 @@
       </p:sp>
       <p:sp>
         <p:nvSpPr>
-          <p:cNvPr id="5" name="TextBox 4"/>
+          <p:cNvPr id="6" name="TextBox 5"/>
           <p:cNvSpPr txBox="1"/>
           <p:nvPr/>
         </p:nvSpPr>
         <p:spPr>
           <a:xfrm>
-            <a:off x="365760" y="685800"/>
-            <a:ext cx="9144000" cy="320040"/>
+            <a:off x="411480" y="685800"/>
+            <a:ext cx="9144000" cy="347472"/>
           </a:xfrm>
           <a:prstGeom prst="rect">
             <a:avLst/>
@@ -5735,7 +5820,7 @@
           <a:p>
             <a:pPr algn="l"/>
             <a:r>
-              <a:rPr sz="1200" b="0">
+              <a:rPr sz="1300" b="0">
                 <a:solidFill>
                   <a:srgbClr val="CCD6E8"/>
                 </a:solidFill>
@@ -5743,49 +5828,6 @@
               </a:rPr>
               <a:t>上位校応募者59名の最終ステータス</a:t>
             </a:r>
-          </a:p>
-        </p:txBody>
-      </p:sp>
-      <p:sp>
-        <p:nvSpPr>
-          <p:cNvPr id="6" name="Rectangle 5"/>
-          <p:cNvSpPr/>
-          <p:nvPr/>
-        </p:nvSpPr>
-        <p:spPr>
-          <a:xfrm>
-            <a:off x="0" y="987552"/>
-            <a:ext cx="12188952" cy="5870448"/>
-          </a:xfrm>
-          <a:prstGeom prst="rect">
-            <a:avLst/>
-          </a:prstGeom>
-          <a:solidFill>
-            <a:srgbClr val="F8F9FA"/>
-          </a:solidFill>
-          <a:ln>
-            <a:noFill/>
-          </a:ln>
-        </p:spPr>
-        <p:style>
-          <a:lnRef idx="1">
-            <a:schemeClr val="accent1"/>
-          </a:lnRef>
-          <a:fillRef idx="3">
-            <a:schemeClr val="accent1"/>
-          </a:fillRef>
-          <a:effectRef idx="2">
-            <a:schemeClr val="accent1"/>
-          </a:effectRef>
-          <a:fontRef idx="minor">
-            <a:schemeClr val="lt1"/>
-          </a:fontRef>
-        </p:style>
-        <p:txBody>
-          <a:bodyPr rtlCol="0" anchor="ctr"/>
-          <a:lstStyle/>
-          <a:p>
-            <a:pPr algn="ctr"/>
           </a:p>
         </p:txBody>
       </p:sp>
@@ -5805,8 +5847,8 @@
         </p:blipFill>
         <p:spPr>
           <a:xfrm>
-            <a:off x="731520" y="1188720"/>
-            <a:ext cx="5486400" cy="5303520"/>
+            <a:off x="457200" y="1143000"/>
+            <a:ext cx="5943600" cy="5486400"/>
           </a:xfrm>
           <a:prstGeom prst="rect">
             <a:avLst/>
@@ -5821,8 +5863,8 @@
         </p:nvSpPr>
         <p:spPr>
           <a:xfrm>
-            <a:off x="6583680" y="1280160"/>
-            <a:ext cx="5212080" cy="5120640"/>
+            <a:off x="6675120" y="1280160"/>
+            <a:ext cx="5120640" cy="5303520"/>
           </a:xfrm>
           <a:prstGeom prst="rect">
             <a:avLst/>
@@ -5864,8 +5906,8 @@
         </p:nvSpPr>
         <p:spPr>
           <a:xfrm>
-            <a:off x="6583680" y="1280160"/>
-            <a:ext cx="64008" cy="5120640"/>
+            <a:off x="6675120" y="1280160"/>
+            <a:ext cx="73152" cy="5303520"/>
           </a:xfrm>
           <a:prstGeom prst="rect">
             <a:avLst/>
@@ -5907,8 +5949,8 @@
         </p:nvSpPr>
         <p:spPr>
           <a:xfrm>
-            <a:off x="6766560" y="1463040"/>
-            <a:ext cx="4754880" cy="411480"/>
+            <a:off x="6903720" y="1444752"/>
+            <a:ext cx="4572000" cy="457200"/>
           </a:xfrm>
           <a:prstGeom prst="rect">
             <a:avLst/>
@@ -5923,7 +5965,7 @@
           <a:p>
             <a:pPr algn="l"/>
             <a:r>
-              <a:rPr sz="1400" b="1">
+              <a:rPr sz="1600" b="1">
                 <a:solidFill>
                   <a:srgbClr val="1E3A5F"/>
                 </a:solidFill>
@@ -5942,8 +5984,8 @@
         </p:nvSpPr>
         <p:spPr>
           <a:xfrm>
-            <a:off x="6766560" y="2057400"/>
-            <a:ext cx="228600" cy="731520"/>
+            <a:off x="6903720" y="2103120"/>
+            <a:ext cx="256032" cy="777240"/>
           </a:xfrm>
           <a:prstGeom prst="rect">
             <a:avLst/>
@@ -5985,8 +6027,8 @@
         </p:nvSpPr>
         <p:spPr>
           <a:xfrm>
-            <a:off x="7086600" y="2103120"/>
-            <a:ext cx="2286000" cy="365760"/>
+            <a:off x="7269480" y="2148839"/>
+            <a:ext cx="2286000" cy="411480"/>
           </a:xfrm>
           <a:prstGeom prst="rect">
             <a:avLst/>
@@ -6001,7 +6043,7 @@
           <a:p>
             <a:pPr algn="l"/>
             <a:r>
-              <a:rPr sz="1400" b="1">
+              <a:rPr sz="1600" b="1">
                 <a:solidFill>
                   <a:srgbClr val="4A4A4A"/>
                 </a:solidFill>
@@ -6020,8 +6062,8 @@
         </p:nvSpPr>
         <p:spPr>
           <a:xfrm>
-            <a:off x="7086600" y="2468880"/>
-            <a:ext cx="2743200" cy="365760"/>
+            <a:off x="7269480" y="2542032"/>
+            <a:ext cx="2926080" cy="384048"/>
           </a:xfrm>
           <a:prstGeom prst="rect">
             <a:avLst/>
@@ -6036,7 +6078,7 @@
           <a:p>
             <a:pPr algn="l"/>
             <a:r>
-              <a:rPr sz="1300" b="0">
+              <a:rPr sz="1500" b="0">
                 <a:solidFill>
                   <a:srgbClr val="7F7F7F"/>
                 </a:solidFill>
@@ -6055,8 +6097,8 @@
         </p:nvSpPr>
         <p:spPr>
           <a:xfrm>
-            <a:off x="9235440" y="2240280"/>
-            <a:ext cx="2286000" cy="365760"/>
+            <a:off x="9601200" y="2286000"/>
+            <a:ext cx="274320" cy="365760"/>
           </a:xfrm>
           <a:prstGeom prst="rect">
             <a:avLst/>
@@ -6071,13 +6113,13 @@
           <a:p>
             <a:pPr algn="l"/>
             <a:r>
-              <a:rPr sz="1100" b="0">
+              <a:rPr sz="1400" b="0">
                 <a:solidFill>
                   <a:srgbClr val="E74C3C"/>
                 </a:solidFill>
                 <a:latin typeface="IPAGothic"/>
               </a:rPr>
-              <a:t>最大の離脱要因</a:t>
+              <a:t>→</a:t>
             </a:r>
           </a:p>
         </p:txBody>
@@ -6090,8 +6132,8 @@
         </p:nvSpPr>
         <p:spPr>
           <a:xfrm>
-            <a:off x="6766560" y="3108960"/>
-            <a:ext cx="228600" cy="731520"/>
+            <a:off x="6903720" y="3182111"/>
+            <a:ext cx="256032" cy="777240"/>
           </a:xfrm>
           <a:prstGeom prst="rect">
             <a:avLst/>
@@ -6133,8 +6175,8 @@
         </p:nvSpPr>
         <p:spPr>
           <a:xfrm>
-            <a:off x="7086600" y="3154679"/>
-            <a:ext cx="2286000" cy="365760"/>
+            <a:off x="7269480" y="3227831"/>
+            <a:ext cx="2286000" cy="411480"/>
           </a:xfrm>
           <a:prstGeom prst="rect">
             <a:avLst/>
@@ -6149,7 +6191,7 @@
           <a:p>
             <a:pPr algn="l"/>
             <a:r>
-              <a:rPr sz="1400" b="1">
+              <a:rPr sz="1600" b="1">
                 <a:solidFill>
                   <a:srgbClr val="4A4A4A"/>
                 </a:solidFill>
@@ -6168,8 +6210,8 @@
         </p:nvSpPr>
         <p:spPr>
           <a:xfrm>
-            <a:off x="7086600" y="3520440"/>
-            <a:ext cx="2743200" cy="365760"/>
+            <a:off x="7269480" y="3621023"/>
+            <a:ext cx="2926080" cy="384048"/>
           </a:xfrm>
           <a:prstGeom prst="rect">
             <a:avLst/>
@@ -6184,7 +6226,7 @@
           <a:p>
             <a:pPr algn="l"/>
             <a:r>
-              <a:rPr sz="1300" b="0">
+              <a:rPr sz="1500" b="0">
                 <a:solidFill>
                   <a:srgbClr val="7F7F7F"/>
                 </a:solidFill>
@@ -6203,8 +6245,8 @@
         </p:nvSpPr>
         <p:spPr>
           <a:xfrm>
-            <a:off x="9235440" y="3291840"/>
-            <a:ext cx="2286000" cy="365760"/>
+            <a:off x="9601200" y="3364991"/>
+            <a:ext cx="274320" cy="365760"/>
           </a:xfrm>
           <a:prstGeom prst="rect">
             <a:avLst/>
@@ -6219,13 +6261,13 @@
           <a:p>
             <a:pPr algn="l"/>
             <a:r>
-              <a:rPr sz="1100" b="0">
+              <a:rPr sz="1400" b="0">
                 <a:solidFill>
                   <a:srgbClr val="4A90D9"/>
                 </a:solidFill>
                 <a:latin typeface="IPAGothic"/>
               </a:rPr>
-              <a:t>継続中</a:t>
+              <a:t>→</a:t>
             </a:r>
           </a:p>
         </p:txBody>
@@ -6238,14 +6280,14 @@
         </p:nvSpPr>
         <p:spPr>
           <a:xfrm>
-            <a:off x="6766560" y="4160520"/>
-            <a:ext cx="228600" cy="731520"/>
+            <a:off x="6903720" y="4261104"/>
+            <a:ext cx="256032" cy="777240"/>
           </a:xfrm>
           <a:prstGeom prst="rect">
             <a:avLst/>
           </a:prstGeom>
           <a:solidFill>
-            <a:srgbClr val="7F7F7F"/>
+            <a:srgbClr val="888888"/>
           </a:solidFill>
           <a:ln>
             <a:noFill/>
@@ -6281,8 +6323,8 @@
         </p:nvSpPr>
         <p:spPr>
           <a:xfrm>
-            <a:off x="7086600" y="4206240"/>
-            <a:ext cx="2286000" cy="365760"/>
+            <a:off x="7269480" y="4306824"/>
+            <a:ext cx="2286000" cy="411480"/>
           </a:xfrm>
           <a:prstGeom prst="rect">
             <a:avLst/>
@@ -6297,7 +6339,7 @@
           <a:p>
             <a:pPr algn="l"/>
             <a:r>
-              <a:rPr sz="1400" b="1">
+              <a:rPr sz="1600" b="1">
                 <a:solidFill>
                   <a:srgbClr val="4A4A4A"/>
                 </a:solidFill>
@@ -6316,8 +6358,8 @@
         </p:nvSpPr>
         <p:spPr>
           <a:xfrm>
-            <a:off x="7086600" y="4572000"/>
-            <a:ext cx="2743200" cy="365760"/>
+            <a:off x="7269480" y="4700016"/>
+            <a:ext cx="2926080" cy="384048"/>
           </a:xfrm>
           <a:prstGeom prst="rect">
             <a:avLst/>
@@ -6332,7 +6374,7 @@
           <a:p>
             <a:pPr algn="l"/>
             <a:r>
-              <a:rPr sz="1300" b="0">
+              <a:rPr sz="1500" b="0">
                 <a:solidFill>
                   <a:srgbClr val="7F7F7F"/>
                 </a:solidFill>
@@ -6351,8 +6393,8 @@
         </p:nvSpPr>
         <p:spPr>
           <a:xfrm>
-            <a:off x="9235440" y="4343400"/>
-            <a:ext cx="2286000" cy="365760"/>
+            <a:off x="9601200" y="4443984"/>
+            <a:ext cx="274320" cy="365760"/>
           </a:xfrm>
           <a:prstGeom prst="rect">
             <a:avLst/>
@@ -6367,13 +6409,13 @@
           <a:p>
             <a:pPr algn="l"/>
             <a:r>
-              <a:rPr sz="1100" b="0">
-                <a:solidFill>
-                  <a:srgbClr val="7F7F7F"/>
+              <a:rPr sz="1400" b="0">
+                <a:solidFill>
+                  <a:srgbClr val="888888"/>
                 </a:solidFill>
                 <a:latin typeface="IPAGothic"/>
               </a:rPr>
-              <a:t>選考落ち</a:t>
+              <a:t>→</a:t>
             </a:r>
           </a:p>
         </p:txBody>
@@ -6386,8 +6428,8 @@
         </p:nvSpPr>
         <p:spPr>
           <a:xfrm>
-            <a:off x="6766560" y="5212079"/>
-            <a:ext cx="228600" cy="731520"/>
+            <a:off x="6903720" y="5340096"/>
+            <a:ext cx="256032" cy="777240"/>
           </a:xfrm>
           <a:prstGeom prst="rect">
             <a:avLst/>
@@ -6429,8 +6471,8 @@
         </p:nvSpPr>
         <p:spPr>
           <a:xfrm>
-            <a:off x="7086600" y="5257799"/>
-            <a:ext cx="2286000" cy="365760"/>
+            <a:off x="7269480" y="5385816"/>
+            <a:ext cx="2286000" cy="411480"/>
           </a:xfrm>
           <a:prstGeom prst="rect">
             <a:avLst/>
@@ -6445,7 +6487,7 @@
           <a:p>
             <a:pPr algn="l"/>
             <a:r>
-              <a:rPr sz="1400" b="1">
+              <a:rPr sz="1600" b="1">
                 <a:solidFill>
                   <a:srgbClr val="4A4A4A"/>
                 </a:solidFill>
@@ -6464,8 +6506,8 @@
         </p:nvSpPr>
         <p:spPr>
           <a:xfrm>
-            <a:off x="7086600" y="5623559"/>
-            <a:ext cx="2743200" cy="365760"/>
+            <a:off x="7269480" y="5779008"/>
+            <a:ext cx="2926080" cy="384048"/>
           </a:xfrm>
           <a:prstGeom prst="rect">
             <a:avLst/>
@@ -6480,7 +6522,7 @@
           <a:p>
             <a:pPr algn="l"/>
             <a:r>
-              <a:rPr sz="1300" b="0">
+              <a:rPr sz="1500" b="0">
                 <a:solidFill>
                   <a:srgbClr val="7F7F7F"/>
                 </a:solidFill>
@@ -6499,8 +6541,8 @@
         </p:nvSpPr>
         <p:spPr>
           <a:xfrm>
-            <a:off x="9235440" y="5394959"/>
-            <a:ext cx="2286000" cy="365760"/>
+            <a:off x="9601200" y="5522976"/>
+            <a:ext cx="274320" cy="365760"/>
           </a:xfrm>
           <a:prstGeom prst="rect">
             <a:avLst/>
@@ -6515,13 +6557,13 @@
           <a:p>
             <a:pPr algn="l"/>
             <a:r>
-              <a:rPr sz="1100" b="0">
+              <a:rPr sz="1400" b="0">
                 <a:solidFill>
                   <a:srgbClr val="27AE60"/>
                 </a:solidFill>
                 <a:latin typeface="IPAGothic"/>
               </a:rPr>
-              <a:t>採用決定</a:t>
+              <a:t>→</a:t>
             </a:r>
           </a:p>
         </p:txBody>
@@ -6553,7 +6595,50 @@
         <p:spPr>
           <a:xfrm>
             <a:off x="0" y="0"/>
-            <a:ext cx="12188952" cy="1005840"/>
+            <a:ext cx="12188952" cy="6858000"/>
+          </a:xfrm>
+          <a:prstGeom prst="rect">
+            <a:avLst/>
+          </a:prstGeom>
+          <a:solidFill>
+            <a:srgbClr val="F8F9FA"/>
+          </a:solidFill>
+          <a:ln>
+            <a:noFill/>
+          </a:ln>
+        </p:spPr>
+        <p:style>
+          <a:lnRef idx="1">
+            <a:schemeClr val="accent1"/>
+          </a:lnRef>
+          <a:fillRef idx="3">
+            <a:schemeClr val="accent1"/>
+          </a:fillRef>
+          <a:effectRef idx="2">
+            <a:schemeClr val="accent1"/>
+          </a:effectRef>
+          <a:fontRef idx="minor">
+            <a:schemeClr val="lt1"/>
+          </a:fontRef>
+        </p:style>
+        <p:txBody>
+          <a:bodyPr rtlCol="0" anchor="ctr"/>
+          <a:lstStyle/>
+          <a:p>
+            <a:pPr algn="ctr"/>
+          </a:p>
+        </p:txBody>
+      </p:sp>
+      <p:sp>
+        <p:nvSpPr>
+          <p:cNvPr id="3" name="Rectangle 2"/>
+          <p:cNvSpPr/>
+          <p:nvPr/>
+        </p:nvSpPr>
+        <p:spPr>
+          <a:xfrm>
+            <a:off x="0" y="0"/>
+            <a:ext cx="12188952" cy="1051560"/>
           </a:xfrm>
           <a:prstGeom prst="rect">
             <a:avLst/>
@@ -6589,14 +6674,14 @@
       </p:sp>
       <p:sp>
         <p:nvSpPr>
-          <p:cNvPr id="3" name="Rectangle 2"/>
+          <p:cNvPr id="4" name="Rectangle 3"/>
           <p:cNvSpPr/>
           <p:nvPr/>
         </p:nvSpPr>
         <p:spPr>
           <a:xfrm>
-            <a:off x="0" y="914400"/>
-            <a:ext cx="12188952" cy="73152"/>
+            <a:off x="0" y="987552"/>
+            <a:ext cx="12188952" cy="91440"/>
           </a:xfrm>
           <a:prstGeom prst="rect">
             <a:avLst/>
@@ -6632,14 +6717,14 @@
       </p:sp>
       <p:sp>
         <p:nvSpPr>
-          <p:cNvPr id="4" name="TextBox 3"/>
+          <p:cNvPr id="5" name="TextBox 4"/>
           <p:cNvSpPr txBox="1"/>
           <p:nvPr/>
         </p:nvSpPr>
         <p:spPr>
           <a:xfrm>
-            <a:off x="365760" y="91440"/>
-            <a:ext cx="9144000" cy="731520"/>
+            <a:off x="411480" y="91440"/>
+            <a:ext cx="10058400" cy="713232"/>
           </a:xfrm>
           <a:prstGeom prst="rect">
             <a:avLst/>
@@ -6654,7 +6739,7 @@
           <a:p>
             <a:pPr algn="l"/>
             <a:r>
-              <a:rPr sz="2400" b="1">
+              <a:rPr sz="2600" b="1">
                 <a:solidFill>
                   <a:srgbClr val="FFFFFF"/>
                 </a:solidFill>
@@ -6667,14 +6752,14 @@
       </p:sp>
       <p:sp>
         <p:nvSpPr>
-          <p:cNvPr id="5" name="TextBox 4"/>
+          <p:cNvPr id="6" name="TextBox 5"/>
           <p:cNvSpPr txBox="1"/>
           <p:nvPr/>
         </p:nvSpPr>
         <p:spPr>
           <a:xfrm>
-            <a:off x="365760" y="685800"/>
-            <a:ext cx="9144000" cy="320040"/>
+            <a:off x="411480" y="685800"/>
+            <a:ext cx="9144000" cy="347472"/>
           </a:xfrm>
           <a:prstGeom prst="rect">
             <a:avLst/>
@@ -6689,7 +6774,7 @@
           <a:p>
             <a:pPr algn="l"/>
             <a:r>
-              <a:rPr sz="1200" b="0">
+              <a:rPr sz="1300" b="0">
                 <a:solidFill>
                   <a:srgbClr val="CCD6E8"/>
                 </a:solidFill>
@@ -6697,49 +6782,6 @@
               </a:rPr>
               <a:t>上位校59名の大学グループ別内訳</a:t>
             </a:r>
-          </a:p>
-        </p:txBody>
-      </p:sp>
-      <p:sp>
-        <p:nvSpPr>
-          <p:cNvPr id="6" name="Rectangle 5"/>
-          <p:cNvSpPr/>
-          <p:nvPr/>
-        </p:nvSpPr>
-        <p:spPr>
-          <a:xfrm>
-            <a:off x="0" y="987552"/>
-            <a:ext cx="12188952" cy="5870448"/>
-          </a:xfrm>
-          <a:prstGeom prst="rect">
-            <a:avLst/>
-          </a:prstGeom>
-          <a:solidFill>
-            <a:srgbClr val="F8F9FA"/>
-          </a:solidFill>
-          <a:ln>
-            <a:noFill/>
-          </a:ln>
-        </p:spPr>
-        <p:style>
-          <a:lnRef idx="1">
-            <a:schemeClr val="accent1"/>
-          </a:lnRef>
-          <a:fillRef idx="3">
-            <a:schemeClr val="accent1"/>
-          </a:fillRef>
-          <a:effectRef idx="2">
-            <a:schemeClr val="accent1"/>
-          </a:effectRef>
-          <a:fontRef idx="minor">
-            <a:schemeClr val="lt1"/>
-          </a:fontRef>
-        </p:style>
-        <p:txBody>
-          <a:bodyPr rtlCol="0" anchor="ctr"/>
-          <a:lstStyle/>
-          <a:p>
-            <a:pPr algn="ctr"/>
           </a:p>
         </p:txBody>
       </p:sp>
@@ -6759,8 +6801,8 @@
         </p:blipFill>
         <p:spPr>
           <a:xfrm>
-            <a:off x="1371600" y="1188720"/>
-            <a:ext cx="9144000" cy="5303520"/>
+            <a:off x="1097280" y="1143000"/>
+            <a:ext cx="9966960" cy="5486400"/>
           </a:xfrm>
           <a:prstGeom prst="rect">
             <a:avLst/>
@@ -6794,7 +6836,50 @@
         <p:spPr>
           <a:xfrm>
             <a:off x="0" y="0"/>
-            <a:ext cx="12188952" cy="1005840"/>
+            <a:ext cx="12188952" cy="6858000"/>
+          </a:xfrm>
+          <a:prstGeom prst="rect">
+            <a:avLst/>
+          </a:prstGeom>
+          <a:solidFill>
+            <a:srgbClr val="F8F9FA"/>
+          </a:solidFill>
+          <a:ln>
+            <a:noFill/>
+          </a:ln>
+        </p:spPr>
+        <p:style>
+          <a:lnRef idx="1">
+            <a:schemeClr val="accent1"/>
+          </a:lnRef>
+          <a:fillRef idx="3">
+            <a:schemeClr val="accent1"/>
+          </a:fillRef>
+          <a:effectRef idx="2">
+            <a:schemeClr val="accent1"/>
+          </a:effectRef>
+          <a:fontRef idx="minor">
+            <a:schemeClr val="lt1"/>
+          </a:fontRef>
+        </p:style>
+        <p:txBody>
+          <a:bodyPr rtlCol="0" anchor="ctr"/>
+          <a:lstStyle/>
+          <a:p>
+            <a:pPr algn="ctr"/>
+          </a:p>
+        </p:txBody>
+      </p:sp>
+      <p:sp>
+        <p:nvSpPr>
+          <p:cNvPr id="3" name="Rectangle 2"/>
+          <p:cNvSpPr/>
+          <p:nvPr/>
+        </p:nvSpPr>
+        <p:spPr>
+          <a:xfrm>
+            <a:off x="0" y="0"/>
+            <a:ext cx="12188952" cy="1051560"/>
           </a:xfrm>
           <a:prstGeom prst="rect">
             <a:avLst/>
@@ -6830,14 +6915,14 @@
       </p:sp>
       <p:sp>
         <p:nvSpPr>
-          <p:cNvPr id="3" name="Rectangle 2"/>
+          <p:cNvPr id="4" name="Rectangle 3"/>
           <p:cNvSpPr/>
           <p:nvPr/>
         </p:nvSpPr>
         <p:spPr>
           <a:xfrm>
-            <a:off x="0" y="914400"/>
-            <a:ext cx="12188952" cy="73152"/>
+            <a:off x="0" y="987552"/>
+            <a:ext cx="12188952" cy="91440"/>
           </a:xfrm>
           <a:prstGeom prst="rect">
             <a:avLst/>
@@ -6873,14 +6958,14 @@
       </p:sp>
       <p:sp>
         <p:nvSpPr>
-          <p:cNvPr id="4" name="TextBox 3"/>
+          <p:cNvPr id="5" name="TextBox 4"/>
           <p:cNvSpPr txBox="1"/>
           <p:nvPr/>
         </p:nvSpPr>
         <p:spPr>
           <a:xfrm>
-            <a:off x="365760" y="91440"/>
-            <a:ext cx="9144000" cy="731520"/>
+            <a:off x="411480" y="91440"/>
+            <a:ext cx="10058400" cy="713232"/>
           </a:xfrm>
           <a:prstGeom prst="rect">
             <a:avLst/>
@@ -6895,7 +6980,7 @@
           <a:p>
             <a:pPr algn="l"/>
             <a:r>
-              <a:rPr sz="2400" b="1">
+              <a:rPr sz="2600" b="1">
                 <a:solidFill>
                   <a:srgbClr val="FFFFFF"/>
                 </a:solidFill>
@@ -6908,14 +6993,14 @@
       </p:sp>
       <p:sp>
         <p:nvSpPr>
-          <p:cNvPr id="5" name="TextBox 4"/>
+          <p:cNvPr id="6" name="TextBox 5"/>
           <p:cNvSpPr txBox="1"/>
           <p:nvPr/>
         </p:nvSpPr>
         <p:spPr>
           <a:xfrm>
-            <a:off x="365760" y="685800"/>
-            <a:ext cx="9144000" cy="320040"/>
+            <a:off x="411480" y="685800"/>
+            <a:ext cx="9144000" cy="347472"/>
           </a:xfrm>
           <a:prstGeom prst="rect">
             <a:avLst/>
@@ -6930,7 +7015,7 @@
           <a:p>
             <a:pPr algn="l"/>
             <a:r>
-              <a:rPr sz="1200" b="0">
+              <a:rPr sz="1300" b="0">
                 <a:solidFill>
                   <a:srgbClr val="CCD6E8"/>
                 </a:solidFill>
@@ -6938,49 +7023,6 @@
               </a:rPr>
               <a:t>上位校14大学の応募者数</a:t>
             </a:r>
-          </a:p>
-        </p:txBody>
-      </p:sp>
-      <p:sp>
-        <p:nvSpPr>
-          <p:cNvPr id="6" name="Rectangle 5"/>
-          <p:cNvSpPr/>
-          <p:nvPr/>
-        </p:nvSpPr>
-        <p:spPr>
-          <a:xfrm>
-            <a:off x="0" y="987552"/>
-            <a:ext cx="12188952" cy="5870448"/>
-          </a:xfrm>
-          <a:prstGeom prst="rect">
-            <a:avLst/>
-          </a:prstGeom>
-          <a:solidFill>
-            <a:srgbClr val="F8F9FA"/>
-          </a:solidFill>
-          <a:ln>
-            <a:noFill/>
-          </a:ln>
-        </p:spPr>
-        <p:style>
-          <a:lnRef idx="1">
-            <a:schemeClr val="accent1"/>
-          </a:lnRef>
-          <a:fillRef idx="3">
-            <a:schemeClr val="accent1"/>
-          </a:fillRef>
-          <a:effectRef idx="2">
-            <a:schemeClr val="accent1"/>
-          </a:effectRef>
-          <a:fontRef idx="minor">
-            <a:schemeClr val="lt1"/>
-          </a:fontRef>
-        </p:style>
-        <p:txBody>
-          <a:bodyPr rtlCol="0" anchor="ctr"/>
-          <a:lstStyle/>
-          <a:p>
-            <a:pPr algn="ctr"/>
           </a:p>
         </p:txBody>
       </p:sp>
@@ -7000,8 +7042,8 @@
         </p:blipFill>
         <p:spPr>
           <a:xfrm>
-            <a:off x="640080" y="1188720"/>
-            <a:ext cx="10881360" cy="5303520"/>
+            <a:off x="365760" y="1143000"/>
+            <a:ext cx="11430000" cy="5486400"/>
           </a:xfrm>
           <a:prstGeom prst="rect">
             <a:avLst/>
@@ -7035,7 +7077,50 @@
         <p:spPr>
           <a:xfrm>
             <a:off x="0" y="0"/>
-            <a:ext cx="12188952" cy="1005840"/>
+            <a:ext cx="12188952" cy="6858000"/>
+          </a:xfrm>
+          <a:prstGeom prst="rect">
+            <a:avLst/>
+          </a:prstGeom>
+          <a:solidFill>
+            <a:srgbClr val="F8F9FA"/>
+          </a:solidFill>
+          <a:ln>
+            <a:noFill/>
+          </a:ln>
+        </p:spPr>
+        <p:style>
+          <a:lnRef idx="1">
+            <a:schemeClr val="accent1"/>
+          </a:lnRef>
+          <a:fillRef idx="3">
+            <a:schemeClr val="accent1"/>
+          </a:fillRef>
+          <a:effectRef idx="2">
+            <a:schemeClr val="accent1"/>
+          </a:effectRef>
+          <a:fontRef idx="minor">
+            <a:schemeClr val="lt1"/>
+          </a:fontRef>
+        </p:style>
+        <p:txBody>
+          <a:bodyPr rtlCol="0" anchor="ctr"/>
+          <a:lstStyle/>
+          <a:p>
+            <a:pPr algn="ctr"/>
+          </a:p>
+        </p:txBody>
+      </p:sp>
+      <p:sp>
+        <p:nvSpPr>
+          <p:cNvPr id="3" name="Rectangle 2"/>
+          <p:cNvSpPr/>
+          <p:nvPr/>
+        </p:nvSpPr>
+        <p:spPr>
+          <a:xfrm>
+            <a:off x="0" y="0"/>
+            <a:ext cx="12188952" cy="1051560"/>
           </a:xfrm>
           <a:prstGeom prst="rect">
             <a:avLst/>
@@ -7071,14 +7156,14 @@
       </p:sp>
       <p:sp>
         <p:nvSpPr>
-          <p:cNvPr id="3" name="Rectangle 2"/>
+          <p:cNvPr id="4" name="Rectangle 3"/>
           <p:cNvSpPr/>
           <p:nvPr/>
         </p:nvSpPr>
         <p:spPr>
           <a:xfrm>
-            <a:off x="0" y="914400"/>
-            <a:ext cx="12188952" cy="73152"/>
+            <a:off x="0" y="987552"/>
+            <a:ext cx="12188952" cy="91440"/>
           </a:xfrm>
           <a:prstGeom prst="rect">
             <a:avLst/>
@@ -7114,14 +7199,14 @@
       </p:sp>
       <p:sp>
         <p:nvSpPr>
-          <p:cNvPr id="4" name="TextBox 3"/>
+          <p:cNvPr id="5" name="TextBox 4"/>
           <p:cNvSpPr txBox="1"/>
           <p:nvPr/>
         </p:nvSpPr>
         <p:spPr>
           <a:xfrm>
-            <a:off x="365760" y="91440"/>
-            <a:ext cx="9144000" cy="731520"/>
+            <a:off x="411480" y="91440"/>
+            <a:ext cx="10058400" cy="713232"/>
           </a:xfrm>
           <a:prstGeom prst="rect">
             <a:avLst/>
@@ -7136,7 +7221,7 @@
           <a:p>
             <a:pPr algn="l"/>
             <a:r>
-              <a:rPr sz="2400" b="1">
+              <a:rPr sz="2600" b="1">
                 <a:solidFill>
                   <a:srgbClr val="FFFFFF"/>
                 </a:solidFill>
@@ -7149,14 +7234,14 @@
       </p:sp>
       <p:sp>
         <p:nvSpPr>
-          <p:cNvPr id="5" name="TextBox 4"/>
+          <p:cNvPr id="6" name="TextBox 5"/>
           <p:cNvSpPr txBox="1"/>
           <p:nvPr/>
         </p:nvSpPr>
         <p:spPr>
           <a:xfrm>
-            <a:off x="365760" y="685800"/>
-            <a:ext cx="9144000" cy="320040"/>
+            <a:off x="411480" y="685800"/>
+            <a:ext cx="9144000" cy="347472"/>
           </a:xfrm>
           <a:prstGeom prst="rect">
             <a:avLst/>
@@ -7171,7 +7256,7 @@
           <a:p>
             <a:pPr algn="l"/>
             <a:r>
-              <a:rPr sz="1200" b="0">
+              <a:rPr sz="1300" b="0">
                 <a:solidFill>
                   <a:srgbClr val="CCD6E8"/>
                 </a:solidFill>
@@ -7179,49 +7264,6 @@
               </a:rPr>
               <a:t>上位校　辞退者28名の理由内訳</a:t>
             </a:r>
-          </a:p>
-        </p:txBody>
-      </p:sp>
-      <p:sp>
-        <p:nvSpPr>
-          <p:cNvPr id="6" name="Rectangle 5"/>
-          <p:cNvSpPr/>
-          <p:nvPr/>
-        </p:nvSpPr>
-        <p:spPr>
-          <a:xfrm>
-            <a:off x="0" y="987552"/>
-            <a:ext cx="12188952" cy="5870448"/>
-          </a:xfrm>
-          <a:prstGeom prst="rect">
-            <a:avLst/>
-          </a:prstGeom>
-          <a:solidFill>
-            <a:srgbClr val="F8F9FA"/>
-          </a:solidFill>
-          <a:ln>
-            <a:noFill/>
-          </a:ln>
-        </p:spPr>
-        <p:style>
-          <a:lnRef idx="1">
-            <a:schemeClr val="accent1"/>
-          </a:lnRef>
-          <a:fillRef idx="3">
-            <a:schemeClr val="accent1"/>
-          </a:fillRef>
-          <a:effectRef idx="2">
-            <a:schemeClr val="accent1"/>
-          </a:effectRef>
-          <a:fontRef idx="minor">
-            <a:schemeClr val="lt1"/>
-          </a:fontRef>
-        </p:style>
-        <p:txBody>
-          <a:bodyPr rtlCol="0" anchor="ctr"/>
-          <a:lstStyle/>
-          <a:p>
-            <a:pPr algn="ctr"/>
           </a:p>
         </p:txBody>
       </p:sp>
@@ -7241,8 +7283,8 @@
         </p:blipFill>
         <p:spPr>
           <a:xfrm>
-            <a:off x="1371600" y="1280160"/>
-            <a:ext cx="9418320" cy="4389120"/>
+            <a:off x="640080" y="1143000"/>
+            <a:ext cx="10972800" cy="4846320"/>
           </a:xfrm>
           <a:prstGeom prst="rect">
             <a:avLst/>
@@ -7257,8 +7299,8 @@
         </p:nvSpPr>
         <p:spPr>
           <a:xfrm>
-            <a:off x="1371600" y="5806440"/>
-            <a:ext cx="9418320" cy="822960"/>
+            <a:off x="640080" y="6080760"/>
+            <a:ext cx="10972800" cy="594360"/>
           </a:xfrm>
           <a:prstGeom prst="rect">
             <a:avLst/>
@@ -7300,8 +7342,8 @@
         </p:nvSpPr>
         <p:spPr>
           <a:xfrm>
-            <a:off x="1371600" y="5806440"/>
-            <a:ext cx="54864" cy="822960"/>
+            <a:off x="640080" y="6080760"/>
+            <a:ext cx="64008" cy="594360"/>
           </a:xfrm>
           <a:prstGeom prst="rect">
             <a:avLst/>
@@ -7343,8 +7385,8 @@
         </p:nvSpPr>
         <p:spPr>
           <a:xfrm>
-            <a:off x="1508760" y="5870448"/>
-            <a:ext cx="9144000" cy="685800"/>
+            <a:off x="804672" y="6126480"/>
+            <a:ext cx="10607040" cy="530352"/>
           </a:xfrm>
           <a:prstGeom prst="rect">
             <a:avLst/>
@@ -7359,13 +7401,13 @@
           <a:p>
             <a:pPr algn="l"/>
             <a:r>
-              <a:rPr sz="1100" b="0">
+              <a:rPr sz="1200" b="0">
                 <a:solidFill>
                   <a:srgbClr val="4A4A4A"/>
                 </a:solidFill>
                 <a:latin typeface="IPAGothic"/>
               </a:rPr>
-              <a:t>※ 辞退理由「その他・未分類・不明」が計26名（93%）を占める。詳細理由の収集強化が課題。</a:t>
+              <a:t>※ 「理由未収集・不明」7名（25%）の解消に向け、辞退時の面談・アンケート実施を推奨</a:t>
             </a:r>
           </a:p>
         </p:txBody>
@@ -7397,7 +7439,50 @@
         <p:spPr>
           <a:xfrm>
             <a:off x="0" y="0"/>
-            <a:ext cx="12188952" cy="1005840"/>
+            <a:ext cx="12188952" cy="6858000"/>
+          </a:xfrm>
+          <a:prstGeom prst="rect">
+            <a:avLst/>
+          </a:prstGeom>
+          <a:solidFill>
+            <a:srgbClr val="F8F9FA"/>
+          </a:solidFill>
+          <a:ln>
+            <a:noFill/>
+          </a:ln>
+        </p:spPr>
+        <p:style>
+          <a:lnRef idx="1">
+            <a:schemeClr val="accent1"/>
+          </a:lnRef>
+          <a:fillRef idx="3">
+            <a:schemeClr val="accent1"/>
+          </a:fillRef>
+          <a:effectRef idx="2">
+            <a:schemeClr val="accent1"/>
+          </a:effectRef>
+          <a:fontRef idx="minor">
+            <a:schemeClr val="lt1"/>
+          </a:fontRef>
+        </p:style>
+        <p:txBody>
+          <a:bodyPr rtlCol="0" anchor="ctr"/>
+          <a:lstStyle/>
+          <a:p>
+            <a:pPr algn="ctr"/>
+          </a:p>
+        </p:txBody>
+      </p:sp>
+      <p:sp>
+        <p:nvSpPr>
+          <p:cNvPr id="3" name="Rectangle 2"/>
+          <p:cNvSpPr/>
+          <p:nvPr/>
+        </p:nvSpPr>
+        <p:spPr>
+          <a:xfrm>
+            <a:off x="0" y="0"/>
+            <a:ext cx="12188952" cy="1051560"/>
           </a:xfrm>
           <a:prstGeom prst="rect">
             <a:avLst/>
@@ -7433,14 +7518,14 @@
       </p:sp>
       <p:sp>
         <p:nvSpPr>
-          <p:cNvPr id="3" name="Rectangle 2"/>
+          <p:cNvPr id="4" name="Rectangle 3"/>
           <p:cNvSpPr/>
           <p:nvPr/>
         </p:nvSpPr>
         <p:spPr>
           <a:xfrm>
-            <a:off x="0" y="914400"/>
-            <a:ext cx="12188952" cy="73152"/>
+            <a:off x="0" y="987552"/>
+            <a:ext cx="12188952" cy="91440"/>
           </a:xfrm>
           <a:prstGeom prst="rect">
             <a:avLst/>
@@ -7476,14 +7561,14 @@
       </p:sp>
       <p:sp>
         <p:nvSpPr>
-          <p:cNvPr id="4" name="TextBox 3"/>
+          <p:cNvPr id="5" name="TextBox 4"/>
           <p:cNvSpPr txBox="1"/>
           <p:nvPr/>
         </p:nvSpPr>
         <p:spPr>
           <a:xfrm>
-            <a:off x="365760" y="91440"/>
-            <a:ext cx="9144000" cy="731520"/>
+            <a:off x="411480" y="91440"/>
+            <a:ext cx="10058400" cy="713232"/>
           </a:xfrm>
           <a:prstGeom prst="rect">
             <a:avLst/>
@@ -7498,7 +7583,7 @@
           <a:p>
             <a:pPr algn="l"/>
             <a:r>
-              <a:rPr sz="2400" b="1">
+              <a:rPr sz="2600" b="1">
                 <a:solidFill>
                   <a:srgbClr val="FFFFFF"/>
                 </a:solidFill>
@@ -7511,14 +7596,14 @@
       </p:sp>
       <p:sp>
         <p:nvSpPr>
-          <p:cNvPr id="5" name="TextBox 4"/>
+          <p:cNvPr id="6" name="TextBox 5"/>
           <p:cNvSpPr txBox="1"/>
           <p:nvPr/>
         </p:nvSpPr>
         <p:spPr>
           <a:xfrm>
-            <a:off x="365760" y="685800"/>
-            <a:ext cx="9144000" cy="320040"/>
+            <a:off x="411480" y="685800"/>
+            <a:ext cx="9144000" cy="347472"/>
           </a:xfrm>
           <a:prstGeom prst="rect">
             <a:avLst/>
@@ -7533,7 +7618,7 @@
           <a:p>
             <a:pPr algn="l"/>
             <a:r>
-              <a:rPr sz="1200" b="0">
+              <a:rPr sz="1300" b="0">
                 <a:solidFill>
                   <a:srgbClr val="CCD6E8"/>
                 </a:solidFill>
@@ -7546,57 +7631,14 @@
       </p:sp>
       <p:sp>
         <p:nvSpPr>
-          <p:cNvPr id="6" name="Rectangle 5"/>
-          <p:cNvSpPr/>
-          <p:nvPr/>
-        </p:nvSpPr>
-        <p:spPr>
-          <a:xfrm>
-            <a:off x="0" y="987552"/>
-            <a:ext cx="12188952" cy="5870448"/>
-          </a:xfrm>
-          <a:prstGeom prst="rect">
-            <a:avLst/>
-          </a:prstGeom>
-          <a:solidFill>
-            <a:srgbClr val="F8F9FA"/>
-          </a:solidFill>
-          <a:ln>
-            <a:noFill/>
-          </a:ln>
-        </p:spPr>
-        <p:style>
-          <a:lnRef idx="1">
-            <a:schemeClr val="accent1"/>
-          </a:lnRef>
-          <a:fillRef idx="3">
-            <a:schemeClr val="accent1"/>
-          </a:fillRef>
-          <a:effectRef idx="2">
-            <a:schemeClr val="accent1"/>
-          </a:effectRef>
-          <a:fontRef idx="minor">
-            <a:schemeClr val="lt1"/>
-          </a:fontRef>
-        </p:style>
-        <p:txBody>
-          <a:bodyPr rtlCol="0" anchor="ctr"/>
-          <a:lstStyle/>
-          <a:p>
-            <a:pPr algn="ctr"/>
-          </a:p>
-        </p:txBody>
-      </p:sp>
-      <p:sp>
-        <p:nvSpPr>
           <p:cNvPr id="7" name="Rectangle 6"/>
           <p:cNvSpPr/>
           <p:nvPr/>
         </p:nvSpPr>
         <p:spPr>
           <a:xfrm>
-            <a:off x="365760" y="1234440"/>
-            <a:ext cx="5669280" cy="2331720"/>
+            <a:off x="320040" y="1261872"/>
+            <a:ext cx="5760720" cy="2377440"/>
           </a:xfrm>
           <a:prstGeom prst="rect">
             <a:avLst/>
@@ -7638,8 +7680,8 @@
         </p:nvSpPr>
         <p:spPr>
           <a:xfrm>
-            <a:off x="365760" y="1234440"/>
-            <a:ext cx="5669280" cy="73152"/>
+            <a:off x="320040" y="1261872"/>
+            <a:ext cx="5760720" cy="82296"/>
           </a:xfrm>
           <a:prstGeom prst="rect">
             <a:avLst/>
@@ -7681,8 +7723,8 @@
         </p:nvSpPr>
         <p:spPr>
           <a:xfrm>
-            <a:off x="502920" y="1344168"/>
-            <a:ext cx="502920" cy="502920"/>
+            <a:off x="457200" y="1408175"/>
+            <a:ext cx="530352" cy="530352"/>
           </a:xfrm>
           <a:prstGeom prst="rect">
             <a:avLst/>
@@ -7724,8 +7766,8 @@
         </p:nvSpPr>
         <p:spPr>
           <a:xfrm>
-            <a:off x="502920" y="1344168"/>
-            <a:ext cx="502920" cy="502920"/>
+            <a:off x="457200" y="1408175"/>
+            <a:ext cx="530352" cy="530352"/>
           </a:xfrm>
           <a:prstGeom prst="rect">
             <a:avLst/>
@@ -7740,7 +7782,7 @@
           <a:p>
             <a:pPr algn="ctr"/>
             <a:r>
-              <a:rPr sz="1600" b="1">
+              <a:rPr sz="1700" b="1">
                 <a:solidFill>
                   <a:srgbClr val="FFFFFF"/>
                 </a:solidFill>
@@ -7759,8 +7801,8 @@
         </p:nvSpPr>
         <p:spPr>
           <a:xfrm>
-            <a:off x="1143000" y="1371600"/>
-            <a:ext cx="4663440" cy="502920"/>
+            <a:off x="1124712" y="1444751"/>
+            <a:ext cx="4754880" cy="502920"/>
           </a:xfrm>
           <a:prstGeom prst="rect">
             <a:avLst/>
@@ -7775,7 +7817,7 @@
           <a:p>
             <a:pPr algn="l"/>
             <a:r>
-              <a:rPr sz="1400" b="1">
+              <a:rPr sz="1500" b="1">
                 <a:solidFill>
                   <a:srgbClr val="1E3A5F"/>
                 </a:solidFill>
@@ -7794,8 +7836,8 @@
         </p:nvSpPr>
         <p:spPr>
           <a:xfrm>
-            <a:off x="548640" y="1984248"/>
-            <a:ext cx="5303520" cy="1463040"/>
+            <a:off x="502920" y="2066543"/>
+            <a:ext cx="5394960" cy="1463040"/>
           </a:xfrm>
           <a:prstGeom prst="rect">
             <a:avLst/>
@@ -7810,14 +7852,14 @@
           <a:p>
             <a:pPr algn="l"/>
             <a:r>
-              <a:rPr sz="1050" b="0">
+              <a:rPr sz="1150" b="0">
                 <a:solidFill>
                   <a:srgbClr val="4A4A4A"/>
                 </a:solidFill>
                 <a:latin typeface="IPAGothic"/>
               </a:rPr>
-              <a:t>辞退者が47.5%（28名）と最大の離脱要因。面談フォロー強化・選考スピード改善・
-オファー面談の設計見直しが急務。辞退理由の詳細収集の仕組みを整備。</a:t>
+              <a:t>辞退者28名（47.5%）が最大の離脱要因。特に他社内定・優先（9名）が最多。
+選考スピード改善・オファー面談の設計見直しと、辞退理由の詳細収集体制を整備。</a:t>
             </a:r>
           </a:p>
         </p:txBody>
@@ -7830,8 +7872,8 @@
         </p:nvSpPr>
         <p:spPr>
           <a:xfrm>
-            <a:off x="6309360" y="1234440"/>
-            <a:ext cx="5669280" cy="2331720"/>
+            <a:off x="6400800" y="1261872"/>
+            <a:ext cx="5760720" cy="2377440"/>
           </a:xfrm>
           <a:prstGeom prst="rect">
             <a:avLst/>
@@ -7873,8 +7915,8 @@
         </p:nvSpPr>
         <p:spPr>
           <a:xfrm>
-            <a:off x="6309360" y="1234440"/>
-            <a:ext cx="5669280" cy="73152"/>
+            <a:off x="6400800" y="1261872"/>
+            <a:ext cx="5760720" cy="82296"/>
           </a:xfrm>
           <a:prstGeom prst="rect">
             <a:avLst/>
@@ -7916,8 +7958,8 @@
         </p:nvSpPr>
         <p:spPr>
           <a:xfrm>
-            <a:off x="6446520" y="1344168"/>
-            <a:ext cx="502920" cy="502920"/>
+            <a:off x="6537960" y="1408175"/>
+            <a:ext cx="530352" cy="530352"/>
           </a:xfrm>
           <a:prstGeom prst="rect">
             <a:avLst/>
@@ -7959,8 +8001,8 @@
         </p:nvSpPr>
         <p:spPr>
           <a:xfrm>
-            <a:off x="6446520" y="1344168"/>
-            <a:ext cx="502920" cy="502920"/>
+            <a:off x="6537960" y="1408175"/>
+            <a:ext cx="530352" cy="530352"/>
           </a:xfrm>
           <a:prstGeom prst="rect">
             <a:avLst/>
@@ -7975,7 +8017,7 @@
           <a:p>
             <a:pPr algn="ctr"/>
             <a:r>
-              <a:rPr sz="1600" b="1">
+              <a:rPr sz="1700" b="1">
                 <a:solidFill>
                   <a:srgbClr val="FFFFFF"/>
                 </a:solidFill>
@@ -7994,8 +8036,8 @@
         </p:nvSpPr>
         <p:spPr>
           <a:xfrm>
-            <a:off x="7086600" y="1371600"/>
-            <a:ext cx="4663440" cy="502920"/>
+            <a:off x="7205472" y="1444751"/>
+            <a:ext cx="4754880" cy="502920"/>
           </a:xfrm>
           <a:prstGeom prst="rect">
             <a:avLst/>
@@ -8010,7 +8052,7 @@
           <a:p>
             <a:pPr algn="l"/>
             <a:r>
-              <a:rPr sz="1400" b="1">
+              <a:rPr sz="1500" b="1">
                 <a:solidFill>
                   <a:srgbClr val="1E3A5F"/>
                 </a:solidFill>
@@ -8029,8 +8071,8 @@
         </p:nvSpPr>
         <p:spPr>
           <a:xfrm>
-            <a:off x="6492240" y="1984248"/>
-            <a:ext cx="5303520" cy="1463040"/>
+            <a:off x="6583680" y="2066543"/>
+            <a:ext cx="5394960" cy="1463040"/>
           </a:xfrm>
           <a:prstGeom prst="rect">
             <a:avLst/>
@@ -8045,14 +8087,14 @@
           <a:p>
             <a:pPr algn="l"/>
             <a:r>
-              <a:rPr sz="1050" b="0">
+              <a:rPr sz="1150" b="0">
                 <a:solidFill>
                   <a:srgbClr val="4A4A4A"/>
                 </a:solidFill>
                 <a:latin typeface="IPAGothic"/>
               </a:rPr>
-              <a:t>1次通過27名のうち2次通過は11名（41%）。母集団の質向上と、
-1次選考後のフォロー・エンゲージメント施策で通過率改善を目指す。</a:t>
+              <a:t>1次通過27名のうち2次通過は11名（41%）。1次通過後のフォロー強化と
+エンゲージメント施策で通過率改善を目指す。</a:t>
             </a:r>
           </a:p>
         </p:txBody>
@@ -8065,8 +8107,8 @@
         </p:nvSpPr>
         <p:spPr>
           <a:xfrm>
-            <a:off x="365760" y="3840480"/>
-            <a:ext cx="5669280" cy="2331720"/>
+            <a:off x="320040" y="3895344"/>
+            <a:ext cx="5760720" cy="2377440"/>
           </a:xfrm>
           <a:prstGeom prst="rect">
             <a:avLst/>
@@ -8108,8 +8150,8 @@
         </p:nvSpPr>
         <p:spPr>
           <a:xfrm>
-            <a:off x="365760" y="3840480"/>
-            <a:ext cx="5669280" cy="73152"/>
+            <a:off x="320040" y="3895344"/>
+            <a:ext cx="5760720" cy="82296"/>
           </a:xfrm>
           <a:prstGeom prst="rect">
             <a:avLst/>
@@ -8151,8 +8193,8 @@
         </p:nvSpPr>
         <p:spPr>
           <a:xfrm>
-            <a:off x="502920" y="3950208"/>
-            <a:ext cx="502920" cy="502920"/>
+            <a:off x="457200" y="4041648"/>
+            <a:ext cx="530352" cy="530352"/>
           </a:xfrm>
           <a:prstGeom prst="rect">
             <a:avLst/>
@@ -8194,8 +8236,8 @@
         </p:nvSpPr>
         <p:spPr>
           <a:xfrm>
-            <a:off x="502920" y="3950208"/>
-            <a:ext cx="502920" cy="502920"/>
+            <a:off x="457200" y="4041648"/>
+            <a:ext cx="530352" cy="530352"/>
           </a:xfrm>
           <a:prstGeom prst="rect">
             <a:avLst/>
@@ -8210,7 +8252,7 @@
           <a:p>
             <a:pPr algn="ctr"/>
             <a:r>
-              <a:rPr sz="1600" b="1">
+              <a:rPr sz="1700" b="1">
                 <a:solidFill>
                   <a:srgbClr val="FFFFFF"/>
                 </a:solidFill>
@@ -8229,8 +8271,8 @@
         </p:nvSpPr>
         <p:spPr>
           <a:xfrm>
-            <a:off x="1143000" y="3977640"/>
-            <a:ext cx="4663440" cy="502920"/>
+            <a:off x="1124712" y="4078224"/>
+            <a:ext cx="4754880" cy="502920"/>
           </a:xfrm>
           <a:prstGeom prst="rect">
             <a:avLst/>
@@ -8245,7 +8287,7 @@
           <a:p>
             <a:pPr algn="l"/>
             <a:r>
-              <a:rPr sz="1400" b="1">
+              <a:rPr sz="1500" b="1">
                 <a:solidFill>
                   <a:srgbClr val="1E3A5F"/>
                 </a:solidFill>
@@ -8264,8 +8306,8 @@
         </p:nvSpPr>
         <p:spPr>
           <a:xfrm>
-            <a:off x="548640" y="4590288"/>
-            <a:ext cx="5303520" cy="1463040"/>
+            <a:off x="502920" y="4700016"/>
+            <a:ext cx="5394960" cy="1463040"/>
           </a:xfrm>
           <a:prstGeom prst="rect">
             <a:avLst/>
@@ -8280,13 +8322,13 @@
           <a:p>
             <a:pPr algn="l"/>
             <a:r>
-              <a:rPr sz="1050" b="0">
+              <a:rPr sz="1150" b="0">
                 <a:solidFill>
                   <a:srgbClr val="4A4A4A"/>
                 </a:solidFill>
                 <a:latin typeface="IPAGothic"/>
               </a:rPr>
-              <a:t>旧帝大・早慶からの応募が少ない（1名）。ターゲット校へのダイレクトリクルーティング・
+              <a:t>旧帝大・早慶からの応募が極めて少ない（計1名）。ダイレクトリクルーティング・
 学内説明会・OB/OGネットワーク活用で接触機会を増やす。</a:t>
             </a:r>
           </a:p>
@@ -8300,8 +8342,8 @@
         </p:nvSpPr>
         <p:spPr>
           <a:xfrm>
-            <a:off x="6309360" y="3840480"/>
-            <a:ext cx="5669280" cy="2331720"/>
+            <a:off x="6400800" y="3895344"/>
+            <a:ext cx="5760720" cy="2377440"/>
           </a:xfrm>
           <a:prstGeom prst="rect">
             <a:avLst/>
@@ -8343,8 +8385,8 @@
         </p:nvSpPr>
         <p:spPr>
           <a:xfrm>
-            <a:off x="6309360" y="3840480"/>
-            <a:ext cx="5669280" cy="73152"/>
+            <a:off x="6400800" y="3895344"/>
+            <a:ext cx="5760720" cy="82296"/>
           </a:xfrm>
           <a:prstGeom prst="rect">
             <a:avLst/>
@@ -8386,8 +8428,8 @@
         </p:nvSpPr>
         <p:spPr>
           <a:xfrm>
-            <a:off x="6446520" y="3950208"/>
-            <a:ext cx="502920" cy="502920"/>
+            <a:off x="6537960" y="4041648"/>
+            <a:ext cx="530352" cy="530352"/>
           </a:xfrm>
           <a:prstGeom prst="rect">
             <a:avLst/>
@@ -8429,8 +8471,8 @@
         </p:nvSpPr>
         <p:spPr>
           <a:xfrm>
-            <a:off x="6446520" y="3950208"/>
-            <a:ext cx="502920" cy="502920"/>
+            <a:off x="6537960" y="4041648"/>
+            <a:ext cx="530352" cy="530352"/>
           </a:xfrm>
           <a:prstGeom prst="rect">
             <a:avLst/>
@@ -8445,7 +8487,7 @@
           <a:p>
             <a:pPr algn="ctr"/>
             <a:r>
-              <a:rPr sz="1600" b="1">
+              <a:rPr sz="1700" b="1">
                 <a:solidFill>
                   <a:srgbClr val="FFFFFF"/>
                 </a:solidFill>
@@ -8464,8 +8506,8 @@
         </p:nvSpPr>
         <p:spPr>
           <a:xfrm>
-            <a:off x="7086600" y="3977640"/>
-            <a:ext cx="4663440" cy="502920"/>
+            <a:off x="7205472" y="4078224"/>
+            <a:ext cx="4754880" cy="502920"/>
           </a:xfrm>
           <a:prstGeom prst="rect">
             <a:avLst/>
@@ -8480,7 +8522,7 @@
           <a:p>
             <a:pPr algn="l"/>
             <a:r>
-              <a:rPr sz="1400" b="1">
+              <a:rPr sz="1500" b="1">
                 <a:solidFill>
                   <a:srgbClr val="1E3A5F"/>
                 </a:solidFill>
@@ -8499,8 +8541,8 @@
         </p:nvSpPr>
         <p:spPr>
           <a:xfrm>
-            <a:off x="6492240" y="4590288"/>
-            <a:ext cx="5303520" cy="1463040"/>
+            <a:off x="6583680" y="4700016"/>
+            <a:ext cx="5394960" cy="1463040"/>
           </a:xfrm>
           <a:prstGeom prst="rect">
             <a:avLst/>
@@ -8515,13 +8557,13 @@
           <a:p>
             <a:pPr algn="l"/>
             <a:r>
-              <a:rPr sz="1050" b="0">
+              <a:rPr sz="1150" b="0">
                 <a:solidFill>
                   <a:srgbClr val="4A4A4A"/>
                 </a:solidFill>
                 <a:latin typeface="IPAGothic"/>
               </a:rPr>
-              <a:t>現在選考中23名のフォローを継続。通過率・辞退率のトラッキングを月次で実施し、
+              <a:t>現在選考中23名のフォローを継続。通過率・辞退率を月次トラッキングし、
 採用目標達成に向けた定量管理体制を構築する。</a:t>
             </a:r>
           </a:p>

</xml_diff>

<commit_message>
Add school names to status slide, rename selection stages
Co-Authored-By: Claude Sonnet 4.6 <noreply@anthropic.com>
Claude-Session: https://claude.ai/code/session_013nk1DEsSGa4nKpUoythx1H
</commit_message>
<xml_diff>
--- a/上位校採用分析レポート_2026.pptx
+++ b/上位校採用分析レポート_2026.pptx
@@ -3971,8 +3971,8 @@
         </p:nvSpPr>
         <p:spPr>
           <a:xfrm>
-            <a:off x="365760" y="1325880"/>
-            <a:ext cx="2743200" cy="1920240"/>
+            <a:off x="365760" y="1261872"/>
+            <a:ext cx="2743200" cy="2057400"/>
           </a:xfrm>
           <a:prstGeom prst="rect">
             <a:avLst/>
@@ -4014,8 +4014,8 @@
         </p:nvSpPr>
         <p:spPr>
           <a:xfrm>
-            <a:off x="365760" y="1325880"/>
-            <a:ext cx="64008" cy="1920240"/>
+            <a:off x="365760" y="1261872"/>
+            <a:ext cx="64008" cy="2057400"/>
           </a:xfrm>
           <a:prstGeom prst="rect">
             <a:avLst/>
@@ -4057,8 +4057,8 @@
         </p:nvSpPr>
         <p:spPr>
           <a:xfrm>
-            <a:off x="530352" y="1444752"/>
-            <a:ext cx="2468880" cy="411480"/>
+            <a:off x="530352" y="1325880"/>
+            <a:ext cx="2468880" cy="594360"/>
           </a:xfrm>
           <a:prstGeom prst="rect">
             <a:avLst/>
@@ -4073,7 +4073,7 @@
           <a:p>
             <a:pPr algn="l"/>
             <a:r>
-              <a:rPr sz="1400" b="0">
+              <a:rPr sz="1300" b="0">
                 <a:solidFill>
                   <a:srgbClr val="4A4A4A"/>
                 </a:solidFill>
@@ -4092,7 +4092,7 @@
         </p:nvSpPr>
         <p:spPr>
           <a:xfrm>
-            <a:off x="530352" y="1828800"/>
+            <a:off x="530352" y="1874519"/>
             <a:ext cx="1737360" cy="822960"/>
           </a:xfrm>
           <a:prstGeom prst="rect">
@@ -4127,7 +4127,7 @@
         </p:nvSpPr>
         <p:spPr>
           <a:xfrm>
-            <a:off x="1993392" y="2240280"/>
+            <a:off x="1993392" y="2286000"/>
             <a:ext cx="731520" cy="365760"/>
           </a:xfrm>
           <a:prstGeom prst="rect">
@@ -4162,7 +4162,7 @@
         </p:nvSpPr>
         <p:spPr>
           <a:xfrm>
-            <a:off x="530352" y="2788920"/>
+            <a:off x="530352" y="2834640"/>
             <a:ext cx="2468880" cy="365760"/>
           </a:xfrm>
           <a:prstGeom prst="rect">
@@ -4197,8 +4197,8 @@
         </p:nvSpPr>
         <p:spPr>
           <a:xfrm>
-            <a:off x="3291840" y="1325880"/>
-            <a:ext cx="2743200" cy="1920240"/>
+            <a:off x="3291840" y="1261872"/>
+            <a:ext cx="2743200" cy="2057400"/>
           </a:xfrm>
           <a:prstGeom prst="rect">
             <a:avLst/>
@@ -4240,8 +4240,8 @@
         </p:nvSpPr>
         <p:spPr>
           <a:xfrm>
-            <a:off x="3291840" y="1325880"/>
-            <a:ext cx="64008" cy="1920240"/>
+            <a:off x="3291840" y="1261872"/>
+            <a:ext cx="64008" cy="2057400"/>
           </a:xfrm>
           <a:prstGeom prst="rect">
             <a:avLst/>
@@ -4283,8 +4283,8 @@
         </p:nvSpPr>
         <p:spPr>
           <a:xfrm>
-            <a:off x="3456432" y="1444752"/>
-            <a:ext cx="2468880" cy="411480"/>
+            <a:off x="3456432" y="1325880"/>
+            <a:ext cx="2468880" cy="594360"/>
           </a:xfrm>
           <a:prstGeom prst="rect">
             <a:avLst/>
@@ -4299,13 +4299,14 @@
           <a:p>
             <a:pPr algn="l"/>
             <a:r>
-              <a:rPr sz="1400" b="0">
+              <a:rPr sz="1300" b="0">
                 <a:solidFill>
                   <a:srgbClr val="4A4A4A"/>
                 </a:solidFill>
                 <a:latin typeface="IPAGothic"/>
               </a:rPr>
-              <a:t>1次通過者数</a:t>
+              <a:t>説明会兼面談
+通過者数</a:t>
             </a:r>
           </a:p>
         </p:txBody>
@@ -4318,7 +4319,7 @@
         </p:nvSpPr>
         <p:spPr>
           <a:xfrm>
-            <a:off x="3456432" y="1828800"/>
+            <a:off x="3456432" y="1874519"/>
             <a:ext cx="1737360" cy="822960"/>
           </a:xfrm>
           <a:prstGeom prst="rect">
@@ -4353,7 +4354,7 @@
         </p:nvSpPr>
         <p:spPr>
           <a:xfrm>
-            <a:off x="4919472" y="2240280"/>
+            <a:off x="4919472" y="2286000"/>
             <a:ext cx="731520" cy="365760"/>
           </a:xfrm>
           <a:prstGeom prst="rect">
@@ -4388,7 +4389,7 @@
         </p:nvSpPr>
         <p:spPr>
           <a:xfrm>
-            <a:off x="3456432" y="2788920"/>
+            <a:off x="3456432" y="2834640"/>
             <a:ext cx="2468880" cy="365760"/>
           </a:xfrm>
           <a:prstGeom prst="rect">
@@ -4423,8 +4424,8 @@
         </p:nvSpPr>
         <p:spPr>
           <a:xfrm>
-            <a:off x="6217920" y="1325880"/>
-            <a:ext cx="2743200" cy="1920240"/>
+            <a:off x="6217920" y="1261872"/>
+            <a:ext cx="2743200" cy="2057400"/>
           </a:xfrm>
           <a:prstGeom prst="rect">
             <a:avLst/>
@@ -4466,8 +4467,8 @@
         </p:nvSpPr>
         <p:spPr>
           <a:xfrm>
-            <a:off x="6217920" y="1325880"/>
-            <a:ext cx="64008" cy="1920240"/>
+            <a:off x="6217920" y="1261872"/>
+            <a:ext cx="64008" cy="2057400"/>
           </a:xfrm>
           <a:prstGeom prst="rect">
             <a:avLst/>
@@ -4509,8 +4510,8 @@
         </p:nvSpPr>
         <p:spPr>
           <a:xfrm>
-            <a:off x="6382512" y="1444752"/>
-            <a:ext cx="2468880" cy="411480"/>
+            <a:off x="6382512" y="1325880"/>
+            <a:ext cx="2468880" cy="594360"/>
           </a:xfrm>
           <a:prstGeom prst="rect">
             <a:avLst/>
@@ -4525,13 +4526,14 @@
           <a:p>
             <a:pPr algn="l"/>
             <a:r>
-              <a:rPr sz="1400" b="0">
+              <a:rPr sz="1300" b="0">
                 <a:solidFill>
                   <a:srgbClr val="4A4A4A"/>
                 </a:solidFill>
                 <a:latin typeface="IPAGothic"/>
               </a:rPr>
-              <a:t>2次通過者数</a:t>
+              <a:t>一次選考
+通過者数</a:t>
             </a:r>
           </a:p>
         </p:txBody>
@@ -4544,7 +4546,7 @@
         </p:nvSpPr>
         <p:spPr>
           <a:xfrm>
-            <a:off x="6382512" y="1828800"/>
+            <a:off x="6382512" y="1874519"/>
             <a:ext cx="1737360" cy="822960"/>
           </a:xfrm>
           <a:prstGeom prst="rect">
@@ -4579,7 +4581,7 @@
         </p:nvSpPr>
         <p:spPr>
           <a:xfrm>
-            <a:off x="7845552" y="2240280"/>
+            <a:off x="7845552" y="2286000"/>
             <a:ext cx="731520" cy="365760"/>
           </a:xfrm>
           <a:prstGeom prst="rect">
@@ -4614,7 +4616,7 @@
         </p:nvSpPr>
         <p:spPr>
           <a:xfrm>
-            <a:off x="6382512" y="2788920"/>
+            <a:off x="6382512" y="2834640"/>
             <a:ext cx="2468880" cy="365760"/>
           </a:xfrm>
           <a:prstGeom prst="rect">
@@ -4649,8 +4651,8 @@
         </p:nvSpPr>
         <p:spPr>
           <a:xfrm>
-            <a:off x="9144000" y="1325880"/>
-            <a:ext cx="2743200" cy="1920240"/>
+            <a:off x="9144000" y="1261872"/>
+            <a:ext cx="2743200" cy="2057400"/>
           </a:xfrm>
           <a:prstGeom prst="rect">
             <a:avLst/>
@@ -4692,8 +4694,8 @@
         </p:nvSpPr>
         <p:spPr>
           <a:xfrm>
-            <a:off x="9144000" y="1325880"/>
-            <a:ext cx="64008" cy="1920240"/>
+            <a:off x="9144000" y="1261872"/>
+            <a:ext cx="64008" cy="2057400"/>
           </a:xfrm>
           <a:prstGeom prst="rect">
             <a:avLst/>
@@ -4735,8 +4737,8 @@
         </p:nvSpPr>
         <p:spPr>
           <a:xfrm>
-            <a:off x="9308592" y="1444752"/>
-            <a:ext cx="2468880" cy="411480"/>
+            <a:off x="9308592" y="1325880"/>
+            <a:ext cx="2468880" cy="594360"/>
           </a:xfrm>
           <a:prstGeom prst="rect">
             <a:avLst/>
@@ -4751,13 +4753,14 @@
           <a:p>
             <a:pPr algn="l"/>
             <a:r>
-              <a:rPr sz="1400" b="0">
+              <a:rPr sz="1300" b="0">
                 <a:solidFill>
                   <a:srgbClr val="4A4A4A"/>
                 </a:solidFill>
                 <a:latin typeface="IPAGothic"/>
               </a:rPr>
-              <a:t>最終通過者数</a:t>
+              <a:t>最終選考
+通過者数</a:t>
             </a:r>
           </a:p>
         </p:txBody>
@@ -4770,7 +4773,7 @@
         </p:nvSpPr>
         <p:spPr>
           <a:xfrm>
-            <a:off x="9308592" y="1828800"/>
+            <a:off x="9308592" y="1874519"/>
             <a:ext cx="1737360" cy="822960"/>
           </a:xfrm>
           <a:prstGeom prst="rect">
@@ -4805,7 +4808,7 @@
         </p:nvSpPr>
         <p:spPr>
           <a:xfrm>
-            <a:off x="10771632" y="2240280"/>
+            <a:off x="10771632" y="2286000"/>
             <a:ext cx="731520" cy="365760"/>
           </a:xfrm>
           <a:prstGeom prst="rect">
@@ -4840,7 +4843,7 @@
         </p:nvSpPr>
         <p:spPr>
           <a:xfrm>
-            <a:off x="9308592" y="2788920"/>
+            <a:off x="9308592" y="2834640"/>
             <a:ext cx="2468880" cy="365760"/>
           </a:xfrm>
           <a:prstGeom prst="rect">
@@ -4876,7 +4879,7 @@
         <p:spPr>
           <a:xfrm>
             <a:off x="365760" y="3401568"/>
-            <a:ext cx="2560320" cy="502920"/>
+            <a:ext cx="2560320" cy="594360"/>
           </a:xfrm>
           <a:prstGeom prst="rect">
             <a:avLst/>
@@ -4891,7 +4894,7 @@
           <a:p>
             <a:pPr algn="ctr"/>
             <a:r>
-              <a:rPr sz="1500" b="1">
+              <a:rPr sz="1300" b="1">
                 <a:solidFill>
                   <a:srgbClr val="1E3A5F"/>
                 </a:solidFill>
@@ -4911,7 +4914,7 @@
         <p:spPr>
           <a:xfrm>
             <a:off x="3108960" y="3401568"/>
-            <a:ext cx="548640" cy="502920"/>
+            <a:ext cx="502920" cy="594360"/>
           </a:xfrm>
           <a:prstGeom prst="rect">
             <a:avLst/>
@@ -4926,7 +4929,7 @@
           <a:p>
             <a:pPr algn="ctr"/>
             <a:r>
-              <a:rPr sz="2000" b="0">
+              <a:rPr sz="2200" b="0">
                 <a:solidFill>
                   <a:srgbClr val="C9A227"/>
                 </a:solidFill>
@@ -4946,7 +4949,7 @@
         <p:spPr>
           <a:xfrm>
             <a:off x="3474720" y="3401568"/>
-            <a:ext cx="2560320" cy="502920"/>
+            <a:ext cx="2560320" cy="594360"/>
           </a:xfrm>
           <a:prstGeom prst="rect">
             <a:avLst/>
@@ -4961,13 +4964,14 @@
           <a:p>
             <a:pPr algn="ctr"/>
             <a:r>
-              <a:rPr sz="1500" b="1">
+              <a:rPr sz="1300" b="1">
                 <a:solidFill>
                   <a:srgbClr val="4A90D9"/>
                 </a:solidFill>
                 <a:latin typeface="IPAGothic"/>
               </a:rPr>
-              <a:t>1次通過</a:t>
+              <a:t>説明会兼
+面談通過</a:t>
             </a:r>
           </a:p>
         </p:txBody>
@@ -4981,7 +4985,7 @@
         <p:spPr>
           <a:xfrm>
             <a:off x="6035040" y="3401568"/>
-            <a:ext cx="548640" cy="502920"/>
+            <a:ext cx="502920" cy="594360"/>
           </a:xfrm>
           <a:prstGeom prst="rect">
             <a:avLst/>
@@ -4996,7 +5000,7 @@
           <a:p>
             <a:pPr algn="ctr"/>
             <a:r>
-              <a:rPr sz="2000" b="0">
+              <a:rPr sz="2200" b="0">
                 <a:solidFill>
                   <a:srgbClr val="C9A227"/>
                 </a:solidFill>
@@ -5016,7 +5020,7 @@
         <p:spPr>
           <a:xfrm>
             <a:off x="6400800" y="3401568"/>
-            <a:ext cx="2560320" cy="502920"/>
+            <a:ext cx="2560320" cy="594360"/>
           </a:xfrm>
           <a:prstGeom prst="rect">
             <a:avLst/>
@@ -5031,13 +5035,14 @@
           <a:p>
             <a:pPr algn="ctr"/>
             <a:r>
-              <a:rPr sz="1500" b="1">
+              <a:rPr sz="1300" b="1">
                 <a:solidFill>
                   <a:srgbClr val="C9A227"/>
                 </a:solidFill>
                 <a:latin typeface="IPAGothic"/>
               </a:rPr>
-              <a:t>2次通過</a:t>
+              <a:t>一次選考
+通過</a:t>
             </a:r>
           </a:p>
         </p:txBody>
@@ -5050,8 +5055,8 @@
         </p:nvSpPr>
         <p:spPr>
           <a:xfrm>
-            <a:off x="8961120" y="3401568"/>
-            <a:ext cx="548640" cy="502920"/>
+            <a:off x="9006840" y="3401568"/>
+            <a:ext cx="502920" cy="594360"/>
           </a:xfrm>
           <a:prstGeom prst="rect">
             <a:avLst/>
@@ -5066,7 +5071,7 @@
           <a:p>
             <a:pPr algn="ctr"/>
             <a:r>
-              <a:rPr sz="2000" b="0">
+              <a:rPr sz="2200" b="0">
                 <a:solidFill>
                   <a:srgbClr val="C9A227"/>
                 </a:solidFill>
@@ -5085,8 +5090,8 @@
         </p:nvSpPr>
         <p:spPr>
           <a:xfrm>
-            <a:off x="9326880" y="3401568"/>
-            <a:ext cx="2560320" cy="502920"/>
+            <a:off x="9372600" y="3401568"/>
+            <a:ext cx="2560320" cy="594360"/>
           </a:xfrm>
           <a:prstGeom prst="rect">
             <a:avLst/>
@@ -5101,13 +5106,14 @@
           <a:p>
             <a:pPr algn="ctr"/>
             <a:r>
-              <a:rPr sz="1500" b="1">
+              <a:rPr sz="1300" b="1">
                 <a:solidFill>
                   <a:srgbClr val="27AE60"/>
                 </a:solidFill>
                 <a:latin typeface="IPAGothic"/>
               </a:rPr>
-              <a:t>最終通過</a:t>
+              <a:t>最終選考
+通過</a:t>
             </a:r>
           </a:p>
         </p:txBody>
@@ -5120,8 +5126,8 @@
         </p:nvSpPr>
         <p:spPr>
           <a:xfrm>
-            <a:off x="365760" y="4069080"/>
-            <a:ext cx="11430000" cy="2514600"/>
+            <a:off x="365760" y="4133087"/>
+            <a:ext cx="11430000" cy="2423160"/>
           </a:xfrm>
           <a:prstGeom prst="rect">
             <a:avLst/>
@@ -5163,8 +5169,8 @@
         </p:nvSpPr>
         <p:spPr>
           <a:xfrm>
-            <a:off x="365760" y="4069080"/>
-            <a:ext cx="82296" cy="2514600"/>
+            <a:off x="365760" y="4133087"/>
+            <a:ext cx="82296" cy="2423160"/>
           </a:xfrm>
           <a:prstGeom prst="rect">
             <a:avLst/>
@@ -5206,7 +5212,7 @@
         </p:nvSpPr>
         <p:spPr>
           <a:xfrm>
-            <a:off x="566928" y="4187952"/>
+            <a:off x="566928" y="4251960"/>
             <a:ext cx="10515600" cy="438912"/>
           </a:xfrm>
           <a:prstGeom prst="rect">
@@ -5241,8 +5247,8 @@
         </p:nvSpPr>
         <p:spPr>
           <a:xfrm>
-            <a:off x="566928" y="4681728"/>
-            <a:ext cx="10972800" cy="420624"/>
+            <a:off x="566928" y="4727448"/>
+            <a:ext cx="10972800" cy="411480"/>
           </a:xfrm>
           <a:prstGeom prst="rect">
             <a:avLst/>
@@ -5263,7 +5269,7 @@
                 </a:solidFill>
                 <a:latin typeface="IPAGothic"/>
               </a:rPr>
-              <a:t>・ 上位校からの応募59名のうち、1次通過は27名（通過率 46%）</a:t>
+              <a:t>・ 上位校からの応募59名のうち、説明会兼面談通過は27名（通過率 46%）</a:t>
             </a:r>
           </a:p>
         </p:txBody>
@@ -5276,8 +5282,8 @@
         </p:nvSpPr>
         <p:spPr>
           <a:xfrm>
-            <a:off x="566928" y="5120640"/>
-            <a:ext cx="10972800" cy="420624"/>
+            <a:off x="566928" y="5157216"/>
+            <a:ext cx="10972800" cy="411480"/>
           </a:xfrm>
           <a:prstGeom prst="rect">
             <a:avLst/>
@@ -5298,7 +5304,7 @@
                 </a:solidFill>
                 <a:latin typeface="IPAGothic"/>
               </a:rPr>
-              <a:t>・ 2次通過は11名（1次通過比 41%）。半数近くが1次〜2次間で離脱</a:t>
+              <a:t>・ 一次選考通過は11名（説明会兼面談通過比 41%）。半数近くが両選考間で離脱</a:t>
             </a:r>
           </a:p>
         </p:txBody>
@@ -5311,8 +5317,8 @@
         </p:nvSpPr>
         <p:spPr>
           <a:xfrm>
-            <a:off x="566928" y="5559552"/>
-            <a:ext cx="10972800" cy="420624"/>
+            <a:off x="566928" y="5586983"/>
+            <a:ext cx="10972800" cy="411480"/>
           </a:xfrm>
           <a:prstGeom prst="rect">
             <a:avLst/>
@@ -5333,7 +5339,7 @@
                 </a:solidFill>
                 <a:latin typeface="IPAGothic"/>
               </a:rPr>
-              <a:t>・ 最終通過（内定）は1名（全体の内定率 1.7%）</a:t>
+              <a:t>・ 最終選考通過（内定）は1名（全体の内定率 1.7%）</a:t>
             </a:r>
           </a:p>
         </p:txBody>
@@ -5346,8 +5352,8 @@
         </p:nvSpPr>
         <p:spPr>
           <a:xfrm>
-            <a:off x="566928" y="5998464"/>
-            <a:ext cx="10972800" cy="420624"/>
+            <a:off x="566928" y="6016752"/>
+            <a:ext cx="10972800" cy="411480"/>
           </a:xfrm>
           <a:prstGeom prst="rect">
             <a:avLst/>
@@ -5847,727 +5853,38 @@
         </p:blipFill>
         <p:spPr>
           <a:xfrm>
-            <a:off x="457200" y="1143000"/>
-            <a:ext cx="5943600" cy="5486400"/>
+            <a:off x="274320" y="1097280"/>
+            <a:ext cx="5029200" cy="5029200"/>
           </a:xfrm>
           <a:prstGeom prst="rect">
             <a:avLst/>
           </a:prstGeom>
         </p:spPr>
       </p:pic>
-      <p:sp>
-        <p:nvSpPr>
-          <p:cNvPr id="8" name="Rectangle 7"/>
-          <p:cNvSpPr/>
-          <p:nvPr/>
-        </p:nvSpPr>
-        <p:spPr>
-          <a:xfrm>
-            <a:off x="6675120" y="1280160"/>
-            <a:ext cx="5120640" cy="5303520"/>
-          </a:xfrm>
-          <a:prstGeom prst="rect">
-            <a:avLst/>
-          </a:prstGeom>
-          <a:solidFill>
-            <a:srgbClr val="FFFFFF"/>
-          </a:solidFill>
-          <a:ln>
-            <a:noFill/>
-          </a:ln>
-        </p:spPr>
-        <p:style>
-          <a:lnRef idx="1">
-            <a:schemeClr val="accent1"/>
-          </a:lnRef>
-          <a:fillRef idx="3">
-            <a:schemeClr val="accent1"/>
-          </a:fillRef>
-          <a:effectRef idx="2">
-            <a:schemeClr val="accent1"/>
-          </a:effectRef>
-          <a:fontRef idx="minor">
-            <a:schemeClr val="lt1"/>
-          </a:fontRef>
-        </p:style>
-        <p:txBody>
-          <a:bodyPr rtlCol="0" anchor="ctr"/>
-          <a:lstStyle/>
-          <a:p>
-            <a:pPr algn="ctr"/>
-          </a:p>
-        </p:txBody>
-      </p:sp>
-      <p:sp>
-        <p:nvSpPr>
-          <p:cNvPr id="9" name="Rectangle 8"/>
-          <p:cNvSpPr/>
-          <p:nvPr/>
-        </p:nvSpPr>
-        <p:spPr>
-          <a:xfrm>
-            <a:off x="6675120" y="1280160"/>
-            <a:ext cx="73152" cy="5303520"/>
-          </a:xfrm>
-          <a:prstGeom prst="rect">
-            <a:avLst/>
-          </a:prstGeom>
-          <a:solidFill>
-            <a:srgbClr val="1E3A5F"/>
-          </a:solidFill>
-          <a:ln>
-            <a:noFill/>
-          </a:ln>
-        </p:spPr>
-        <p:style>
-          <a:lnRef idx="1">
-            <a:schemeClr val="accent1"/>
-          </a:lnRef>
-          <a:fillRef idx="3">
-            <a:schemeClr val="accent1"/>
-          </a:fillRef>
-          <a:effectRef idx="2">
-            <a:schemeClr val="accent1"/>
-          </a:effectRef>
-          <a:fontRef idx="minor">
-            <a:schemeClr val="lt1"/>
-          </a:fontRef>
-        </p:style>
-        <p:txBody>
-          <a:bodyPr rtlCol="0" anchor="ctr"/>
-          <a:lstStyle/>
-          <a:p>
-            <a:pPr algn="ctr"/>
-          </a:p>
-        </p:txBody>
-      </p:sp>
-      <p:sp>
-        <p:nvSpPr>
-          <p:cNvPr id="10" name="TextBox 9"/>
-          <p:cNvSpPr txBox="1"/>
-          <p:nvPr/>
-        </p:nvSpPr>
-        <p:spPr>
-          <a:xfrm>
-            <a:off x="6903720" y="1444752"/>
-            <a:ext cx="4572000" cy="457200"/>
-          </a:xfrm>
-          <a:prstGeom prst="rect">
-            <a:avLst/>
-          </a:prstGeom>
-          <a:noFill/>
-        </p:spPr>
-        <p:txBody>
-          <a:bodyPr wrap="square">
-            <a:spAutoFit/>
-          </a:bodyPr>
-          <a:lstStyle/>
-          <a:p>
-            <a:pPr algn="l"/>
-            <a:r>
-              <a:rPr sz="1600" b="1">
-                <a:solidFill>
-                  <a:srgbClr val="1E3A5F"/>
-                </a:solidFill>
-                <a:latin typeface="IPAGothic"/>
-              </a:rPr>
-              <a:t>■ ステータス詳細</a:t>
-            </a:r>
-          </a:p>
-        </p:txBody>
-      </p:sp>
-      <p:sp>
-        <p:nvSpPr>
-          <p:cNvPr id="11" name="Rectangle 10"/>
-          <p:cNvSpPr/>
-          <p:nvPr/>
-        </p:nvSpPr>
-        <p:spPr>
-          <a:xfrm>
-            <a:off x="6903720" y="2103120"/>
-            <a:ext cx="256032" cy="777240"/>
-          </a:xfrm>
-          <a:prstGeom prst="rect">
-            <a:avLst/>
-          </a:prstGeom>
-          <a:solidFill>
-            <a:srgbClr val="E74C3C"/>
-          </a:solidFill>
-          <a:ln>
-            <a:noFill/>
-          </a:ln>
-        </p:spPr>
-        <p:style>
-          <a:lnRef idx="1">
-            <a:schemeClr val="accent1"/>
-          </a:lnRef>
-          <a:fillRef idx="3">
-            <a:schemeClr val="accent1"/>
-          </a:fillRef>
-          <a:effectRef idx="2">
-            <a:schemeClr val="accent1"/>
-          </a:effectRef>
-          <a:fontRef idx="minor">
-            <a:schemeClr val="lt1"/>
-          </a:fontRef>
-        </p:style>
-        <p:txBody>
-          <a:bodyPr rtlCol="0" anchor="ctr"/>
-          <a:lstStyle/>
-          <a:p>
-            <a:pPr algn="ctr"/>
-          </a:p>
-        </p:txBody>
-      </p:sp>
-      <p:sp>
-        <p:nvSpPr>
-          <p:cNvPr id="12" name="TextBox 11"/>
-          <p:cNvSpPr txBox="1"/>
-          <p:nvPr/>
-        </p:nvSpPr>
-        <p:spPr>
-          <a:xfrm>
-            <a:off x="7269480" y="2148839"/>
-            <a:ext cx="2286000" cy="411480"/>
-          </a:xfrm>
-          <a:prstGeom prst="rect">
-            <a:avLst/>
-          </a:prstGeom>
-          <a:noFill/>
-        </p:spPr>
-        <p:txBody>
-          <a:bodyPr wrap="square">
-            <a:spAutoFit/>
-          </a:bodyPr>
-          <a:lstStyle/>
-          <a:p>
-            <a:pPr algn="l"/>
-            <a:r>
-              <a:rPr sz="1600" b="1">
-                <a:solidFill>
-                  <a:srgbClr val="4A4A4A"/>
-                </a:solidFill>
-                <a:latin typeface="IPAGothic"/>
-              </a:rPr>
-              <a:t>辞退</a:t>
-            </a:r>
-          </a:p>
-        </p:txBody>
-      </p:sp>
-      <p:sp>
-        <p:nvSpPr>
-          <p:cNvPr id="13" name="TextBox 12"/>
-          <p:cNvSpPr txBox="1"/>
-          <p:nvPr/>
-        </p:nvSpPr>
-        <p:spPr>
-          <a:xfrm>
-            <a:off x="7269480" y="2542032"/>
-            <a:ext cx="2926080" cy="384048"/>
-          </a:xfrm>
-          <a:prstGeom prst="rect">
-            <a:avLst/>
-          </a:prstGeom>
-          <a:noFill/>
-        </p:spPr>
-        <p:txBody>
-          <a:bodyPr wrap="square">
-            <a:spAutoFit/>
-          </a:bodyPr>
-          <a:lstStyle/>
-          <a:p>
-            <a:pPr algn="l"/>
-            <a:r>
-              <a:rPr sz="1500" b="0">
-                <a:solidFill>
-                  <a:srgbClr val="7F7F7F"/>
-                </a:solidFill>
-                <a:latin typeface="IPAGothic"/>
-              </a:rPr>
-              <a:t>28名　47.5%</a:t>
-            </a:r>
-          </a:p>
-        </p:txBody>
-      </p:sp>
-      <p:sp>
-        <p:nvSpPr>
-          <p:cNvPr id="14" name="TextBox 13"/>
-          <p:cNvSpPr txBox="1"/>
-          <p:nvPr/>
-        </p:nvSpPr>
-        <p:spPr>
-          <a:xfrm>
-            <a:off x="9601200" y="2286000"/>
-            <a:ext cx="274320" cy="365760"/>
-          </a:xfrm>
-          <a:prstGeom prst="rect">
-            <a:avLst/>
-          </a:prstGeom>
-          <a:noFill/>
-        </p:spPr>
-        <p:txBody>
-          <a:bodyPr wrap="square">
-            <a:spAutoFit/>
-          </a:bodyPr>
-          <a:lstStyle/>
-          <a:p>
-            <a:pPr algn="l"/>
-            <a:r>
-              <a:rPr sz="1400" b="0">
-                <a:solidFill>
-                  <a:srgbClr val="E74C3C"/>
-                </a:solidFill>
-                <a:latin typeface="IPAGothic"/>
-              </a:rPr>
-              <a:t>→</a:t>
-            </a:r>
-          </a:p>
-        </p:txBody>
-      </p:sp>
-      <p:sp>
-        <p:nvSpPr>
-          <p:cNvPr id="15" name="Rectangle 14"/>
-          <p:cNvSpPr/>
-          <p:nvPr/>
-        </p:nvSpPr>
-        <p:spPr>
-          <a:xfrm>
-            <a:off x="6903720" y="3182111"/>
-            <a:ext cx="256032" cy="777240"/>
-          </a:xfrm>
-          <a:prstGeom prst="rect">
-            <a:avLst/>
-          </a:prstGeom>
-          <a:solidFill>
-            <a:srgbClr val="4A90D9"/>
-          </a:solidFill>
-          <a:ln>
-            <a:noFill/>
-          </a:ln>
-        </p:spPr>
-        <p:style>
-          <a:lnRef idx="1">
-            <a:schemeClr val="accent1"/>
-          </a:lnRef>
-          <a:fillRef idx="3">
-            <a:schemeClr val="accent1"/>
-          </a:fillRef>
-          <a:effectRef idx="2">
-            <a:schemeClr val="accent1"/>
-          </a:effectRef>
-          <a:fontRef idx="minor">
-            <a:schemeClr val="lt1"/>
-          </a:fontRef>
-        </p:style>
-        <p:txBody>
-          <a:bodyPr rtlCol="0" anchor="ctr"/>
-          <a:lstStyle/>
-          <a:p>
-            <a:pPr algn="ctr"/>
-          </a:p>
-        </p:txBody>
-      </p:sp>
-      <p:sp>
-        <p:nvSpPr>
-          <p:cNvPr id="16" name="TextBox 15"/>
-          <p:cNvSpPr txBox="1"/>
-          <p:nvPr/>
-        </p:nvSpPr>
-        <p:spPr>
-          <a:xfrm>
-            <a:off x="7269480" y="3227831"/>
-            <a:ext cx="2286000" cy="411480"/>
-          </a:xfrm>
-          <a:prstGeom prst="rect">
-            <a:avLst/>
-          </a:prstGeom>
-          <a:noFill/>
-        </p:spPr>
-        <p:txBody>
-          <a:bodyPr wrap="square">
-            <a:spAutoFit/>
-          </a:bodyPr>
-          <a:lstStyle/>
-          <a:p>
-            <a:pPr algn="l"/>
-            <a:r>
-              <a:rPr sz="1600" b="1">
-                <a:solidFill>
-                  <a:srgbClr val="4A4A4A"/>
-                </a:solidFill>
-                <a:latin typeface="IPAGothic"/>
-              </a:rPr>
-              <a:t>選考中</a:t>
-            </a:r>
-          </a:p>
-        </p:txBody>
-      </p:sp>
-      <p:sp>
-        <p:nvSpPr>
-          <p:cNvPr id="17" name="TextBox 16"/>
-          <p:cNvSpPr txBox="1"/>
-          <p:nvPr/>
-        </p:nvSpPr>
-        <p:spPr>
-          <a:xfrm>
-            <a:off x="7269480" y="3621023"/>
-            <a:ext cx="2926080" cy="384048"/>
-          </a:xfrm>
-          <a:prstGeom prst="rect">
-            <a:avLst/>
-          </a:prstGeom>
-          <a:noFill/>
-        </p:spPr>
-        <p:txBody>
-          <a:bodyPr wrap="square">
-            <a:spAutoFit/>
-          </a:bodyPr>
-          <a:lstStyle/>
-          <a:p>
-            <a:pPr algn="l"/>
-            <a:r>
-              <a:rPr sz="1500" b="0">
-                <a:solidFill>
-                  <a:srgbClr val="7F7F7F"/>
-                </a:solidFill>
-                <a:latin typeface="IPAGothic"/>
-              </a:rPr>
-              <a:t>23名　39.0%</a:t>
-            </a:r>
-          </a:p>
-        </p:txBody>
-      </p:sp>
-      <p:sp>
-        <p:nvSpPr>
-          <p:cNvPr id="18" name="TextBox 17"/>
-          <p:cNvSpPr txBox="1"/>
-          <p:nvPr/>
-        </p:nvSpPr>
-        <p:spPr>
-          <a:xfrm>
-            <a:off x="9601200" y="3364991"/>
-            <a:ext cx="274320" cy="365760"/>
-          </a:xfrm>
-          <a:prstGeom prst="rect">
-            <a:avLst/>
-          </a:prstGeom>
-          <a:noFill/>
-        </p:spPr>
-        <p:txBody>
-          <a:bodyPr wrap="square">
-            <a:spAutoFit/>
-          </a:bodyPr>
-          <a:lstStyle/>
-          <a:p>
-            <a:pPr algn="l"/>
-            <a:r>
-              <a:rPr sz="1400" b="0">
-                <a:solidFill>
-                  <a:srgbClr val="4A90D9"/>
-                </a:solidFill>
-                <a:latin typeface="IPAGothic"/>
-              </a:rPr>
-              <a:t>→</a:t>
-            </a:r>
-          </a:p>
-        </p:txBody>
-      </p:sp>
-      <p:sp>
-        <p:nvSpPr>
-          <p:cNvPr id="19" name="Rectangle 18"/>
-          <p:cNvSpPr/>
-          <p:nvPr/>
-        </p:nvSpPr>
-        <p:spPr>
-          <a:xfrm>
-            <a:off x="6903720" y="4261104"/>
-            <a:ext cx="256032" cy="777240"/>
-          </a:xfrm>
-          <a:prstGeom prst="rect">
-            <a:avLst/>
-          </a:prstGeom>
-          <a:solidFill>
-            <a:srgbClr val="888888"/>
-          </a:solidFill>
-          <a:ln>
-            <a:noFill/>
-          </a:ln>
-        </p:spPr>
-        <p:style>
-          <a:lnRef idx="1">
-            <a:schemeClr val="accent1"/>
-          </a:lnRef>
-          <a:fillRef idx="3">
-            <a:schemeClr val="accent1"/>
-          </a:fillRef>
-          <a:effectRef idx="2">
-            <a:schemeClr val="accent1"/>
-          </a:effectRef>
-          <a:fontRef idx="minor">
-            <a:schemeClr val="lt1"/>
-          </a:fontRef>
-        </p:style>
-        <p:txBody>
-          <a:bodyPr rtlCol="0" anchor="ctr"/>
-          <a:lstStyle/>
-          <a:p>
-            <a:pPr algn="ctr"/>
-          </a:p>
-        </p:txBody>
-      </p:sp>
-      <p:sp>
-        <p:nvSpPr>
-          <p:cNvPr id="20" name="TextBox 19"/>
-          <p:cNvSpPr txBox="1"/>
-          <p:nvPr/>
-        </p:nvSpPr>
-        <p:spPr>
-          <a:xfrm>
-            <a:off x="7269480" y="4306824"/>
-            <a:ext cx="2286000" cy="411480"/>
-          </a:xfrm>
-          <a:prstGeom prst="rect">
-            <a:avLst/>
-          </a:prstGeom>
-          <a:noFill/>
-        </p:spPr>
-        <p:txBody>
-          <a:bodyPr wrap="square">
-            <a:spAutoFit/>
-          </a:bodyPr>
-          <a:lstStyle/>
-          <a:p>
-            <a:pPr algn="l"/>
-            <a:r>
-              <a:rPr sz="1600" b="1">
-                <a:solidFill>
-                  <a:srgbClr val="4A4A4A"/>
-                </a:solidFill>
-                <a:latin typeface="IPAGothic"/>
-              </a:rPr>
-              <a:t>不合格</a:t>
-            </a:r>
-          </a:p>
-        </p:txBody>
-      </p:sp>
-      <p:sp>
-        <p:nvSpPr>
-          <p:cNvPr id="21" name="TextBox 20"/>
-          <p:cNvSpPr txBox="1"/>
-          <p:nvPr/>
-        </p:nvSpPr>
-        <p:spPr>
-          <a:xfrm>
-            <a:off x="7269480" y="4700016"/>
-            <a:ext cx="2926080" cy="384048"/>
-          </a:xfrm>
-          <a:prstGeom prst="rect">
-            <a:avLst/>
-          </a:prstGeom>
-          <a:noFill/>
-        </p:spPr>
-        <p:txBody>
-          <a:bodyPr wrap="square">
-            <a:spAutoFit/>
-          </a:bodyPr>
-          <a:lstStyle/>
-          <a:p>
-            <a:pPr algn="l"/>
-            <a:r>
-              <a:rPr sz="1500" b="0">
-                <a:solidFill>
-                  <a:srgbClr val="7F7F7F"/>
-                </a:solidFill>
-                <a:latin typeface="IPAGothic"/>
-              </a:rPr>
-              <a:t>7名　11.9%</a:t>
-            </a:r>
-          </a:p>
-        </p:txBody>
-      </p:sp>
-      <p:sp>
-        <p:nvSpPr>
-          <p:cNvPr id="22" name="TextBox 21"/>
-          <p:cNvSpPr txBox="1"/>
-          <p:nvPr/>
-        </p:nvSpPr>
-        <p:spPr>
-          <a:xfrm>
-            <a:off x="9601200" y="4443984"/>
-            <a:ext cx="274320" cy="365760"/>
-          </a:xfrm>
-          <a:prstGeom prst="rect">
-            <a:avLst/>
-          </a:prstGeom>
-          <a:noFill/>
-        </p:spPr>
-        <p:txBody>
-          <a:bodyPr wrap="square">
-            <a:spAutoFit/>
-          </a:bodyPr>
-          <a:lstStyle/>
-          <a:p>
-            <a:pPr algn="l"/>
-            <a:r>
-              <a:rPr sz="1400" b="0">
-                <a:solidFill>
-                  <a:srgbClr val="888888"/>
-                </a:solidFill>
-                <a:latin typeface="IPAGothic"/>
-              </a:rPr>
-              <a:t>→</a:t>
-            </a:r>
-          </a:p>
-        </p:txBody>
-      </p:sp>
-      <p:sp>
-        <p:nvSpPr>
-          <p:cNvPr id="23" name="Rectangle 22"/>
-          <p:cNvSpPr/>
-          <p:nvPr/>
-        </p:nvSpPr>
-        <p:spPr>
-          <a:xfrm>
-            <a:off x="6903720" y="5340096"/>
-            <a:ext cx="256032" cy="777240"/>
-          </a:xfrm>
-          <a:prstGeom prst="rect">
-            <a:avLst/>
-          </a:prstGeom>
-          <a:solidFill>
-            <a:srgbClr val="27AE60"/>
-          </a:solidFill>
-          <a:ln>
-            <a:noFill/>
-          </a:ln>
-        </p:spPr>
-        <p:style>
-          <a:lnRef idx="1">
-            <a:schemeClr val="accent1"/>
-          </a:lnRef>
-          <a:fillRef idx="3">
-            <a:schemeClr val="accent1"/>
-          </a:fillRef>
-          <a:effectRef idx="2">
-            <a:schemeClr val="accent1"/>
-          </a:effectRef>
-          <a:fontRef idx="minor">
-            <a:schemeClr val="lt1"/>
-          </a:fontRef>
-        </p:style>
-        <p:txBody>
-          <a:bodyPr rtlCol="0" anchor="ctr"/>
-          <a:lstStyle/>
-          <a:p>
-            <a:pPr algn="ctr"/>
-          </a:p>
-        </p:txBody>
-      </p:sp>
-      <p:sp>
-        <p:nvSpPr>
-          <p:cNvPr id="24" name="TextBox 23"/>
-          <p:cNvSpPr txBox="1"/>
-          <p:nvPr/>
-        </p:nvSpPr>
-        <p:spPr>
-          <a:xfrm>
-            <a:off x="7269480" y="5385816"/>
-            <a:ext cx="2286000" cy="411480"/>
-          </a:xfrm>
-          <a:prstGeom prst="rect">
-            <a:avLst/>
-          </a:prstGeom>
-          <a:noFill/>
-        </p:spPr>
-        <p:txBody>
-          <a:bodyPr wrap="square">
-            <a:spAutoFit/>
-          </a:bodyPr>
-          <a:lstStyle/>
-          <a:p>
-            <a:pPr algn="l"/>
-            <a:r>
-              <a:rPr sz="1600" b="1">
-                <a:solidFill>
-                  <a:srgbClr val="4A4A4A"/>
-                </a:solidFill>
-                <a:latin typeface="IPAGothic"/>
-              </a:rPr>
-              <a:t>内定</a:t>
-            </a:r>
-          </a:p>
-        </p:txBody>
-      </p:sp>
-      <p:sp>
-        <p:nvSpPr>
-          <p:cNvPr id="25" name="TextBox 24"/>
-          <p:cNvSpPr txBox="1"/>
-          <p:nvPr/>
-        </p:nvSpPr>
-        <p:spPr>
-          <a:xfrm>
-            <a:off x="7269480" y="5779008"/>
-            <a:ext cx="2926080" cy="384048"/>
-          </a:xfrm>
-          <a:prstGeom prst="rect">
-            <a:avLst/>
-          </a:prstGeom>
-          <a:noFill/>
-        </p:spPr>
-        <p:txBody>
-          <a:bodyPr wrap="square">
-            <a:spAutoFit/>
-          </a:bodyPr>
-          <a:lstStyle/>
-          <a:p>
-            <a:pPr algn="l"/>
-            <a:r>
-              <a:rPr sz="1500" b="0">
-                <a:solidFill>
-                  <a:srgbClr val="7F7F7F"/>
-                </a:solidFill>
-                <a:latin typeface="IPAGothic"/>
-              </a:rPr>
-              <a:t>1名　1.7%</a:t>
-            </a:r>
-          </a:p>
-        </p:txBody>
-      </p:sp>
-      <p:sp>
-        <p:nvSpPr>
-          <p:cNvPr id="26" name="TextBox 25"/>
-          <p:cNvSpPr txBox="1"/>
-          <p:nvPr/>
-        </p:nvSpPr>
-        <p:spPr>
-          <a:xfrm>
-            <a:off x="9601200" y="5522976"/>
-            <a:ext cx="274320" cy="365760"/>
-          </a:xfrm>
-          <a:prstGeom prst="rect">
-            <a:avLst/>
-          </a:prstGeom>
-          <a:noFill/>
-        </p:spPr>
-        <p:txBody>
-          <a:bodyPr wrap="square">
-            <a:spAutoFit/>
-          </a:bodyPr>
-          <a:lstStyle/>
-          <a:p>
-            <a:pPr algn="l"/>
-            <a:r>
-              <a:rPr sz="1400" b="0">
-                <a:solidFill>
-                  <a:srgbClr val="27AE60"/>
-                </a:solidFill>
-                <a:latin typeface="IPAGothic"/>
-              </a:rPr>
-              <a:t>→</a:t>
-            </a:r>
-          </a:p>
-        </p:txBody>
-      </p:sp>
+      <p:pic>
+        <p:nvPicPr>
+          <p:cNvPr id="8" name="Picture 7" descr="status_by_univ.png"/>
+          <p:cNvPicPr>
+            <a:picLocks noChangeAspect="1"/>
+          </p:cNvPicPr>
+          <p:nvPr/>
+        </p:nvPicPr>
+        <p:blipFill>
+          <a:blip r:embed="rId3"/>
+          <a:stretch>
+            <a:fillRect/>
+          </a:stretch>
+        </p:blipFill>
+        <p:spPr>
+          <a:xfrm>
+            <a:off x="5303520" y="1097280"/>
+            <a:ext cx="6675120" cy="5577840"/>
+          </a:xfrm>
+          <a:prstGeom prst="rect">
+            <a:avLst/>
+          </a:prstGeom>
+        </p:spPr>
+      </p:pic>
     </p:spTree>
   </p:cSld>
   <p:clrMapOvr>
@@ -8058,7 +7375,7 @@
                 </a:solidFill>
                 <a:latin typeface="IPAGothic"/>
               </a:rPr>
-              <a:t>1次→2次の歩留まり向上</a:t>
+              <a:t>説明会兼面談→一次選考の歩留まり向上</a:t>
             </a:r>
           </a:p>
         </p:txBody>
@@ -8093,8 +7410,8 @@
                 </a:solidFill>
                 <a:latin typeface="IPAGothic"/>
               </a:rPr>
-              <a:t>1次通過27名のうち2次通過は11名（41%）。1次通過後のフォロー強化と
-エンゲージメント施策で通過率改善を目指す。</a:t>
+              <a:t>説明会兼面談通過27名のうち一次選考通過は11名（41%）。
+通過後のフォロー強化とエンゲージメント施策で通過率改善を目指す。</a:t>
             </a:r>
           </a:p>
         </p:txBody>

</xml_diff>

<commit_message>
Add withdrawal by step/reason, redesign summary with pass rate and non-participation counts
Co-Authored-By: Claude Sonnet 4.6 <noreply@anthropic.com>
Claude-Session: https://claude.ai/code/session_013nk1DEsSGa4nKpUoythx1H
</commit_message>
<xml_diff>
--- a/上位校採用分析レポート_2026.pptx
+++ b/上位校採用分析レポート_2026.pptx
@@ -13,6 +13,7 @@
     <p:sldId id="261" r:id="rId12"/>
     <p:sldId id="262" r:id="rId13"/>
     <p:sldId id="263" r:id="rId14"/>
+    <p:sldId id="264" r:id="rId15"/>
   </p:sldIdLst>
   <p:sldSz cx="12188952" cy="6858000" type="screen4x3"/>
   <p:notesSz cx="6858000" cy="9144000"/>
@@ -3971,14 +3972,14 @@
         </p:nvSpPr>
         <p:spPr>
           <a:xfrm>
-            <a:off x="365760" y="1261872"/>
-            <a:ext cx="2743200" cy="2057400"/>
-          </a:xfrm>
-          <a:prstGeom prst="rect">
-            <a:avLst/>
-          </a:prstGeom>
-          <a:solidFill>
-            <a:srgbClr val="FFFFFF"/>
+            <a:off x="320040" y="1261872"/>
+            <a:ext cx="2011680" cy="658368"/>
+          </a:xfrm>
+          <a:prstGeom prst="rect">
+            <a:avLst/>
+          </a:prstGeom>
+          <a:solidFill>
+            <a:srgbClr val="1E3A5F"/>
           </a:solidFill>
           <a:ln>
             <a:noFill/>
@@ -4008,14 +4009,49 @@
       </p:sp>
       <p:sp>
         <p:nvSpPr>
-          <p:cNvPr id="8" name="Rectangle 7"/>
+          <p:cNvPr id="8" name="TextBox 7"/>
+          <p:cNvSpPr txBox="1"/>
+          <p:nvPr/>
+        </p:nvSpPr>
+        <p:spPr>
+          <a:xfrm>
+            <a:off x="374904" y="1298448"/>
+            <a:ext cx="1920240" cy="594360"/>
+          </a:xfrm>
+          <a:prstGeom prst="rect">
+            <a:avLst/>
+          </a:prstGeom>
+          <a:noFill/>
+        </p:spPr>
+        <p:txBody>
+          <a:bodyPr wrap="square">
+            <a:spAutoFit/>
+          </a:bodyPr>
+          <a:lstStyle/>
+          <a:p>
+            <a:pPr algn="ctr"/>
+            <a:r>
+              <a:rPr sz="1200" b="1">
+                <a:solidFill>
+                  <a:srgbClr val="FFFFFF"/>
+                </a:solidFill>
+                <a:latin typeface="IPAGothic"/>
+              </a:rPr>
+              <a:t>選考ステップ</a:t>
+            </a:r>
+          </a:p>
+        </p:txBody>
+      </p:sp>
+      <p:sp>
+        <p:nvSpPr>
+          <p:cNvPr id="9" name="Rectangle 8"/>
           <p:cNvSpPr/>
           <p:nvPr/>
         </p:nvSpPr>
         <p:spPr>
           <a:xfrm>
-            <a:off x="365760" y="1261872"/>
-            <a:ext cx="64008" cy="2057400"/>
+            <a:off x="2331720" y="1261872"/>
+            <a:ext cx="1188720" cy="658368"/>
           </a:xfrm>
           <a:prstGeom prst="rect">
             <a:avLst/>
@@ -4051,14 +4087,14 @@
       </p:sp>
       <p:sp>
         <p:nvSpPr>
-          <p:cNvPr id="9" name="TextBox 8"/>
+          <p:cNvPr id="10" name="TextBox 9"/>
           <p:cNvSpPr txBox="1"/>
           <p:nvPr/>
         </p:nvSpPr>
         <p:spPr>
           <a:xfrm>
-            <a:off x="530352" y="1325880"/>
-            <a:ext cx="2468880" cy="594360"/>
+            <a:off x="2386584" y="1298448"/>
+            <a:ext cx="1097280" cy="594360"/>
           </a:xfrm>
           <a:prstGeom prst="rect">
             <a:avLst/>
@@ -4071,29 +4107,2355 @@
           </a:bodyPr>
           <a:lstStyle/>
           <a:p>
+            <a:pPr algn="ctr"/>
+            <a:r>
+              <a:rPr sz="1200" b="1">
+                <a:solidFill>
+                  <a:srgbClr val="FFFFFF"/>
+                </a:solidFill>
+                <a:latin typeface="IPAGothic"/>
+              </a:rPr>
+              <a:t>受験者数</a:t>
+            </a:r>
+          </a:p>
+        </p:txBody>
+      </p:sp>
+      <p:sp>
+        <p:nvSpPr>
+          <p:cNvPr id="11" name="Rectangle 10"/>
+          <p:cNvSpPr/>
+          <p:nvPr/>
+        </p:nvSpPr>
+        <p:spPr>
+          <a:xfrm>
+            <a:off x="3520440" y="1261872"/>
+            <a:ext cx="1371600" cy="658368"/>
+          </a:xfrm>
+          <a:prstGeom prst="rect">
+            <a:avLst/>
+          </a:prstGeom>
+          <a:solidFill>
+            <a:srgbClr val="1E3A5F"/>
+          </a:solidFill>
+          <a:ln>
+            <a:noFill/>
+          </a:ln>
+        </p:spPr>
+        <p:style>
+          <a:lnRef idx="1">
+            <a:schemeClr val="accent1"/>
+          </a:lnRef>
+          <a:fillRef idx="3">
+            <a:schemeClr val="accent1"/>
+          </a:fillRef>
+          <a:effectRef idx="2">
+            <a:schemeClr val="accent1"/>
+          </a:effectRef>
+          <a:fontRef idx="minor">
+            <a:schemeClr val="lt1"/>
+          </a:fontRef>
+        </p:style>
+        <p:txBody>
+          <a:bodyPr rtlCol="0" anchor="ctr"/>
+          <a:lstStyle/>
+          <a:p>
+            <a:pPr algn="ctr"/>
+          </a:p>
+        </p:txBody>
+      </p:sp>
+      <p:sp>
+        <p:nvSpPr>
+          <p:cNvPr id="12" name="TextBox 11"/>
+          <p:cNvSpPr txBox="1"/>
+          <p:nvPr/>
+        </p:nvSpPr>
+        <p:spPr>
+          <a:xfrm>
+            <a:off x="3575304" y="1298448"/>
+            <a:ext cx="1280160" cy="594360"/>
+          </a:xfrm>
+          <a:prstGeom prst="rect">
+            <a:avLst/>
+          </a:prstGeom>
+          <a:noFill/>
+        </p:spPr>
+        <p:txBody>
+          <a:bodyPr wrap="square">
+            <a:spAutoFit/>
+          </a:bodyPr>
+          <a:lstStyle/>
+          <a:p>
+            <a:pPr algn="ctr"/>
+            <a:r>
+              <a:rPr sz="1200" b="1">
+                <a:solidFill>
+                  <a:srgbClr val="FFFFFF"/>
+                </a:solidFill>
+                <a:latin typeface="IPAGothic"/>
+              </a:rPr>
+              <a:t>通過数
+(通過率)</a:t>
+            </a:r>
+          </a:p>
+        </p:txBody>
+      </p:sp>
+      <p:sp>
+        <p:nvSpPr>
+          <p:cNvPr id="13" name="Rectangle 12"/>
+          <p:cNvSpPr/>
+          <p:nvPr/>
+        </p:nvSpPr>
+        <p:spPr>
+          <a:xfrm>
+            <a:off x="4892040" y="1261872"/>
+            <a:ext cx="1097280" cy="658368"/>
+          </a:xfrm>
+          <a:prstGeom prst="rect">
+            <a:avLst/>
+          </a:prstGeom>
+          <a:solidFill>
+            <a:srgbClr val="1E3A5F"/>
+          </a:solidFill>
+          <a:ln>
+            <a:noFill/>
+          </a:ln>
+        </p:spPr>
+        <p:style>
+          <a:lnRef idx="1">
+            <a:schemeClr val="accent1"/>
+          </a:lnRef>
+          <a:fillRef idx="3">
+            <a:schemeClr val="accent1"/>
+          </a:fillRef>
+          <a:effectRef idx="2">
+            <a:schemeClr val="accent1"/>
+          </a:effectRef>
+          <a:fontRef idx="minor">
+            <a:schemeClr val="lt1"/>
+          </a:fontRef>
+        </p:style>
+        <p:txBody>
+          <a:bodyPr rtlCol="0" anchor="ctr"/>
+          <a:lstStyle/>
+          <a:p>
+            <a:pPr algn="ctr"/>
+          </a:p>
+        </p:txBody>
+      </p:sp>
+      <p:sp>
+        <p:nvSpPr>
+          <p:cNvPr id="14" name="TextBox 13"/>
+          <p:cNvSpPr txBox="1"/>
+          <p:nvPr/>
+        </p:nvSpPr>
+        <p:spPr>
+          <a:xfrm>
+            <a:off x="4946904" y="1298448"/>
+            <a:ext cx="1005839" cy="594360"/>
+          </a:xfrm>
+          <a:prstGeom prst="rect">
+            <a:avLst/>
+          </a:prstGeom>
+          <a:noFill/>
+        </p:spPr>
+        <p:txBody>
+          <a:bodyPr wrap="square">
+            <a:spAutoFit/>
+          </a:bodyPr>
+          <a:lstStyle/>
+          <a:p>
+            <a:pPr algn="ctr"/>
+            <a:r>
+              <a:rPr sz="1200" b="1">
+                <a:solidFill>
+                  <a:srgbClr val="FFFFFF"/>
+                </a:solidFill>
+                <a:latin typeface="IPAGothic"/>
+              </a:rPr>
+              <a:t>辞退数</a:t>
+            </a:r>
+          </a:p>
+        </p:txBody>
+      </p:sp>
+      <p:sp>
+        <p:nvSpPr>
+          <p:cNvPr id="15" name="Rectangle 14"/>
+          <p:cNvSpPr/>
+          <p:nvPr/>
+        </p:nvSpPr>
+        <p:spPr>
+          <a:xfrm>
+            <a:off x="5989320" y="1261872"/>
+            <a:ext cx="1097280" cy="658368"/>
+          </a:xfrm>
+          <a:prstGeom prst="rect">
+            <a:avLst/>
+          </a:prstGeom>
+          <a:solidFill>
+            <a:srgbClr val="1E3A5F"/>
+          </a:solidFill>
+          <a:ln>
+            <a:noFill/>
+          </a:ln>
+        </p:spPr>
+        <p:style>
+          <a:lnRef idx="1">
+            <a:schemeClr val="accent1"/>
+          </a:lnRef>
+          <a:fillRef idx="3">
+            <a:schemeClr val="accent1"/>
+          </a:fillRef>
+          <a:effectRef idx="2">
+            <a:schemeClr val="accent1"/>
+          </a:effectRef>
+          <a:fontRef idx="minor">
+            <a:schemeClr val="lt1"/>
+          </a:fontRef>
+        </p:style>
+        <p:txBody>
+          <a:bodyPr rtlCol="0" anchor="ctr"/>
+          <a:lstStyle/>
+          <a:p>
+            <a:pPr algn="ctr"/>
+          </a:p>
+        </p:txBody>
+      </p:sp>
+      <p:sp>
+        <p:nvSpPr>
+          <p:cNvPr id="16" name="TextBox 15"/>
+          <p:cNvSpPr txBox="1"/>
+          <p:nvPr/>
+        </p:nvSpPr>
+        <p:spPr>
+          <a:xfrm>
+            <a:off x="6044184" y="1298448"/>
+            <a:ext cx="1005839" cy="594360"/>
+          </a:xfrm>
+          <a:prstGeom prst="rect">
+            <a:avLst/>
+          </a:prstGeom>
+          <a:noFill/>
+        </p:spPr>
+        <p:txBody>
+          <a:bodyPr wrap="square">
+            <a:spAutoFit/>
+          </a:bodyPr>
+          <a:lstStyle/>
+          <a:p>
+            <a:pPr algn="ctr"/>
+            <a:r>
+              <a:rPr sz="1200" b="1">
+                <a:solidFill>
+                  <a:srgbClr val="FFFFFF"/>
+                </a:solidFill>
+                <a:latin typeface="IPAGothic"/>
+              </a:rPr>
+              <a:t>不合格数</a:t>
+            </a:r>
+          </a:p>
+        </p:txBody>
+      </p:sp>
+      <p:sp>
+        <p:nvSpPr>
+          <p:cNvPr id="17" name="Rectangle 16"/>
+          <p:cNvSpPr/>
+          <p:nvPr/>
+        </p:nvSpPr>
+        <p:spPr>
+          <a:xfrm>
+            <a:off x="7086600" y="1261872"/>
+            <a:ext cx="1005840" cy="658368"/>
+          </a:xfrm>
+          <a:prstGeom prst="rect">
+            <a:avLst/>
+          </a:prstGeom>
+          <a:solidFill>
+            <a:srgbClr val="1E3A5F"/>
+          </a:solidFill>
+          <a:ln>
+            <a:noFill/>
+          </a:ln>
+        </p:spPr>
+        <p:style>
+          <a:lnRef idx="1">
+            <a:schemeClr val="accent1"/>
+          </a:lnRef>
+          <a:fillRef idx="3">
+            <a:schemeClr val="accent1"/>
+          </a:fillRef>
+          <a:effectRef idx="2">
+            <a:schemeClr val="accent1"/>
+          </a:effectRef>
+          <a:fontRef idx="minor">
+            <a:schemeClr val="lt1"/>
+          </a:fontRef>
+        </p:style>
+        <p:txBody>
+          <a:bodyPr rtlCol="0" anchor="ctr"/>
+          <a:lstStyle/>
+          <a:p>
+            <a:pPr algn="ctr"/>
+          </a:p>
+        </p:txBody>
+      </p:sp>
+      <p:sp>
+        <p:nvSpPr>
+          <p:cNvPr id="18" name="TextBox 17"/>
+          <p:cNvSpPr txBox="1"/>
+          <p:nvPr/>
+        </p:nvSpPr>
+        <p:spPr>
+          <a:xfrm>
+            <a:off x="7141464" y="1298448"/>
+            <a:ext cx="914400" cy="594360"/>
+          </a:xfrm>
+          <a:prstGeom prst="rect">
+            <a:avLst/>
+          </a:prstGeom>
+          <a:noFill/>
+        </p:spPr>
+        <p:txBody>
+          <a:bodyPr wrap="square">
+            <a:spAutoFit/>
+          </a:bodyPr>
+          <a:lstStyle/>
+          <a:p>
+            <a:pPr algn="ctr"/>
+            <a:r>
+              <a:rPr sz="1200" b="1">
+                <a:solidFill>
+                  <a:srgbClr val="FFFFFF"/>
+                </a:solidFill>
+                <a:latin typeface="IPAGothic"/>
+              </a:rPr>
+              <a:t>選考中</a:t>
+            </a:r>
+          </a:p>
+        </p:txBody>
+      </p:sp>
+      <p:sp>
+        <p:nvSpPr>
+          <p:cNvPr id="19" name="Rectangle 18"/>
+          <p:cNvSpPr/>
+          <p:nvPr/>
+        </p:nvSpPr>
+        <p:spPr>
+          <a:xfrm>
+            <a:off x="8092440" y="1261872"/>
+            <a:ext cx="1280160" cy="658368"/>
+          </a:xfrm>
+          <a:prstGeom prst="rect">
+            <a:avLst/>
+          </a:prstGeom>
+          <a:solidFill>
+            <a:srgbClr val="1E3A5F"/>
+          </a:solidFill>
+          <a:ln>
+            <a:noFill/>
+          </a:ln>
+        </p:spPr>
+        <p:style>
+          <a:lnRef idx="1">
+            <a:schemeClr val="accent1"/>
+          </a:lnRef>
+          <a:fillRef idx="3">
+            <a:schemeClr val="accent1"/>
+          </a:fillRef>
+          <a:effectRef idx="2">
+            <a:schemeClr val="accent1"/>
+          </a:effectRef>
+          <a:fontRef idx="minor">
+            <a:schemeClr val="lt1"/>
+          </a:fontRef>
+        </p:style>
+        <p:txBody>
+          <a:bodyPr rtlCol="0" anchor="ctr"/>
+          <a:lstStyle/>
+          <a:p>
+            <a:pPr algn="ctr"/>
+          </a:p>
+        </p:txBody>
+      </p:sp>
+      <p:sp>
+        <p:nvSpPr>
+          <p:cNvPr id="20" name="TextBox 19"/>
+          <p:cNvSpPr txBox="1"/>
+          <p:nvPr/>
+        </p:nvSpPr>
+        <p:spPr>
+          <a:xfrm>
+            <a:off x="8147304" y="1298448"/>
+            <a:ext cx="1188719" cy="594360"/>
+          </a:xfrm>
+          <a:prstGeom prst="rect">
+            <a:avLst/>
+          </a:prstGeom>
+          <a:noFill/>
+        </p:spPr>
+        <p:txBody>
+          <a:bodyPr wrap="square">
+            <a:spAutoFit/>
+          </a:bodyPr>
+          <a:lstStyle/>
+          <a:p>
+            <a:pPr algn="ctr"/>
+            <a:r>
+              <a:rPr sz="1200" b="1">
+                <a:solidFill>
+                  <a:srgbClr val="FFFFFF"/>
+                </a:solidFill>
+                <a:latin typeface="IPAGothic"/>
+              </a:rPr>
+              <a:t>前段階
+未到達</a:t>
+            </a:r>
+          </a:p>
+        </p:txBody>
+      </p:sp>
+      <p:sp>
+        <p:nvSpPr>
+          <p:cNvPr id="21" name="Rectangle 20"/>
+          <p:cNvSpPr/>
+          <p:nvPr/>
+        </p:nvSpPr>
+        <p:spPr>
+          <a:xfrm>
+            <a:off x="320040" y="1965960"/>
+            <a:ext cx="2011680" cy="777240"/>
+          </a:xfrm>
+          <a:prstGeom prst="rect">
+            <a:avLst/>
+          </a:prstGeom>
+          <a:solidFill>
+            <a:srgbClr val="E8F0F8"/>
+          </a:solidFill>
+          <a:ln>
+            <a:noFill/>
+          </a:ln>
+        </p:spPr>
+        <p:style>
+          <a:lnRef idx="1">
+            <a:schemeClr val="accent1"/>
+          </a:lnRef>
+          <a:fillRef idx="3">
+            <a:schemeClr val="accent1"/>
+          </a:fillRef>
+          <a:effectRef idx="2">
+            <a:schemeClr val="accent1"/>
+          </a:effectRef>
+          <a:fontRef idx="minor">
+            <a:schemeClr val="lt1"/>
+          </a:fontRef>
+        </p:style>
+        <p:txBody>
+          <a:bodyPr rtlCol="0" anchor="ctr"/>
+          <a:lstStyle/>
+          <a:p>
+            <a:pPr algn="ctr"/>
+          </a:p>
+        </p:txBody>
+      </p:sp>
+      <p:sp>
+        <p:nvSpPr>
+          <p:cNvPr id="22" name="TextBox 21"/>
+          <p:cNvSpPr txBox="1"/>
+          <p:nvPr/>
+        </p:nvSpPr>
+        <p:spPr>
+          <a:xfrm>
+            <a:off x="365759" y="2011679"/>
+            <a:ext cx="1938528" cy="694944"/>
+          </a:xfrm>
+          <a:prstGeom prst="rect">
+            <a:avLst/>
+          </a:prstGeom>
+          <a:noFill/>
+        </p:spPr>
+        <p:txBody>
+          <a:bodyPr wrap="square">
+            <a:spAutoFit/>
+          </a:bodyPr>
+          <a:lstStyle/>
+          <a:p>
+            <a:pPr algn="ctr"/>
+            <a:r>
+              <a:rPr sz="1400" b="0">
+                <a:solidFill>
+                  <a:srgbClr val="1E3A5F"/>
+                </a:solidFill>
+                <a:latin typeface="IPAGothic"/>
+              </a:rPr>
+              <a:t>説明会兼面談</a:t>
+            </a:r>
+          </a:p>
+        </p:txBody>
+      </p:sp>
+      <p:sp>
+        <p:nvSpPr>
+          <p:cNvPr id="23" name="Rectangle 22"/>
+          <p:cNvSpPr/>
+          <p:nvPr/>
+        </p:nvSpPr>
+        <p:spPr>
+          <a:xfrm>
+            <a:off x="2331720" y="1965960"/>
+            <a:ext cx="1188720" cy="777240"/>
+          </a:xfrm>
+          <a:prstGeom prst="rect">
+            <a:avLst/>
+          </a:prstGeom>
+          <a:solidFill>
+            <a:srgbClr val="E8F0F8"/>
+          </a:solidFill>
+          <a:ln>
+            <a:noFill/>
+          </a:ln>
+        </p:spPr>
+        <p:style>
+          <a:lnRef idx="1">
+            <a:schemeClr val="accent1"/>
+          </a:lnRef>
+          <a:fillRef idx="3">
+            <a:schemeClr val="accent1"/>
+          </a:fillRef>
+          <a:effectRef idx="2">
+            <a:schemeClr val="accent1"/>
+          </a:effectRef>
+          <a:fontRef idx="minor">
+            <a:schemeClr val="lt1"/>
+          </a:fontRef>
+        </p:style>
+        <p:txBody>
+          <a:bodyPr rtlCol="0" anchor="ctr"/>
+          <a:lstStyle/>
+          <a:p>
+            <a:pPr algn="ctr"/>
+          </a:p>
+        </p:txBody>
+      </p:sp>
+      <p:sp>
+        <p:nvSpPr>
+          <p:cNvPr id="24" name="TextBox 23"/>
+          <p:cNvSpPr txBox="1"/>
+          <p:nvPr/>
+        </p:nvSpPr>
+        <p:spPr>
+          <a:xfrm>
+            <a:off x="2377440" y="2011679"/>
+            <a:ext cx="1115568" cy="694944"/>
+          </a:xfrm>
+          <a:prstGeom prst="rect">
+            <a:avLst/>
+          </a:prstGeom>
+          <a:noFill/>
+        </p:spPr>
+        <p:txBody>
+          <a:bodyPr wrap="square">
+            <a:spAutoFit/>
+          </a:bodyPr>
+          <a:lstStyle/>
+          <a:p>
+            <a:pPr algn="ctr"/>
+            <a:r>
+              <a:rPr sz="1500" b="1">
+                <a:solidFill>
+                  <a:srgbClr val="1E3A5F"/>
+                </a:solidFill>
+                <a:latin typeface="IPAGothic"/>
+              </a:rPr>
+              <a:t>59名</a:t>
+            </a:r>
+          </a:p>
+        </p:txBody>
+      </p:sp>
+      <p:sp>
+        <p:nvSpPr>
+          <p:cNvPr id="25" name="Rectangle 24"/>
+          <p:cNvSpPr/>
+          <p:nvPr/>
+        </p:nvSpPr>
+        <p:spPr>
+          <a:xfrm>
+            <a:off x="3520440" y="1965960"/>
+            <a:ext cx="1371600" cy="777240"/>
+          </a:xfrm>
+          <a:prstGeom prst="rect">
+            <a:avLst/>
+          </a:prstGeom>
+          <a:solidFill>
+            <a:srgbClr val="E8F0F8"/>
+          </a:solidFill>
+          <a:ln>
+            <a:noFill/>
+          </a:ln>
+        </p:spPr>
+        <p:style>
+          <a:lnRef idx="1">
+            <a:schemeClr val="accent1"/>
+          </a:lnRef>
+          <a:fillRef idx="3">
+            <a:schemeClr val="accent1"/>
+          </a:fillRef>
+          <a:effectRef idx="2">
+            <a:schemeClr val="accent1"/>
+          </a:effectRef>
+          <a:fontRef idx="minor">
+            <a:schemeClr val="lt1"/>
+          </a:fontRef>
+        </p:style>
+        <p:txBody>
+          <a:bodyPr rtlCol="0" anchor="ctr"/>
+          <a:lstStyle/>
+          <a:p>
+            <a:pPr algn="ctr"/>
+          </a:p>
+        </p:txBody>
+      </p:sp>
+      <p:sp>
+        <p:nvSpPr>
+          <p:cNvPr id="26" name="TextBox 25"/>
+          <p:cNvSpPr txBox="1"/>
+          <p:nvPr/>
+        </p:nvSpPr>
+        <p:spPr>
+          <a:xfrm>
+            <a:off x="3566160" y="2011679"/>
+            <a:ext cx="1298448" cy="694944"/>
+          </a:xfrm>
+          <a:prstGeom prst="rect">
+            <a:avLst/>
+          </a:prstGeom>
+          <a:noFill/>
+        </p:spPr>
+        <p:txBody>
+          <a:bodyPr wrap="square">
+            <a:spAutoFit/>
+          </a:bodyPr>
+          <a:lstStyle/>
+          <a:p>
+            <a:pPr algn="ctr"/>
+            <a:r>
+              <a:rPr sz="1500" b="1">
+                <a:solidFill>
+                  <a:srgbClr val="27AE60"/>
+                </a:solidFill>
+                <a:latin typeface="IPAGothic"/>
+              </a:rPr>
+              <a:t>27名
+(46%)</a:t>
+            </a:r>
+          </a:p>
+        </p:txBody>
+      </p:sp>
+      <p:sp>
+        <p:nvSpPr>
+          <p:cNvPr id="27" name="Rectangle 26"/>
+          <p:cNvSpPr/>
+          <p:nvPr/>
+        </p:nvSpPr>
+        <p:spPr>
+          <a:xfrm>
+            <a:off x="4892040" y="1965960"/>
+            <a:ext cx="1097280" cy="777240"/>
+          </a:xfrm>
+          <a:prstGeom prst="rect">
+            <a:avLst/>
+          </a:prstGeom>
+          <a:solidFill>
+            <a:srgbClr val="E8F0F8"/>
+          </a:solidFill>
+          <a:ln>
+            <a:noFill/>
+          </a:ln>
+        </p:spPr>
+        <p:style>
+          <a:lnRef idx="1">
+            <a:schemeClr val="accent1"/>
+          </a:lnRef>
+          <a:fillRef idx="3">
+            <a:schemeClr val="accent1"/>
+          </a:fillRef>
+          <a:effectRef idx="2">
+            <a:schemeClr val="accent1"/>
+          </a:effectRef>
+          <a:fontRef idx="minor">
+            <a:schemeClr val="lt1"/>
+          </a:fontRef>
+        </p:style>
+        <p:txBody>
+          <a:bodyPr rtlCol="0" anchor="ctr"/>
+          <a:lstStyle/>
+          <a:p>
+            <a:pPr algn="ctr"/>
+          </a:p>
+        </p:txBody>
+      </p:sp>
+      <p:sp>
+        <p:nvSpPr>
+          <p:cNvPr id="28" name="TextBox 27"/>
+          <p:cNvSpPr txBox="1"/>
+          <p:nvPr/>
+        </p:nvSpPr>
+        <p:spPr>
+          <a:xfrm>
+            <a:off x="4937760" y="2011679"/>
+            <a:ext cx="1024127" cy="694944"/>
+          </a:xfrm>
+          <a:prstGeom prst="rect">
+            <a:avLst/>
+          </a:prstGeom>
+          <a:noFill/>
+        </p:spPr>
+        <p:txBody>
+          <a:bodyPr wrap="square">
+            <a:spAutoFit/>
+          </a:bodyPr>
+          <a:lstStyle/>
+          <a:p>
+            <a:pPr algn="ctr"/>
+            <a:r>
+              <a:rPr sz="1400" b="0">
+                <a:solidFill>
+                  <a:srgbClr val="E74C3C"/>
+                </a:solidFill>
+                <a:latin typeface="IPAGothic"/>
+              </a:rPr>
+              <a:t>18名</a:t>
+            </a:r>
+          </a:p>
+        </p:txBody>
+      </p:sp>
+      <p:sp>
+        <p:nvSpPr>
+          <p:cNvPr id="29" name="Rectangle 28"/>
+          <p:cNvSpPr/>
+          <p:nvPr/>
+        </p:nvSpPr>
+        <p:spPr>
+          <a:xfrm>
+            <a:off x="5989320" y="1965960"/>
+            <a:ext cx="1097280" cy="777240"/>
+          </a:xfrm>
+          <a:prstGeom prst="rect">
+            <a:avLst/>
+          </a:prstGeom>
+          <a:solidFill>
+            <a:srgbClr val="E8F0F8"/>
+          </a:solidFill>
+          <a:ln>
+            <a:noFill/>
+          </a:ln>
+        </p:spPr>
+        <p:style>
+          <a:lnRef idx="1">
+            <a:schemeClr val="accent1"/>
+          </a:lnRef>
+          <a:fillRef idx="3">
+            <a:schemeClr val="accent1"/>
+          </a:fillRef>
+          <a:effectRef idx="2">
+            <a:schemeClr val="accent1"/>
+          </a:effectRef>
+          <a:fontRef idx="minor">
+            <a:schemeClr val="lt1"/>
+          </a:fontRef>
+        </p:style>
+        <p:txBody>
+          <a:bodyPr rtlCol="0" anchor="ctr"/>
+          <a:lstStyle/>
+          <a:p>
+            <a:pPr algn="ctr"/>
+          </a:p>
+        </p:txBody>
+      </p:sp>
+      <p:sp>
+        <p:nvSpPr>
+          <p:cNvPr id="30" name="TextBox 29"/>
+          <p:cNvSpPr txBox="1"/>
+          <p:nvPr/>
+        </p:nvSpPr>
+        <p:spPr>
+          <a:xfrm>
+            <a:off x="6035040" y="2011679"/>
+            <a:ext cx="1024127" cy="694944"/>
+          </a:xfrm>
+          <a:prstGeom prst="rect">
+            <a:avLst/>
+          </a:prstGeom>
+          <a:noFill/>
+        </p:spPr>
+        <p:txBody>
+          <a:bodyPr wrap="square">
+            <a:spAutoFit/>
+          </a:bodyPr>
+          <a:lstStyle/>
+          <a:p>
+            <a:pPr algn="ctr"/>
+            <a:r>
+              <a:rPr sz="1400" b="0">
+                <a:solidFill>
+                  <a:srgbClr val="95A5A6"/>
+                </a:solidFill>
+                <a:latin typeface="IPAGothic"/>
+              </a:rPr>
+              <a:t>2名</a:t>
+            </a:r>
+          </a:p>
+        </p:txBody>
+      </p:sp>
+      <p:sp>
+        <p:nvSpPr>
+          <p:cNvPr id="31" name="Rectangle 30"/>
+          <p:cNvSpPr/>
+          <p:nvPr/>
+        </p:nvSpPr>
+        <p:spPr>
+          <a:xfrm>
+            <a:off x="7086600" y="1965960"/>
+            <a:ext cx="1005840" cy="777240"/>
+          </a:xfrm>
+          <a:prstGeom prst="rect">
+            <a:avLst/>
+          </a:prstGeom>
+          <a:solidFill>
+            <a:srgbClr val="E8F0F8"/>
+          </a:solidFill>
+          <a:ln>
+            <a:noFill/>
+          </a:ln>
+        </p:spPr>
+        <p:style>
+          <a:lnRef idx="1">
+            <a:schemeClr val="accent1"/>
+          </a:lnRef>
+          <a:fillRef idx="3">
+            <a:schemeClr val="accent1"/>
+          </a:fillRef>
+          <a:effectRef idx="2">
+            <a:schemeClr val="accent1"/>
+          </a:effectRef>
+          <a:fontRef idx="minor">
+            <a:schemeClr val="lt1"/>
+          </a:fontRef>
+        </p:style>
+        <p:txBody>
+          <a:bodyPr rtlCol="0" anchor="ctr"/>
+          <a:lstStyle/>
+          <a:p>
+            <a:pPr algn="ctr"/>
+          </a:p>
+        </p:txBody>
+      </p:sp>
+      <p:sp>
+        <p:nvSpPr>
+          <p:cNvPr id="32" name="TextBox 31"/>
+          <p:cNvSpPr txBox="1"/>
+          <p:nvPr/>
+        </p:nvSpPr>
+        <p:spPr>
+          <a:xfrm>
+            <a:off x="7132320" y="2011679"/>
+            <a:ext cx="932688" cy="694944"/>
+          </a:xfrm>
+          <a:prstGeom prst="rect">
+            <a:avLst/>
+          </a:prstGeom>
+          <a:noFill/>
+        </p:spPr>
+        <p:txBody>
+          <a:bodyPr wrap="square">
+            <a:spAutoFit/>
+          </a:bodyPr>
+          <a:lstStyle/>
+          <a:p>
+            <a:pPr algn="ctr"/>
+            <a:r>
+              <a:rPr sz="1400" b="0">
+                <a:solidFill>
+                  <a:srgbClr val="4A90D9"/>
+                </a:solidFill>
+                <a:latin typeface="IPAGothic"/>
+              </a:rPr>
+              <a:t>12名</a:t>
+            </a:r>
+          </a:p>
+        </p:txBody>
+      </p:sp>
+      <p:sp>
+        <p:nvSpPr>
+          <p:cNvPr id="33" name="Rectangle 32"/>
+          <p:cNvSpPr/>
+          <p:nvPr/>
+        </p:nvSpPr>
+        <p:spPr>
+          <a:xfrm>
+            <a:off x="8092440" y="1965960"/>
+            <a:ext cx="1280160" cy="777240"/>
+          </a:xfrm>
+          <a:prstGeom prst="rect">
+            <a:avLst/>
+          </a:prstGeom>
+          <a:solidFill>
+            <a:srgbClr val="E8F0F8"/>
+          </a:solidFill>
+          <a:ln>
+            <a:noFill/>
+          </a:ln>
+        </p:spPr>
+        <p:style>
+          <a:lnRef idx="1">
+            <a:schemeClr val="accent1"/>
+          </a:lnRef>
+          <a:fillRef idx="3">
+            <a:schemeClr val="accent1"/>
+          </a:fillRef>
+          <a:effectRef idx="2">
+            <a:schemeClr val="accent1"/>
+          </a:effectRef>
+          <a:fontRef idx="minor">
+            <a:schemeClr val="lt1"/>
+          </a:fontRef>
+        </p:style>
+        <p:txBody>
+          <a:bodyPr rtlCol="0" anchor="ctr"/>
+          <a:lstStyle/>
+          <a:p>
+            <a:pPr algn="ctr"/>
+          </a:p>
+        </p:txBody>
+      </p:sp>
+      <p:sp>
+        <p:nvSpPr>
+          <p:cNvPr id="34" name="TextBox 33"/>
+          <p:cNvSpPr txBox="1"/>
+          <p:nvPr/>
+        </p:nvSpPr>
+        <p:spPr>
+          <a:xfrm>
+            <a:off x="8138160" y="2011679"/>
+            <a:ext cx="1207007" cy="694944"/>
+          </a:xfrm>
+          <a:prstGeom prst="rect">
+            <a:avLst/>
+          </a:prstGeom>
+          <a:noFill/>
+        </p:spPr>
+        <p:txBody>
+          <a:bodyPr wrap="square">
+            <a:spAutoFit/>
+          </a:bodyPr>
+          <a:lstStyle/>
+          <a:p>
+            <a:pPr algn="ctr"/>
+            <a:r>
+              <a:rPr sz="1400" b="0">
+                <a:solidFill>
+                  <a:srgbClr val="999999"/>
+                </a:solidFill>
+                <a:latin typeface="IPAGothic"/>
+              </a:rPr>
+              <a:t>─</a:t>
+            </a:r>
+          </a:p>
+        </p:txBody>
+      </p:sp>
+      <p:sp>
+        <p:nvSpPr>
+          <p:cNvPr id="35" name="Rectangle 34"/>
+          <p:cNvSpPr/>
+          <p:nvPr/>
+        </p:nvSpPr>
+        <p:spPr>
+          <a:xfrm>
+            <a:off x="320040" y="2788920"/>
+            <a:ext cx="2011680" cy="777240"/>
+          </a:xfrm>
+          <a:prstGeom prst="rect">
+            <a:avLst/>
+          </a:prstGeom>
+          <a:solidFill>
+            <a:srgbClr val="FFFFFF"/>
+          </a:solidFill>
+          <a:ln>
+            <a:noFill/>
+          </a:ln>
+        </p:spPr>
+        <p:style>
+          <a:lnRef idx="1">
+            <a:schemeClr val="accent1"/>
+          </a:lnRef>
+          <a:fillRef idx="3">
+            <a:schemeClr val="accent1"/>
+          </a:fillRef>
+          <a:effectRef idx="2">
+            <a:schemeClr val="accent1"/>
+          </a:effectRef>
+          <a:fontRef idx="minor">
+            <a:schemeClr val="lt1"/>
+          </a:fontRef>
+        </p:style>
+        <p:txBody>
+          <a:bodyPr rtlCol="0" anchor="ctr"/>
+          <a:lstStyle/>
+          <a:p>
+            <a:pPr algn="ctr"/>
+          </a:p>
+        </p:txBody>
+      </p:sp>
+      <p:sp>
+        <p:nvSpPr>
+          <p:cNvPr id="36" name="TextBox 35"/>
+          <p:cNvSpPr txBox="1"/>
+          <p:nvPr/>
+        </p:nvSpPr>
+        <p:spPr>
+          <a:xfrm>
+            <a:off x="365759" y="2834639"/>
+            <a:ext cx="1938528" cy="694944"/>
+          </a:xfrm>
+          <a:prstGeom prst="rect">
+            <a:avLst/>
+          </a:prstGeom>
+          <a:noFill/>
+        </p:spPr>
+        <p:txBody>
+          <a:bodyPr wrap="square">
+            <a:spAutoFit/>
+          </a:bodyPr>
+          <a:lstStyle/>
+          <a:p>
+            <a:pPr algn="ctr"/>
+            <a:r>
+              <a:rPr sz="1400" b="0">
+                <a:solidFill>
+                  <a:srgbClr val="1E3A5F"/>
+                </a:solidFill>
+                <a:latin typeface="IPAGothic"/>
+              </a:rPr>
+              <a:t>一次選考</a:t>
+            </a:r>
+          </a:p>
+        </p:txBody>
+      </p:sp>
+      <p:sp>
+        <p:nvSpPr>
+          <p:cNvPr id="37" name="Rectangle 36"/>
+          <p:cNvSpPr/>
+          <p:nvPr/>
+        </p:nvSpPr>
+        <p:spPr>
+          <a:xfrm>
+            <a:off x="2331720" y="2788920"/>
+            <a:ext cx="1188720" cy="777240"/>
+          </a:xfrm>
+          <a:prstGeom prst="rect">
+            <a:avLst/>
+          </a:prstGeom>
+          <a:solidFill>
+            <a:srgbClr val="FFFFFF"/>
+          </a:solidFill>
+          <a:ln>
+            <a:noFill/>
+          </a:ln>
+        </p:spPr>
+        <p:style>
+          <a:lnRef idx="1">
+            <a:schemeClr val="accent1"/>
+          </a:lnRef>
+          <a:fillRef idx="3">
+            <a:schemeClr val="accent1"/>
+          </a:fillRef>
+          <a:effectRef idx="2">
+            <a:schemeClr val="accent1"/>
+          </a:effectRef>
+          <a:fontRef idx="minor">
+            <a:schemeClr val="lt1"/>
+          </a:fontRef>
+        </p:style>
+        <p:txBody>
+          <a:bodyPr rtlCol="0" anchor="ctr"/>
+          <a:lstStyle/>
+          <a:p>
+            <a:pPr algn="ctr"/>
+          </a:p>
+        </p:txBody>
+      </p:sp>
+      <p:sp>
+        <p:nvSpPr>
+          <p:cNvPr id="38" name="TextBox 37"/>
+          <p:cNvSpPr txBox="1"/>
+          <p:nvPr/>
+        </p:nvSpPr>
+        <p:spPr>
+          <a:xfrm>
+            <a:off x="2377440" y="2834639"/>
+            <a:ext cx="1115568" cy="694944"/>
+          </a:xfrm>
+          <a:prstGeom prst="rect">
+            <a:avLst/>
+          </a:prstGeom>
+          <a:noFill/>
+        </p:spPr>
+        <p:txBody>
+          <a:bodyPr wrap="square">
+            <a:spAutoFit/>
+          </a:bodyPr>
+          <a:lstStyle/>
+          <a:p>
+            <a:pPr algn="ctr"/>
+            <a:r>
+              <a:rPr sz="1500" b="1">
+                <a:solidFill>
+                  <a:srgbClr val="1E3A5F"/>
+                </a:solidFill>
+                <a:latin typeface="IPAGothic"/>
+              </a:rPr>
+              <a:t>27名</a:t>
+            </a:r>
+          </a:p>
+        </p:txBody>
+      </p:sp>
+      <p:sp>
+        <p:nvSpPr>
+          <p:cNvPr id="39" name="Rectangle 38"/>
+          <p:cNvSpPr/>
+          <p:nvPr/>
+        </p:nvSpPr>
+        <p:spPr>
+          <a:xfrm>
+            <a:off x="3520440" y="2788920"/>
+            <a:ext cx="1371600" cy="777240"/>
+          </a:xfrm>
+          <a:prstGeom prst="rect">
+            <a:avLst/>
+          </a:prstGeom>
+          <a:solidFill>
+            <a:srgbClr val="FFFFFF"/>
+          </a:solidFill>
+          <a:ln>
+            <a:noFill/>
+          </a:ln>
+        </p:spPr>
+        <p:style>
+          <a:lnRef idx="1">
+            <a:schemeClr val="accent1"/>
+          </a:lnRef>
+          <a:fillRef idx="3">
+            <a:schemeClr val="accent1"/>
+          </a:fillRef>
+          <a:effectRef idx="2">
+            <a:schemeClr val="accent1"/>
+          </a:effectRef>
+          <a:fontRef idx="minor">
+            <a:schemeClr val="lt1"/>
+          </a:fontRef>
+        </p:style>
+        <p:txBody>
+          <a:bodyPr rtlCol="0" anchor="ctr"/>
+          <a:lstStyle/>
+          <a:p>
+            <a:pPr algn="ctr"/>
+          </a:p>
+        </p:txBody>
+      </p:sp>
+      <p:sp>
+        <p:nvSpPr>
+          <p:cNvPr id="40" name="TextBox 39"/>
+          <p:cNvSpPr txBox="1"/>
+          <p:nvPr/>
+        </p:nvSpPr>
+        <p:spPr>
+          <a:xfrm>
+            <a:off x="3566160" y="2834639"/>
+            <a:ext cx="1298448" cy="694944"/>
+          </a:xfrm>
+          <a:prstGeom prst="rect">
+            <a:avLst/>
+          </a:prstGeom>
+          <a:noFill/>
+        </p:spPr>
+        <p:txBody>
+          <a:bodyPr wrap="square">
+            <a:spAutoFit/>
+          </a:bodyPr>
+          <a:lstStyle/>
+          <a:p>
+            <a:pPr algn="ctr"/>
+            <a:r>
+              <a:rPr sz="1500" b="1">
+                <a:solidFill>
+                  <a:srgbClr val="27AE60"/>
+                </a:solidFill>
+                <a:latin typeface="IPAGothic"/>
+              </a:rPr>
+              <a:t>11名
+(41%)</a:t>
+            </a:r>
+          </a:p>
+        </p:txBody>
+      </p:sp>
+      <p:sp>
+        <p:nvSpPr>
+          <p:cNvPr id="41" name="Rectangle 40"/>
+          <p:cNvSpPr/>
+          <p:nvPr/>
+        </p:nvSpPr>
+        <p:spPr>
+          <a:xfrm>
+            <a:off x="4892040" y="2788920"/>
+            <a:ext cx="1097280" cy="777240"/>
+          </a:xfrm>
+          <a:prstGeom prst="rect">
+            <a:avLst/>
+          </a:prstGeom>
+          <a:solidFill>
+            <a:srgbClr val="FFFFFF"/>
+          </a:solidFill>
+          <a:ln>
+            <a:noFill/>
+          </a:ln>
+        </p:spPr>
+        <p:style>
+          <a:lnRef idx="1">
+            <a:schemeClr val="accent1"/>
+          </a:lnRef>
+          <a:fillRef idx="3">
+            <a:schemeClr val="accent1"/>
+          </a:fillRef>
+          <a:effectRef idx="2">
+            <a:schemeClr val="accent1"/>
+          </a:effectRef>
+          <a:fontRef idx="minor">
+            <a:schemeClr val="lt1"/>
+          </a:fontRef>
+        </p:style>
+        <p:txBody>
+          <a:bodyPr rtlCol="0" anchor="ctr"/>
+          <a:lstStyle/>
+          <a:p>
+            <a:pPr algn="ctr"/>
+          </a:p>
+        </p:txBody>
+      </p:sp>
+      <p:sp>
+        <p:nvSpPr>
+          <p:cNvPr id="42" name="TextBox 41"/>
+          <p:cNvSpPr txBox="1"/>
+          <p:nvPr/>
+        </p:nvSpPr>
+        <p:spPr>
+          <a:xfrm>
+            <a:off x="4937760" y="2834639"/>
+            <a:ext cx="1024127" cy="694944"/>
+          </a:xfrm>
+          <a:prstGeom prst="rect">
+            <a:avLst/>
+          </a:prstGeom>
+          <a:noFill/>
+        </p:spPr>
+        <p:txBody>
+          <a:bodyPr wrap="square">
+            <a:spAutoFit/>
+          </a:bodyPr>
+          <a:lstStyle/>
+          <a:p>
+            <a:pPr algn="ctr"/>
+            <a:r>
+              <a:rPr sz="1400" b="0">
+                <a:solidFill>
+                  <a:srgbClr val="E74C3C"/>
+                </a:solidFill>
+                <a:latin typeface="IPAGothic"/>
+              </a:rPr>
+              <a:t>7名</a:t>
+            </a:r>
+          </a:p>
+        </p:txBody>
+      </p:sp>
+      <p:sp>
+        <p:nvSpPr>
+          <p:cNvPr id="43" name="Rectangle 42"/>
+          <p:cNvSpPr/>
+          <p:nvPr/>
+        </p:nvSpPr>
+        <p:spPr>
+          <a:xfrm>
+            <a:off x="5989320" y="2788920"/>
+            <a:ext cx="1097280" cy="777240"/>
+          </a:xfrm>
+          <a:prstGeom prst="rect">
+            <a:avLst/>
+          </a:prstGeom>
+          <a:solidFill>
+            <a:srgbClr val="FFFFFF"/>
+          </a:solidFill>
+          <a:ln>
+            <a:noFill/>
+          </a:ln>
+        </p:spPr>
+        <p:style>
+          <a:lnRef idx="1">
+            <a:schemeClr val="accent1"/>
+          </a:lnRef>
+          <a:fillRef idx="3">
+            <a:schemeClr val="accent1"/>
+          </a:fillRef>
+          <a:effectRef idx="2">
+            <a:schemeClr val="accent1"/>
+          </a:effectRef>
+          <a:fontRef idx="minor">
+            <a:schemeClr val="lt1"/>
+          </a:fontRef>
+        </p:style>
+        <p:txBody>
+          <a:bodyPr rtlCol="0" anchor="ctr"/>
+          <a:lstStyle/>
+          <a:p>
+            <a:pPr algn="ctr"/>
+          </a:p>
+        </p:txBody>
+      </p:sp>
+      <p:sp>
+        <p:nvSpPr>
+          <p:cNvPr id="44" name="TextBox 43"/>
+          <p:cNvSpPr txBox="1"/>
+          <p:nvPr/>
+        </p:nvSpPr>
+        <p:spPr>
+          <a:xfrm>
+            <a:off x="6035040" y="2834639"/>
+            <a:ext cx="1024127" cy="694944"/>
+          </a:xfrm>
+          <a:prstGeom prst="rect">
+            <a:avLst/>
+          </a:prstGeom>
+          <a:noFill/>
+        </p:spPr>
+        <p:txBody>
+          <a:bodyPr wrap="square">
+            <a:spAutoFit/>
+          </a:bodyPr>
+          <a:lstStyle/>
+          <a:p>
+            <a:pPr algn="ctr"/>
+            <a:r>
+              <a:rPr sz="1400" b="0">
+                <a:solidFill>
+                  <a:srgbClr val="95A5A6"/>
+                </a:solidFill>
+                <a:latin typeface="IPAGothic"/>
+              </a:rPr>
+              <a:t>2名</a:t>
+            </a:r>
+          </a:p>
+        </p:txBody>
+      </p:sp>
+      <p:sp>
+        <p:nvSpPr>
+          <p:cNvPr id="45" name="Rectangle 44"/>
+          <p:cNvSpPr/>
+          <p:nvPr/>
+        </p:nvSpPr>
+        <p:spPr>
+          <a:xfrm>
+            <a:off x="7086600" y="2788920"/>
+            <a:ext cx="1005840" cy="777240"/>
+          </a:xfrm>
+          <a:prstGeom prst="rect">
+            <a:avLst/>
+          </a:prstGeom>
+          <a:solidFill>
+            <a:srgbClr val="FFFFFF"/>
+          </a:solidFill>
+          <a:ln>
+            <a:noFill/>
+          </a:ln>
+        </p:spPr>
+        <p:style>
+          <a:lnRef idx="1">
+            <a:schemeClr val="accent1"/>
+          </a:lnRef>
+          <a:fillRef idx="3">
+            <a:schemeClr val="accent1"/>
+          </a:fillRef>
+          <a:effectRef idx="2">
+            <a:schemeClr val="accent1"/>
+          </a:effectRef>
+          <a:fontRef idx="minor">
+            <a:schemeClr val="lt1"/>
+          </a:fontRef>
+        </p:style>
+        <p:txBody>
+          <a:bodyPr rtlCol="0" anchor="ctr"/>
+          <a:lstStyle/>
+          <a:p>
+            <a:pPr algn="ctr"/>
+          </a:p>
+        </p:txBody>
+      </p:sp>
+      <p:sp>
+        <p:nvSpPr>
+          <p:cNvPr id="46" name="TextBox 45"/>
+          <p:cNvSpPr txBox="1"/>
+          <p:nvPr/>
+        </p:nvSpPr>
+        <p:spPr>
+          <a:xfrm>
+            <a:off x="7132320" y="2834639"/>
+            <a:ext cx="932688" cy="694944"/>
+          </a:xfrm>
+          <a:prstGeom prst="rect">
+            <a:avLst/>
+          </a:prstGeom>
+          <a:noFill/>
+        </p:spPr>
+        <p:txBody>
+          <a:bodyPr wrap="square">
+            <a:spAutoFit/>
+          </a:bodyPr>
+          <a:lstStyle/>
+          <a:p>
+            <a:pPr algn="ctr"/>
+            <a:r>
+              <a:rPr sz="1400" b="0">
+                <a:solidFill>
+                  <a:srgbClr val="4A90D9"/>
+                </a:solidFill>
+                <a:latin typeface="IPAGothic"/>
+              </a:rPr>
+              <a:t>7名</a:t>
+            </a:r>
+          </a:p>
+        </p:txBody>
+      </p:sp>
+      <p:sp>
+        <p:nvSpPr>
+          <p:cNvPr id="47" name="Rectangle 46"/>
+          <p:cNvSpPr/>
+          <p:nvPr/>
+        </p:nvSpPr>
+        <p:spPr>
+          <a:xfrm>
+            <a:off x="8092440" y="2788920"/>
+            <a:ext cx="1280160" cy="777240"/>
+          </a:xfrm>
+          <a:prstGeom prst="rect">
+            <a:avLst/>
+          </a:prstGeom>
+          <a:solidFill>
+            <a:srgbClr val="FFFFFF"/>
+          </a:solidFill>
+          <a:ln>
+            <a:noFill/>
+          </a:ln>
+        </p:spPr>
+        <p:style>
+          <a:lnRef idx="1">
+            <a:schemeClr val="accent1"/>
+          </a:lnRef>
+          <a:fillRef idx="3">
+            <a:schemeClr val="accent1"/>
+          </a:fillRef>
+          <a:effectRef idx="2">
+            <a:schemeClr val="accent1"/>
+          </a:effectRef>
+          <a:fontRef idx="minor">
+            <a:schemeClr val="lt1"/>
+          </a:fontRef>
+        </p:style>
+        <p:txBody>
+          <a:bodyPr rtlCol="0" anchor="ctr"/>
+          <a:lstStyle/>
+          <a:p>
+            <a:pPr algn="ctr"/>
+          </a:p>
+        </p:txBody>
+      </p:sp>
+      <p:sp>
+        <p:nvSpPr>
+          <p:cNvPr id="48" name="TextBox 47"/>
+          <p:cNvSpPr txBox="1"/>
+          <p:nvPr/>
+        </p:nvSpPr>
+        <p:spPr>
+          <a:xfrm>
+            <a:off x="8138160" y="2834639"/>
+            <a:ext cx="1207007" cy="694944"/>
+          </a:xfrm>
+          <a:prstGeom prst="rect">
+            <a:avLst/>
+          </a:prstGeom>
+          <a:noFill/>
+        </p:spPr>
+        <p:txBody>
+          <a:bodyPr wrap="square">
+            <a:spAutoFit/>
+          </a:bodyPr>
+          <a:lstStyle/>
+          <a:p>
+            <a:pPr algn="ctr"/>
+            <a:r>
+              <a:rPr sz="1400" b="0">
+                <a:solidFill>
+                  <a:srgbClr val="999999"/>
+                </a:solidFill>
+                <a:latin typeface="IPAGothic"/>
+              </a:rPr>
+              <a:t>32名</a:t>
+            </a:r>
+          </a:p>
+        </p:txBody>
+      </p:sp>
+      <p:sp>
+        <p:nvSpPr>
+          <p:cNvPr id="49" name="Rectangle 48"/>
+          <p:cNvSpPr/>
+          <p:nvPr/>
+        </p:nvSpPr>
+        <p:spPr>
+          <a:xfrm>
+            <a:off x="320040" y="3611880"/>
+            <a:ext cx="2011680" cy="777240"/>
+          </a:xfrm>
+          <a:prstGeom prst="rect">
+            <a:avLst/>
+          </a:prstGeom>
+          <a:solidFill>
+            <a:srgbClr val="E8F0F8"/>
+          </a:solidFill>
+          <a:ln>
+            <a:noFill/>
+          </a:ln>
+        </p:spPr>
+        <p:style>
+          <a:lnRef idx="1">
+            <a:schemeClr val="accent1"/>
+          </a:lnRef>
+          <a:fillRef idx="3">
+            <a:schemeClr val="accent1"/>
+          </a:fillRef>
+          <a:effectRef idx="2">
+            <a:schemeClr val="accent1"/>
+          </a:effectRef>
+          <a:fontRef idx="minor">
+            <a:schemeClr val="lt1"/>
+          </a:fontRef>
+        </p:style>
+        <p:txBody>
+          <a:bodyPr rtlCol="0" anchor="ctr"/>
+          <a:lstStyle/>
+          <a:p>
+            <a:pPr algn="ctr"/>
+          </a:p>
+        </p:txBody>
+      </p:sp>
+      <p:sp>
+        <p:nvSpPr>
+          <p:cNvPr id="50" name="TextBox 49"/>
+          <p:cNvSpPr txBox="1"/>
+          <p:nvPr/>
+        </p:nvSpPr>
+        <p:spPr>
+          <a:xfrm>
+            <a:off x="365759" y="3657600"/>
+            <a:ext cx="1938528" cy="694944"/>
+          </a:xfrm>
+          <a:prstGeom prst="rect">
+            <a:avLst/>
+          </a:prstGeom>
+          <a:noFill/>
+        </p:spPr>
+        <p:txBody>
+          <a:bodyPr wrap="square">
+            <a:spAutoFit/>
+          </a:bodyPr>
+          <a:lstStyle/>
+          <a:p>
+            <a:pPr algn="ctr"/>
+            <a:r>
+              <a:rPr sz="1400" b="0">
+                <a:solidFill>
+                  <a:srgbClr val="1E3A5F"/>
+                </a:solidFill>
+                <a:latin typeface="IPAGothic"/>
+              </a:rPr>
+              <a:t>最終選考</a:t>
+            </a:r>
+          </a:p>
+        </p:txBody>
+      </p:sp>
+      <p:sp>
+        <p:nvSpPr>
+          <p:cNvPr id="51" name="Rectangle 50"/>
+          <p:cNvSpPr/>
+          <p:nvPr/>
+        </p:nvSpPr>
+        <p:spPr>
+          <a:xfrm>
+            <a:off x="2331720" y="3611880"/>
+            <a:ext cx="1188720" cy="777240"/>
+          </a:xfrm>
+          <a:prstGeom prst="rect">
+            <a:avLst/>
+          </a:prstGeom>
+          <a:solidFill>
+            <a:srgbClr val="E8F0F8"/>
+          </a:solidFill>
+          <a:ln>
+            <a:noFill/>
+          </a:ln>
+        </p:spPr>
+        <p:style>
+          <a:lnRef idx="1">
+            <a:schemeClr val="accent1"/>
+          </a:lnRef>
+          <a:fillRef idx="3">
+            <a:schemeClr val="accent1"/>
+          </a:fillRef>
+          <a:effectRef idx="2">
+            <a:schemeClr val="accent1"/>
+          </a:effectRef>
+          <a:fontRef idx="minor">
+            <a:schemeClr val="lt1"/>
+          </a:fontRef>
+        </p:style>
+        <p:txBody>
+          <a:bodyPr rtlCol="0" anchor="ctr"/>
+          <a:lstStyle/>
+          <a:p>
+            <a:pPr algn="ctr"/>
+          </a:p>
+        </p:txBody>
+      </p:sp>
+      <p:sp>
+        <p:nvSpPr>
+          <p:cNvPr id="52" name="TextBox 51"/>
+          <p:cNvSpPr txBox="1"/>
+          <p:nvPr/>
+        </p:nvSpPr>
+        <p:spPr>
+          <a:xfrm>
+            <a:off x="2377440" y="3657600"/>
+            <a:ext cx="1115568" cy="694944"/>
+          </a:xfrm>
+          <a:prstGeom prst="rect">
+            <a:avLst/>
+          </a:prstGeom>
+          <a:noFill/>
+        </p:spPr>
+        <p:txBody>
+          <a:bodyPr wrap="square">
+            <a:spAutoFit/>
+          </a:bodyPr>
+          <a:lstStyle/>
+          <a:p>
+            <a:pPr algn="ctr"/>
+            <a:r>
+              <a:rPr sz="1500" b="1">
+                <a:solidFill>
+                  <a:srgbClr val="1E3A5F"/>
+                </a:solidFill>
+                <a:latin typeface="IPAGothic"/>
+              </a:rPr>
+              <a:t>11名</a:t>
+            </a:r>
+          </a:p>
+        </p:txBody>
+      </p:sp>
+      <p:sp>
+        <p:nvSpPr>
+          <p:cNvPr id="53" name="Rectangle 52"/>
+          <p:cNvSpPr/>
+          <p:nvPr/>
+        </p:nvSpPr>
+        <p:spPr>
+          <a:xfrm>
+            <a:off x="3520440" y="3611880"/>
+            <a:ext cx="1371600" cy="777240"/>
+          </a:xfrm>
+          <a:prstGeom prst="rect">
+            <a:avLst/>
+          </a:prstGeom>
+          <a:solidFill>
+            <a:srgbClr val="E8F0F8"/>
+          </a:solidFill>
+          <a:ln>
+            <a:noFill/>
+          </a:ln>
+        </p:spPr>
+        <p:style>
+          <a:lnRef idx="1">
+            <a:schemeClr val="accent1"/>
+          </a:lnRef>
+          <a:fillRef idx="3">
+            <a:schemeClr val="accent1"/>
+          </a:fillRef>
+          <a:effectRef idx="2">
+            <a:schemeClr val="accent1"/>
+          </a:effectRef>
+          <a:fontRef idx="minor">
+            <a:schemeClr val="lt1"/>
+          </a:fontRef>
+        </p:style>
+        <p:txBody>
+          <a:bodyPr rtlCol="0" anchor="ctr"/>
+          <a:lstStyle/>
+          <a:p>
+            <a:pPr algn="ctr"/>
+          </a:p>
+        </p:txBody>
+      </p:sp>
+      <p:sp>
+        <p:nvSpPr>
+          <p:cNvPr id="54" name="TextBox 53"/>
+          <p:cNvSpPr txBox="1"/>
+          <p:nvPr/>
+        </p:nvSpPr>
+        <p:spPr>
+          <a:xfrm>
+            <a:off x="3566160" y="3657600"/>
+            <a:ext cx="1298448" cy="694944"/>
+          </a:xfrm>
+          <a:prstGeom prst="rect">
+            <a:avLst/>
+          </a:prstGeom>
+          <a:noFill/>
+        </p:spPr>
+        <p:txBody>
+          <a:bodyPr wrap="square">
+            <a:spAutoFit/>
+          </a:bodyPr>
+          <a:lstStyle/>
+          <a:p>
+            <a:pPr algn="ctr"/>
+            <a:r>
+              <a:rPr sz="1500" b="1">
+                <a:solidFill>
+                  <a:srgbClr val="27AE60"/>
+                </a:solidFill>
+                <a:latin typeface="IPAGothic"/>
+              </a:rPr>
+              <a:t>1名
+(9%)</a:t>
+            </a:r>
+          </a:p>
+        </p:txBody>
+      </p:sp>
+      <p:sp>
+        <p:nvSpPr>
+          <p:cNvPr id="55" name="Rectangle 54"/>
+          <p:cNvSpPr/>
+          <p:nvPr/>
+        </p:nvSpPr>
+        <p:spPr>
+          <a:xfrm>
+            <a:off x="4892040" y="3611880"/>
+            <a:ext cx="1097280" cy="777240"/>
+          </a:xfrm>
+          <a:prstGeom prst="rect">
+            <a:avLst/>
+          </a:prstGeom>
+          <a:solidFill>
+            <a:srgbClr val="E8F0F8"/>
+          </a:solidFill>
+          <a:ln>
+            <a:noFill/>
+          </a:ln>
+        </p:spPr>
+        <p:style>
+          <a:lnRef idx="1">
+            <a:schemeClr val="accent1"/>
+          </a:lnRef>
+          <a:fillRef idx="3">
+            <a:schemeClr val="accent1"/>
+          </a:fillRef>
+          <a:effectRef idx="2">
+            <a:schemeClr val="accent1"/>
+          </a:effectRef>
+          <a:fontRef idx="minor">
+            <a:schemeClr val="lt1"/>
+          </a:fontRef>
+        </p:style>
+        <p:txBody>
+          <a:bodyPr rtlCol="0" anchor="ctr"/>
+          <a:lstStyle/>
+          <a:p>
+            <a:pPr algn="ctr"/>
+          </a:p>
+        </p:txBody>
+      </p:sp>
+      <p:sp>
+        <p:nvSpPr>
+          <p:cNvPr id="56" name="TextBox 55"/>
+          <p:cNvSpPr txBox="1"/>
+          <p:nvPr/>
+        </p:nvSpPr>
+        <p:spPr>
+          <a:xfrm>
+            <a:off x="4937760" y="3657600"/>
+            <a:ext cx="1024127" cy="694944"/>
+          </a:xfrm>
+          <a:prstGeom prst="rect">
+            <a:avLst/>
+          </a:prstGeom>
+          <a:noFill/>
+        </p:spPr>
+        <p:txBody>
+          <a:bodyPr wrap="square">
+            <a:spAutoFit/>
+          </a:bodyPr>
+          <a:lstStyle/>
+          <a:p>
+            <a:pPr algn="ctr"/>
+            <a:r>
+              <a:rPr sz="1400" b="0">
+                <a:solidFill>
+                  <a:srgbClr val="E74C3C"/>
+                </a:solidFill>
+                <a:latin typeface="IPAGothic"/>
+              </a:rPr>
+              <a:t>3名</a:t>
+            </a:r>
+          </a:p>
+        </p:txBody>
+      </p:sp>
+      <p:sp>
+        <p:nvSpPr>
+          <p:cNvPr id="57" name="Rectangle 56"/>
+          <p:cNvSpPr/>
+          <p:nvPr/>
+        </p:nvSpPr>
+        <p:spPr>
+          <a:xfrm>
+            <a:off x="5989320" y="3611880"/>
+            <a:ext cx="1097280" cy="777240"/>
+          </a:xfrm>
+          <a:prstGeom prst="rect">
+            <a:avLst/>
+          </a:prstGeom>
+          <a:solidFill>
+            <a:srgbClr val="E8F0F8"/>
+          </a:solidFill>
+          <a:ln>
+            <a:noFill/>
+          </a:ln>
+        </p:spPr>
+        <p:style>
+          <a:lnRef idx="1">
+            <a:schemeClr val="accent1"/>
+          </a:lnRef>
+          <a:fillRef idx="3">
+            <a:schemeClr val="accent1"/>
+          </a:fillRef>
+          <a:effectRef idx="2">
+            <a:schemeClr val="accent1"/>
+          </a:effectRef>
+          <a:fontRef idx="minor">
+            <a:schemeClr val="lt1"/>
+          </a:fontRef>
+        </p:style>
+        <p:txBody>
+          <a:bodyPr rtlCol="0" anchor="ctr"/>
+          <a:lstStyle/>
+          <a:p>
+            <a:pPr algn="ctr"/>
+          </a:p>
+        </p:txBody>
+      </p:sp>
+      <p:sp>
+        <p:nvSpPr>
+          <p:cNvPr id="58" name="TextBox 57"/>
+          <p:cNvSpPr txBox="1"/>
+          <p:nvPr/>
+        </p:nvSpPr>
+        <p:spPr>
+          <a:xfrm>
+            <a:off x="6035040" y="3657600"/>
+            <a:ext cx="1024127" cy="694944"/>
+          </a:xfrm>
+          <a:prstGeom prst="rect">
+            <a:avLst/>
+          </a:prstGeom>
+          <a:noFill/>
+        </p:spPr>
+        <p:txBody>
+          <a:bodyPr wrap="square">
+            <a:spAutoFit/>
+          </a:bodyPr>
+          <a:lstStyle/>
+          <a:p>
+            <a:pPr algn="ctr"/>
+            <a:r>
+              <a:rPr sz="1400" b="0">
+                <a:solidFill>
+                  <a:srgbClr val="95A5A6"/>
+                </a:solidFill>
+                <a:latin typeface="IPAGothic"/>
+              </a:rPr>
+              <a:t>3名</a:t>
+            </a:r>
+          </a:p>
+        </p:txBody>
+      </p:sp>
+      <p:sp>
+        <p:nvSpPr>
+          <p:cNvPr id="59" name="Rectangle 58"/>
+          <p:cNvSpPr/>
+          <p:nvPr/>
+        </p:nvSpPr>
+        <p:spPr>
+          <a:xfrm>
+            <a:off x="7086600" y="3611880"/>
+            <a:ext cx="1005840" cy="777240"/>
+          </a:xfrm>
+          <a:prstGeom prst="rect">
+            <a:avLst/>
+          </a:prstGeom>
+          <a:solidFill>
+            <a:srgbClr val="E8F0F8"/>
+          </a:solidFill>
+          <a:ln>
+            <a:noFill/>
+          </a:ln>
+        </p:spPr>
+        <p:style>
+          <a:lnRef idx="1">
+            <a:schemeClr val="accent1"/>
+          </a:lnRef>
+          <a:fillRef idx="3">
+            <a:schemeClr val="accent1"/>
+          </a:fillRef>
+          <a:effectRef idx="2">
+            <a:schemeClr val="accent1"/>
+          </a:effectRef>
+          <a:fontRef idx="minor">
+            <a:schemeClr val="lt1"/>
+          </a:fontRef>
+        </p:style>
+        <p:txBody>
+          <a:bodyPr rtlCol="0" anchor="ctr"/>
+          <a:lstStyle/>
+          <a:p>
+            <a:pPr algn="ctr"/>
+          </a:p>
+        </p:txBody>
+      </p:sp>
+      <p:sp>
+        <p:nvSpPr>
+          <p:cNvPr id="60" name="TextBox 59"/>
+          <p:cNvSpPr txBox="1"/>
+          <p:nvPr/>
+        </p:nvSpPr>
+        <p:spPr>
+          <a:xfrm>
+            <a:off x="7132320" y="3657600"/>
+            <a:ext cx="932688" cy="694944"/>
+          </a:xfrm>
+          <a:prstGeom prst="rect">
+            <a:avLst/>
+          </a:prstGeom>
+          <a:noFill/>
+        </p:spPr>
+        <p:txBody>
+          <a:bodyPr wrap="square">
+            <a:spAutoFit/>
+          </a:bodyPr>
+          <a:lstStyle/>
+          <a:p>
+            <a:pPr algn="ctr"/>
+            <a:r>
+              <a:rPr sz="1400" b="0">
+                <a:solidFill>
+                  <a:srgbClr val="4A90D9"/>
+                </a:solidFill>
+                <a:latin typeface="IPAGothic"/>
+              </a:rPr>
+              <a:t>4名</a:t>
+            </a:r>
+          </a:p>
+        </p:txBody>
+      </p:sp>
+      <p:sp>
+        <p:nvSpPr>
+          <p:cNvPr id="61" name="Rectangle 60"/>
+          <p:cNvSpPr/>
+          <p:nvPr/>
+        </p:nvSpPr>
+        <p:spPr>
+          <a:xfrm>
+            <a:off x="8092440" y="3611880"/>
+            <a:ext cx="1280160" cy="777240"/>
+          </a:xfrm>
+          <a:prstGeom prst="rect">
+            <a:avLst/>
+          </a:prstGeom>
+          <a:solidFill>
+            <a:srgbClr val="E8F0F8"/>
+          </a:solidFill>
+          <a:ln>
+            <a:noFill/>
+          </a:ln>
+        </p:spPr>
+        <p:style>
+          <a:lnRef idx="1">
+            <a:schemeClr val="accent1"/>
+          </a:lnRef>
+          <a:fillRef idx="3">
+            <a:schemeClr val="accent1"/>
+          </a:fillRef>
+          <a:effectRef idx="2">
+            <a:schemeClr val="accent1"/>
+          </a:effectRef>
+          <a:fontRef idx="minor">
+            <a:schemeClr val="lt1"/>
+          </a:fontRef>
+        </p:style>
+        <p:txBody>
+          <a:bodyPr rtlCol="0" anchor="ctr"/>
+          <a:lstStyle/>
+          <a:p>
+            <a:pPr algn="ctr"/>
+          </a:p>
+        </p:txBody>
+      </p:sp>
+      <p:sp>
+        <p:nvSpPr>
+          <p:cNvPr id="62" name="TextBox 61"/>
+          <p:cNvSpPr txBox="1"/>
+          <p:nvPr/>
+        </p:nvSpPr>
+        <p:spPr>
+          <a:xfrm>
+            <a:off x="8138160" y="3657600"/>
+            <a:ext cx="1207007" cy="694944"/>
+          </a:xfrm>
+          <a:prstGeom prst="rect">
+            <a:avLst/>
+          </a:prstGeom>
+          <a:noFill/>
+        </p:spPr>
+        <p:txBody>
+          <a:bodyPr wrap="square">
+            <a:spAutoFit/>
+          </a:bodyPr>
+          <a:lstStyle/>
+          <a:p>
+            <a:pPr algn="ctr"/>
+            <a:r>
+              <a:rPr sz="1400" b="0">
+                <a:solidFill>
+                  <a:srgbClr val="999999"/>
+                </a:solidFill>
+                <a:latin typeface="IPAGothic"/>
+              </a:rPr>
+              <a:t>48名</a:t>
+            </a:r>
+          </a:p>
+        </p:txBody>
+      </p:sp>
+      <p:sp>
+        <p:nvSpPr>
+          <p:cNvPr id="63" name="Rectangle 62"/>
+          <p:cNvSpPr/>
+          <p:nvPr/>
+        </p:nvSpPr>
+        <p:spPr>
+          <a:xfrm>
+            <a:off x="320040" y="1911095"/>
+            <a:ext cx="11521440" cy="18288"/>
+          </a:xfrm>
+          <a:prstGeom prst="rect">
+            <a:avLst/>
+          </a:prstGeom>
+          <a:solidFill>
+            <a:srgbClr val="CCCCCC"/>
+          </a:solidFill>
+          <a:ln>
+            <a:noFill/>
+          </a:ln>
+        </p:spPr>
+        <p:style>
+          <a:lnRef idx="1">
+            <a:schemeClr val="accent1"/>
+          </a:lnRef>
+          <a:fillRef idx="3">
+            <a:schemeClr val="accent1"/>
+          </a:fillRef>
+          <a:effectRef idx="2">
+            <a:schemeClr val="accent1"/>
+          </a:effectRef>
+          <a:fontRef idx="minor">
+            <a:schemeClr val="lt1"/>
+          </a:fontRef>
+        </p:style>
+        <p:txBody>
+          <a:bodyPr rtlCol="0" anchor="ctr"/>
+          <a:lstStyle/>
+          <a:p>
+            <a:pPr algn="ctr"/>
+          </a:p>
+        </p:txBody>
+      </p:sp>
+      <p:sp>
+        <p:nvSpPr>
+          <p:cNvPr id="64" name="Rectangle 63"/>
+          <p:cNvSpPr/>
+          <p:nvPr/>
+        </p:nvSpPr>
+        <p:spPr>
+          <a:xfrm>
+            <a:off x="320040" y="2734056"/>
+            <a:ext cx="11521440" cy="18288"/>
+          </a:xfrm>
+          <a:prstGeom prst="rect">
+            <a:avLst/>
+          </a:prstGeom>
+          <a:solidFill>
+            <a:srgbClr val="CCCCCC"/>
+          </a:solidFill>
+          <a:ln>
+            <a:noFill/>
+          </a:ln>
+        </p:spPr>
+        <p:style>
+          <a:lnRef idx="1">
+            <a:schemeClr val="accent1"/>
+          </a:lnRef>
+          <a:fillRef idx="3">
+            <a:schemeClr val="accent1"/>
+          </a:fillRef>
+          <a:effectRef idx="2">
+            <a:schemeClr val="accent1"/>
+          </a:effectRef>
+          <a:fontRef idx="minor">
+            <a:schemeClr val="lt1"/>
+          </a:fontRef>
+        </p:style>
+        <p:txBody>
+          <a:bodyPr rtlCol="0" anchor="ctr"/>
+          <a:lstStyle/>
+          <a:p>
+            <a:pPr algn="ctr"/>
+          </a:p>
+        </p:txBody>
+      </p:sp>
+      <p:sp>
+        <p:nvSpPr>
+          <p:cNvPr id="65" name="Rectangle 64"/>
+          <p:cNvSpPr/>
+          <p:nvPr/>
+        </p:nvSpPr>
+        <p:spPr>
+          <a:xfrm>
+            <a:off x="320040" y="3557015"/>
+            <a:ext cx="11521440" cy="18288"/>
+          </a:xfrm>
+          <a:prstGeom prst="rect">
+            <a:avLst/>
+          </a:prstGeom>
+          <a:solidFill>
+            <a:srgbClr val="CCCCCC"/>
+          </a:solidFill>
+          <a:ln>
+            <a:noFill/>
+          </a:ln>
+        </p:spPr>
+        <p:style>
+          <a:lnRef idx="1">
+            <a:schemeClr val="accent1"/>
+          </a:lnRef>
+          <a:fillRef idx="3">
+            <a:schemeClr val="accent1"/>
+          </a:fillRef>
+          <a:effectRef idx="2">
+            <a:schemeClr val="accent1"/>
+          </a:effectRef>
+          <a:fontRef idx="minor">
+            <a:schemeClr val="lt1"/>
+          </a:fontRef>
+        </p:style>
+        <p:txBody>
+          <a:bodyPr rtlCol="0" anchor="ctr"/>
+          <a:lstStyle/>
+          <a:p>
+            <a:pPr algn="ctr"/>
+          </a:p>
+        </p:txBody>
+      </p:sp>
+      <p:sp>
+        <p:nvSpPr>
+          <p:cNvPr id="66" name="Rectangle 65"/>
+          <p:cNvSpPr/>
+          <p:nvPr/>
+        </p:nvSpPr>
+        <p:spPr>
+          <a:xfrm>
+            <a:off x="320040" y="4379976"/>
+            <a:ext cx="11521440" cy="18288"/>
+          </a:xfrm>
+          <a:prstGeom prst="rect">
+            <a:avLst/>
+          </a:prstGeom>
+          <a:solidFill>
+            <a:srgbClr val="CCCCCC"/>
+          </a:solidFill>
+          <a:ln>
+            <a:noFill/>
+          </a:ln>
+        </p:spPr>
+        <p:style>
+          <a:lnRef idx="1">
+            <a:schemeClr val="accent1"/>
+          </a:lnRef>
+          <a:fillRef idx="3">
+            <a:schemeClr val="accent1"/>
+          </a:fillRef>
+          <a:effectRef idx="2">
+            <a:schemeClr val="accent1"/>
+          </a:effectRef>
+          <a:fontRef idx="minor">
+            <a:schemeClr val="lt1"/>
+          </a:fontRef>
+        </p:style>
+        <p:txBody>
+          <a:bodyPr rtlCol="0" anchor="ctr"/>
+          <a:lstStyle/>
+          <a:p>
+            <a:pPr algn="ctr"/>
+          </a:p>
+        </p:txBody>
+      </p:sp>
+      <p:sp>
+        <p:nvSpPr>
+          <p:cNvPr id="67" name="Rectangle 66"/>
+          <p:cNvSpPr/>
+          <p:nvPr/>
+        </p:nvSpPr>
+        <p:spPr>
+          <a:xfrm>
+            <a:off x="365760" y="4663440"/>
+            <a:ext cx="201168" cy="201168"/>
+          </a:xfrm>
+          <a:prstGeom prst="rect">
+            <a:avLst/>
+          </a:prstGeom>
+          <a:solidFill>
+            <a:srgbClr val="27AE60"/>
+          </a:solidFill>
+          <a:ln>
+            <a:noFill/>
+          </a:ln>
+        </p:spPr>
+        <p:style>
+          <a:lnRef idx="1">
+            <a:schemeClr val="accent1"/>
+          </a:lnRef>
+          <a:fillRef idx="3">
+            <a:schemeClr val="accent1"/>
+          </a:fillRef>
+          <a:effectRef idx="2">
+            <a:schemeClr val="accent1"/>
+          </a:effectRef>
+          <a:fontRef idx="minor">
+            <a:schemeClr val="lt1"/>
+          </a:fontRef>
+        </p:style>
+        <p:txBody>
+          <a:bodyPr rtlCol="0" anchor="ctr"/>
+          <a:lstStyle/>
+          <a:p>
+            <a:pPr algn="ctr"/>
+          </a:p>
+        </p:txBody>
+      </p:sp>
+      <p:sp>
+        <p:nvSpPr>
+          <p:cNvPr id="68" name="TextBox 67"/>
+          <p:cNvSpPr txBox="1"/>
+          <p:nvPr/>
+        </p:nvSpPr>
+        <p:spPr>
+          <a:xfrm>
+            <a:off x="612648" y="4645152"/>
+            <a:ext cx="1371600" cy="256032"/>
+          </a:xfrm>
+          <a:prstGeom prst="rect">
+            <a:avLst/>
+          </a:prstGeom>
+          <a:noFill/>
+        </p:spPr>
+        <p:txBody>
+          <a:bodyPr wrap="square">
+            <a:spAutoFit/>
+          </a:bodyPr>
+          <a:lstStyle/>
+          <a:p>
             <a:pPr algn="l"/>
             <a:r>
-              <a:rPr sz="1300" b="0">
+              <a:rPr sz="1200" b="0">
                 <a:solidFill>
                   <a:srgbClr val="4A4A4A"/>
                 </a:solidFill>
                 <a:latin typeface="IPAGothic"/>
               </a:rPr>
-              <a:t>応募者数</a:t>
-            </a:r>
-          </a:p>
-        </p:txBody>
-      </p:sp>
-      <p:sp>
-        <p:nvSpPr>
-          <p:cNvPr id="10" name="TextBox 9"/>
+              <a:t>通過</a:t>
+            </a:r>
+          </a:p>
+        </p:txBody>
+      </p:sp>
+      <p:sp>
+        <p:nvSpPr>
+          <p:cNvPr id="69" name="Rectangle 68"/>
+          <p:cNvSpPr/>
+          <p:nvPr/>
+        </p:nvSpPr>
+        <p:spPr>
+          <a:xfrm>
+            <a:off x="1920240" y="4663440"/>
+            <a:ext cx="201168" cy="201168"/>
+          </a:xfrm>
+          <a:prstGeom prst="rect">
+            <a:avLst/>
+          </a:prstGeom>
+          <a:solidFill>
+            <a:srgbClr val="E74C3C"/>
+          </a:solidFill>
+          <a:ln>
+            <a:noFill/>
+          </a:ln>
+        </p:spPr>
+        <p:style>
+          <a:lnRef idx="1">
+            <a:schemeClr val="accent1"/>
+          </a:lnRef>
+          <a:fillRef idx="3">
+            <a:schemeClr val="accent1"/>
+          </a:fillRef>
+          <a:effectRef idx="2">
+            <a:schemeClr val="accent1"/>
+          </a:effectRef>
+          <a:fontRef idx="minor">
+            <a:schemeClr val="lt1"/>
+          </a:fontRef>
+        </p:style>
+        <p:txBody>
+          <a:bodyPr rtlCol="0" anchor="ctr"/>
+          <a:lstStyle/>
+          <a:p>
+            <a:pPr algn="ctr"/>
+          </a:p>
+        </p:txBody>
+      </p:sp>
+      <p:sp>
+        <p:nvSpPr>
+          <p:cNvPr id="70" name="TextBox 69"/>
           <p:cNvSpPr txBox="1"/>
           <p:nvPr/>
         </p:nvSpPr>
         <p:spPr>
           <a:xfrm>
-            <a:off x="530352" y="1874519"/>
-            <a:ext cx="1737360" cy="822960"/>
+            <a:off x="2167128" y="4645152"/>
+            <a:ext cx="1371600" cy="256032"/>
           </a:xfrm>
           <a:prstGeom prst="rect">
             <a:avLst/>
@@ -4108,103 +6470,33 @@
           <a:p>
             <a:pPr algn="l"/>
             <a:r>
-              <a:rPr sz="4200" b="1">
-                <a:solidFill>
-                  <a:srgbClr val="1E3A5F"/>
-                </a:solidFill>
-                <a:latin typeface="IPAGothic"/>
-              </a:rPr>
-              <a:t>59</a:t>
-            </a:r>
-          </a:p>
-        </p:txBody>
-      </p:sp>
-      <p:sp>
-        <p:nvSpPr>
-          <p:cNvPr id="11" name="TextBox 10"/>
-          <p:cNvSpPr txBox="1"/>
-          <p:nvPr/>
-        </p:nvSpPr>
-        <p:spPr>
-          <a:xfrm>
-            <a:off x="1993392" y="2286000"/>
-            <a:ext cx="731520" cy="365760"/>
-          </a:xfrm>
-          <a:prstGeom prst="rect">
-            <a:avLst/>
-          </a:prstGeom>
-          <a:noFill/>
-        </p:spPr>
-        <p:txBody>
-          <a:bodyPr wrap="square">
-            <a:spAutoFit/>
-          </a:bodyPr>
-          <a:lstStyle/>
-          <a:p>
-            <a:pPr algn="l"/>
-            <a:r>
-              <a:rPr sz="1600" b="0">
+              <a:rPr sz="1200" b="0">
                 <a:solidFill>
                   <a:srgbClr val="4A4A4A"/>
                 </a:solidFill>
                 <a:latin typeface="IPAGothic"/>
               </a:rPr>
-              <a:t>名</a:t>
-            </a:r>
-          </a:p>
-        </p:txBody>
-      </p:sp>
-      <p:sp>
-        <p:nvSpPr>
-          <p:cNvPr id="12" name="TextBox 11"/>
-          <p:cNvSpPr txBox="1"/>
-          <p:nvPr/>
-        </p:nvSpPr>
-        <p:spPr>
-          <a:xfrm>
-            <a:off x="530352" y="2834640"/>
-            <a:ext cx="2468880" cy="365760"/>
-          </a:xfrm>
-          <a:prstGeom prst="rect">
-            <a:avLst/>
-          </a:prstGeom>
-          <a:noFill/>
-        </p:spPr>
-        <p:txBody>
-          <a:bodyPr wrap="square">
-            <a:spAutoFit/>
-          </a:bodyPr>
-          <a:lstStyle/>
-          <a:p>
-            <a:pPr algn="l"/>
-            <a:r>
-              <a:rPr sz="1300" b="0">
-                <a:solidFill>
-                  <a:srgbClr val="7F7F7F"/>
-                </a:solidFill>
-                <a:latin typeface="IPAGothic"/>
-              </a:rPr>
-              <a:t>上位校全体</a:t>
-            </a:r>
-          </a:p>
-        </p:txBody>
-      </p:sp>
-      <p:sp>
-        <p:nvSpPr>
-          <p:cNvPr id="13" name="Rectangle 12"/>
+              <a:t>辞退</a:t>
+            </a:r>
+          </a:p>
+        </p:txBody>
+      </p:sp>
+      <p:sp>
+        <p:nvSpPr>
+          <p:cNvPr id="71" name="Rectangle 70"/>
           <p:cNvSpPr/>
           <p:nvPr/>
         </p:nvSpPr>
         <p:spPr>
           <a:xfrm>
-            <a:off x="3291840" y="1261872"/>
-            <a:ext cx="2743200" cy="2057400"/>
-          </a:xfrm>
-          <a:prstGeom prst="rect">
-            <a:avLst/>
-          </a:prstGeom>
-          <a:solidFill>
-            <a:srgbClr val="FFFFFF"/>
+            <a:off x="3474720" y="4663440"/>
+            <a:ext cx="201168" cy="201168"/>
+          </a:xfrm>
+          <a:prstGeom prst="rect">
+            <a:avLst/>
+          </a:prstGeom>
+          <a:solidFill>
+            <a:srgbClr val="95A5A6"/>
           </a:solidFill>
           <a:ln>
             <a:noFill/>
@@ -4234,14 +6526,49 @@
       </p:sp>
       <p:sp>
         <p:nvSpPr>
-          <p:cNvPr id="14" name="Rectangle 13"/>
+          <p:cNvPr id="72" name="TextBox 71"/>
+          <p:cNvSpPr txBox="1"/>
+          <p:nvPr/>
+        </p:nvSpPr>
+        <p:spPr>
+          <a:xfrm>
+            <a:off x="3721608" y="4645152"/>
+            <a:ext cx="1371600" cy="256032"/>
+          </a:xfrm>
+          <a:prstGeom prst="rect">
+            <a:avLst/>
+          </a:prstGeom>
+          <a:noFill/>
+        </p:spPr>
+        <p:txBody>
+          <a:bodyPr wrap="square">
+            <a:spAutoFit/>
+          </a:bodyPr>
+          <a:lstStyle/>
+          <a:p>
+            <a:pPr algn="l"/>
+            <a:r>
+              <a:rPr sz="1200" b="0">
+                <a:solidFill>
+                  <a:srgbClr val="4A4A4A"/>
+                </a:solidFill>
+                <a:latin typeface="IPAGothic"/>
+              </a:rPr>
+              <a:t>不合格</a:t>
+            </a:r>
+          </a:p>
+        </p:txBody>
+      </p:sp>
+      <p:sp>
+        <p:nvSpPr>
+          <p:cNvPr id="73" name="Rectangle 72"/>
           <p:cNvSpPr/>
           <p:nvPr/>
         </p:nvSpPr>
         <p:spPr>
           <a:xfrm>
-            <a:off x="3291840" y="1261872"/>
-            <a:ext cx="64008" cy="2057400"/>
+            <a:off x="5029200" y="4663440"/>
+            <a:ext cx="201168" cy="201168"/>
           </a:xfrm>
           <a:prstGeom prst="rect">
             <a:avLst/>
@@ -4277,14 +6604,14 @@
       </p:sp>
       <p:sp>
         <p:nvSpPr>
-          <p:cNvPr id="15" name="TextBox 14"/>
+          <p:cNvPr id="74" name="TextBox 73"/>
           <p:cNvSpPr txBox="1"/>
           <p:nvPr/>
         </p:nvSpPr>
         <p:spPr>
           <a:xfrm>
-            <a:off x="3456432" y="1325880"/>
-            <a:ext cx="2468880" cy="594360"/>
+            <a:off x="5276088" y="4645152"/>
+            <a:ext cx="1371600" cy="256032"/>
           </a:xfrm>
           <a:prstGeom prst="rect">
             <a:avLst/>
@@ -4299,28 +6626,70 @@
           <a:p>
             <a:pPr algn="l"/>
             <a:r>
-              <a:rPr sz="1300" b="0">
+              <a:rPr sz="1200" b="0">
                 <a:solidFill>
                   <a:srgbClr val="4A4A4A"/>
                 </a:solidFill>
                 <a:latin typeface="IPAGothic"/>
               </a:rPr>
-              <a:t>説明会兼面談
-通過者数</a:t>
-            </a:r>
-          </a:p>
-        </p:txBody>
-      </p:sp>
-      <p:sp>
-        <p:nvSpPr>
-          <p:cNvPr id="16" name="TextBox 15"/>
+              <a:t>選考中</a:t>
+            </a:r>
+          </a:p>
+        </p:txBody>
+      </p:sp>
+      <p:sp>
+        <p:nvSpPr>
+          <p:cNvPr id="75" name="Rectangle 74"/>
+          <p:cNvSpPr/>
+          <p:nvPr/>
+        </p:nvSpPr>
+        <p:spPr>
+          <a:xfrm>
+            <a:off x="6583680" y="4663440"/>
+            <a:ext cx="201168" cy="201168"/>
+          </a:xfrm>
+          <a:prstGeom prst="rect">
+            <a:avLst/>
+          </a:prstGeom>
+          <a:solidFill>
+            <a:srgbClr val="999999"/>
+          </a:solidFill>
+          <a:ln>
+            <a:noFill/>
+          </a:ln>
+        </p:spPr>
+        <p:style>
+          <a:lnRef idx="1">
+            <a:schemeClr val="accent1"/>
+          </a:lnRef>
+          <a:fillRef idx="3">
+            <a:schemeClr val="accent1"/>
+          </a:fillRef>
+          <a:effectRef idx="2">
+            <a:schemeClr val="accent1"/>
+          </a:effectRef>
+          <a:fontRef idx="minor">
+            <a:schemeClr val="lt1"/>
+          </a:fontRef>
+        </p:style>
+        <p:txBody>
+          <a:bodyPr rtlCol="0" anchor="ctr"/>
+          <a:lstStyle/>
+          <a:p>
+            <a:pPr algn="ctr"/>
+          </a:p>
+        </p:txBody>
+      </p:sp>
+      <p:sp>
+        <p:nvSpPr>
+          <p:cNvPr id="76" name="TextBox 75"/>
           <p:cNvSpPr txBox="1"/>
           <p:nvPr/>
         </p:nvSpPr>
         <p:spPr>
           <a:xfrm>
-            <a:off x="3456432" y="1874519"/>
-            <a:ext cx="1737360" cy="822960"/>
+            <a:off x="6830568" y="4645152"/>
+            <a:ext cx="1371600" cy="256032"/>
           </a:xfrm>
           <a:prstGeom prst="rect">
             <a:avLst/>
@@ -4335,97 +6704,27 @@
           <a:p>
             <a:pPr algn="l"/>
             <a:r>
-              <a:rPr sz="4200" b="1">
-                <a:solidFill>
-                  <a:srgbClr val="4A90D9"/>
-                </a:solidFill>
-                <a:latin typeface="IPAGothic"/>
-              </a:rPr>
-              <a:t>27</a:t>
-            </a:r>
-          </a:p>
-        </p:txBody>
-      </p:sp>
-      <p:sp>
-        <p:nvSpPr>
-          <p:cNvPr id="17" name="TextBox 16"/>
-          <p:cNvSpPr txBox="1"/>
-          <p:nvPr/>
-        </p:nvSpPr>
-        <p:spPr>
-          <a:xfrm>
-            <a:off x="4919472" y="2286000"/>
-            <a:ext cx="731520" cy="365760"/>
-          </a:xfrm>
-          <a:prstGeom prst="rect">
-            <a:avLst/>
-          </a:prstGeom>
-          <a:noFill/>
-        </p:spPr>
-        <p:txBody>
-          <a:bodyPr wrap="square">
-            <a:spAutoFit/>
-          </a:bodyPr>
-          <a:lstStyle/>
-          <a:p>
-            <a:pPr algn="l"/>
-            <a:r>
-              <a:rPr sz="1600" b="0">
+              <a:rPr sz="1200" b="0">
                 <a:solidFill>
                   <a:srgbClr val="4A4A4A"/>
                 </a:solidFill>
                 <a:latin typeface="IPAGothic"/>
               </a:rPr>
-              <a:t>名</a:t>
-            </a:r>
-          </a:p>
-        </p:txBody>
-      </p:sp>
-      <p:sp>
-        <p:nvSpPr>
-          <p:cNvPr id="18" name="TextBox 17"/>
-          <p:cNvSpPr txBox="1"/>
-          <p:nvPr/>
-        </p:nvSpPr>
-        <p:spPr>
-          <a:xfrm>
-            <a:off x="3456432" y="2834640"/>
-            <a:ext cx="2468880" cy="365760"/>
-          </a:xfrm>
-          <a:prstGeom prst="rect">
-            <a:avLst/>
-          </a:prstGeom>
-          <a:noFill/>
-        </p:spPr>
-        <p:txBody>
-          <a:bodyPr wrap="square">
-            <a:spAutoFit/>
-          </a:bodyPr>
-          <a:lstStyle/>
-          <a:p>
-            <a:pPr algn="l"/>
-            <a:r>
-              <a:rPr sz="1300" b="0">
-                <a:solidFill>
-                  <a:srgbClr val="7F7F7F"/>
-                </a:solidFill>
-                <a:latin typeface="IPAGothic"/>
-              </a:rPr>
-              <a:t>通過率 46%</a:t>
-            </a:r>
-          </a:p>
-        </p:txBody>
-      </p:sp>
-      <p:sp>
-        <p:nvSpPr>
-          <p:cNvPr id="19" name="Rectangle 18"/>
+              <a:t>前段階未到達</a:t>
+            </a:r>
+          </a:p>
+        </p:txBody>
+      </p:sp>
+      <p:sp>
+        <p:nvSpPr>
+          <p:cNvPr id="77" name="Rectangle 76"/>
           <p:cNvSpPr/>
           <p:nvPr/>
         </p:nvSpPr>
         <p:spPr>
           <a:xfrm>
-            <a:off x="6217920" y="1261872"/>
-            <a:ext cx="2743200" cy="2057400"/>
+            <a:off x="320040" y="5010912"/>
+            <a:ext cx="11521440" cy="1645920"/>
           </a:xfrm>
           <a:prstGeom prst="rect">
             <a:avLst/>
@@ -4461,20 +6760,20 @@
       </p:sp>
       <p:sp>
         <p:nvSpPr>
-          <p:cNvPr id="20" name="Rectangle 19"/>
+          <p:cNvPr id="78" name="Rectangle 77"/>
           <p:cNvSpPr/>
           <p:nvPr/>
         </p:nvSpPr>
         <p:spPr>
           <a:xfrm>
-            <a:off x="6217920" y="1261872"/>
-            <a:ext cx="64008" cy="2057400"/>
-          </a:xfrm>
-          <a:prstGeom prst="rect">
-            <a:avLst/>
-          </a:prstGeom>
-          <a:solidFill>
-            <a:srgbClr val="C9A227"/>
+            <a:off x="320040" y="5010912"/>
+            <a:ext cx="82296" cy="1645920"/>
+          </a:xfrm>
+          <a:prstGeom prst="rect">
+            <a:avLst/>
+          </a:prstGeom>
+          <a:solidFill>
+            <a:srgbClr val="1E3A5F"/>
           </a:solidFill>
           <a:ln>
             <a:noFill/>
@@ -4504,14 +6803,14 @@
       </p:sp>
       <p:sp>
         <p:nvSpPr>
-          <p:cNvPr id="21" name="TextBox 20"/>
+          <p:cNvPr id="79" name="TextBox 78"/>
           <p:cNvSpPr txBox="1"/>
           <p:nvPr/>
         </p:nvSpPr>
         <p:spPr>
           <a:xfrm>
-            <a:off x="6382512" y="1325880"/>
-            <a:ext cx="2468880" cy="594360"/>
+            <a:off x="530352" y="5102352"/>
+            <a:ext cx="10058400" cy="384048"/>
           </a:xfrm>
           <a:prstGeom prst="rect">
             <a:avLst/>
@@ -4526,709 +6825,7 @@
           <a:p>
             <a:pPr algn="l"/>
             <a:r>
-              <a:rPr sz="1300" b="0">
-                <a:solidFill>
-                  <a:srgbClr val="4A4A4A"/>
-                </a:solidFill>
-                <a:latin typeface="IPAGothic"/>
-              </a:rPr>
-              <a:t>一次選考
-通過者数</a:t>
-            </a:r>
-          </a:p>
-        </p:txBody>
-      </p:sp>
-      <p:sp>
-        <p:nvSpPr>
-          <p:cNvPr id="22" name="TextBox 21"/>
-          <p:cNvSpPr txBox="1"/>
-          <p:nvPr/>
-        </p:nvSpPr>
-        <p:spPr>
-          <a:xfrm>
-            <a:off x="6382512" y="1874519"/>
-            <a:ext cx="1737360" cy="822960"/>
-          </a:xfrm>
-          <a:prstGeom prst="rect">
-            <a:avLst/>
-          </a:prstGeom>
-          <a:noFill/>
-        </p:spPr>
-        <p:txBody>
-          <a:bodyPr wrap="square">
-            <a:spAutoFit/>
-          </a:bodyPr>
-          <a:lstStyle/>
-          <a:p>
-            <a:pPr algn="l"/>
-            <a:r>
-              <a:rPr sz="4200" b="1">
-                <a:solidFill>
-                  <a:srgbClr val="C9A227"/>
-                </a:solidFill>
-                <a:latin typeface="IPAGothic"/>
-              </a:rPr>
-              <a:t>11</a:t>
-            </a:r>
-          </a:p>
-        </p:txBody>
-      </p:sp>
-      <p:sp>
-        <p:nvSpPr>
-          <p:cNvPr id="23" name="TextBox 22"/>
-          <p:cNvSpPr txBox="1"/>
-          <p:nvPr/>
-        </p:nvSpPr>
-        <p:spPr>
-          <a:xfrm>
-            <a:off x="7845552" y="2286000"/>
-            <a:ext cx="731520" cy="365760"/>
-          </a:xfrm>
-          <a:prstGeom prst="rect">
-            <a:avLst/>
-          </a:prstGeom>
-          <a:noFill/>
-        </p:spPr>
-        <p:txBody>
-          <a:bodyPr wrap="square">
-            <a:spAutoFit/>
-          </a:bodyPr>
-          <a:lstStyle/>
-          <a:p>
-            <a:pPr algn="l"/>
-            <a:r>
-              <a:rPr sz="1600" b="0">
-                <a:solidFill>
-                  <a:srgbClr val="4A4A4A"/>
-                </a:solidFill>
-                <a:latin typeface="IPAGothic"/>
-              </a:rPr>
-              <a:t>名</a:t>
-            </a:r>
-          </a:p>
-        </p:txBody>
-      </p:sp>
-      <p:sp>
-        <p:nvSpPr>
-          <p:cNvPr id="24" name="TextBox 23"/>
-          <p:cNvSpPr txBox="1"/>
-          <p:nvPr/>
-        </p:nvSpPr>
-        <p:spPr>
-          <a:xfrm>
-            <a:off x="6382512" y="2834640"/>
-            <a:ext cx="2468880" cy="365760"/>
-          </a:xfrm>
-          <a:prstGeom prst="rect">
-            <a:avLst/>
-          </a:prstGeom>
-          <a:noFill/>
-        </p:spPr>
-        <p:txBody>
-          <a:bodyPr wrap="square">
-            <a:spAutoFit/>
-          </a:bodyPr>
-          <a:lstStyle/>
-          <a:p>
-            <a:pPr algn="l"/>
-            <a:r>
-              <a:rPr sz="1300" b="0">
-                <a:solidFill>
-                  <a:srgbClr val="7F7F7F"/>
-                </a:solidFill>
-                <a:latin typeface="IPAGothic"/>
-              </a:rPr>
-              <a:t>通過率 41%</a:t>
-            </a:r>
-          </a:p>
-        </p:txBody>
-      </p:sp>
-      <p:sp>
-        <p:nvSpPr>
-          <p:cNvPr id="25" name="Rectangle 24"/>
-          <p:cNvSpPr/>
-          <p:nvPr/>
-        </p:nvSpPr>
-        <p:spPr>
-          <a:xfrm>
-            <a:off x="9144000" y="1261872"/>
-            <a:ext cx="2743200" cy="2057400"/>
-          </a:xfrm>
-          <a:prstGeom prst="rect">
-            <a:avLst/>
-          </a:prstGeom>
-          <a:solidFill>
-            <a:srgbClr val="FFFFFF"/>
-          </a:solidFill>
-          <a:ln>
-            <a:noFill/>
-          </a:ln>
-        </p:spPr>
-        <p:style>
-          <a:lnRef idx="1">
-            <a:schemeClr val="accent1"/>
-          </a:lnRef>
-          <a:fillRef idx="3">
-            <a:schemeClr val="accent1"/>
-          </a:fillRef>
-          <a:effectRef idx="2">
-            <a:schemeClr val="accent1"/>
-          </a:effectRef>
-          <a:fontRef idx="minor">
-            <a:schemeClr val="lt1"/>
-          </a:fontRef>
-        </p:style>
-        <p:txBody>
-          <a:bodyPr rtlCol="0" anchor="ctr"/>
-          <a:lstStyle/>
-          <a:p>
-            <a:pPr algn="ctr"/>
-          </a:p>
-        </p:txBody>
-      </p:sp>
-      <p:sp>
-        <p:nvSpPr>
-          <p:cNvPr id="26" name="Rectangle 25"/>
-          <p:cNvSpPr/>
-          <p:nvPr/>
-        </p:nvSpPr>
-        <p:spPr>
-          <a:xfrm>
-            <a:off x="9144000" y="1261872"/>
-            <a:ext cx="64008" cy="2057400"/>
-          </a:xfrm>
-          <a:prstGeom prst="rect">
-            <a:avLst/>
-          </a:prstGeom>
-          <a:solidFill>
-            <a:srgbClr val="27AE60"/>
-          </a:solidFill>
-          <a:ln>
-            <a:noFill/>
-          </a:ln>
-        </p:spPr>
-        <p:style>
-          <a:lnRef idx="1">
-            <a:schemeClr val="accent1"/>
-          </a:lnRef>
-          <a:fillRef idx="3">
-            <a:schemeClr val="accent1"/>
-          </a:fillRef>
-          <a:effectRef idx="2">
-            <a:schemeClr val="accent1"/>
-          </a:effectRef>
-          <a:fontRef idx="minor">
-            <a:schemeClr val="lt1"/>
-          </a:fontRef>
-        </p:style>
-        <p:txBody>
-          <a:bodyPr rtlCol="0" anchor="ctr"/>
-          <a:lstStyle/>
-          <a:p>
-            <a:pPr algn="ctr"/>
-          </a:p>
-        </p:txBody>
-      </p:sp>
-      <p:sp>
-        <p:nvSpPr>
-          <p:cNvPr id="27" name="TextBox 26"/>
-          <p:cNvSpPr txBox="1"/>
-          <p:nvPr/>
-        </p:nvSpPr>
-        <p:spPr>
-          <a:xfrm>
-            <a:off x="9308592" y="1325880"/>
-            <a:ext cx="2468880" cy="594360"/>
-          </a:xfrm>
-          <a:prstGeom prst="rect">
-            <a:avLst/>
-          </a:prstGeom>
-          <a:noFill/>
-        </p:spPr>
-        <p:txBody>
-          <a:bodyPr wrap="square">
-            <a:spAutoFit/>
-          </a:bodyPr>
-          <a:lstStyle/>
-          <a:p>
-            <a:pPr algn="l"/>
-            <a:r>
-              <a:rPr sz="1300" b="0">
-                <a:solidFill>
-                  <a:srgbClr val="4A4A4A"/>
-                </a:solidFill>
-                <a:latin typeface="IPAGothic"/>
-              </a:rPr>
-              <a:t>最終選考
-通過者数</a:t>
-            </a:r>
-          </a:p>
-        </p:txBody>
-      </p:sp>
-      <p:sp>
-        <p:nvSpPr>
-          <p:cNvPr id="28" name="TextBox 27"/>
-          <p:cNvSpPr txBox="1"/>
-          <p:nvPr/>
-        </p:nvSpPr>
-        <p:spPr>
-          <a:xfrm>
-            <a:off x="9308592" y="1874519"/>
-            <a:ext cx="1737360" cy="822960"/>
-          </a:xfrm>
-          <a:prstGeom prst="rect">
-            <a:avLst/>
-          </a:prstGeom>
-          <a:noFill/>
-        </p:spPr>
-        <p:txBody>
-          <a:bodyPr wrap="square">
-            <a:spAutoFit/>
-          </a:bodyPr>
-          <a:lstStyle/>
-          <a:p>
-            <a:pPr algn="l"/>
-            <a:r>
-              <a:rPr sz="4200" b="1">
-                <a:solidFill>
-                  <a:srgbClr val="27AE60"/>
-                </a:solidFill>
-                <a:latin typeface="IPAGothic"/>
-              </a:rPr>
-              <a:t>1</a:t>
-            </a:r>
-          </a:p>
-        </p:txBody>
-      </p:sp>
-      <p:sp>
-        <p:nvSpPr>
-          <p:cNvPr id="29" name="TextBox 28"/>
-          <p:cNvSpPr txBox="1"/>
-          <p:nvPr/>
-        </p:nvSpPr>
-        <p:spPr>
-          <a:xfrm>
-            <a:off x="10771632" y="2286000"/>
-            <a:ext cx="731520" cy="365760"/>
-          </a:xfrm>
-          <a:prstGeom prst="rect">
-            <a:avLst/>
-          </a:prstGeom>
-          <a:noFill/>
-        </p:spPr>
-        <p:txBody>
-          <a:bodyPr wrap="square">
-            <a:spAutoFit/>
-          </a:bodyPr>
-          <a:lstStyle/>
-          <a:p>
-            <a:pPr algn="l"/>
-            <a:r>
-              <a:rPr sz="1600" b="0">
-                <a:solidFill>
-                  <a:srgbClr val="4A4A4A"/>
-                </a:solidFill>
-                <a:latin typeface="IPAGothic"/>
-              </a:rPr>
-              <a:t>名</a:t>
-            </a:r>
-          </a:p>
-        </p:txBody>
-      </p:sp>
-      <p:sp>
-        <p:nvSpPr>
-          <p:cNvPr id="30" name="TextBox 29"/>
-          <p:cNvSpPr txBox="1"/>
-          <p:nvPr/>
-        </p:nvSpPr>
-        <p:spPr>
-          <a:xfrm>
-            <a:off x="9308592" y="2834640"/>
-            <a:ext cx="2468880" cy="365760"/>
-          </a:xfrm>
-          <a:prstGeom prst="rect">
-            <a:avLst/>
-          </a:prstGeom>
-          <a:noFill/>
-        </p:spPr>
-        <p:txBody>
-          <a:bodyPr wrap="square">
-            <a:spAutoFit/>
-          </a:bodyPr>
-          <a:lstStyle/>
-          <a:p>
-            <a:pPr algn="l"/>
-            <a:r>
-              <a:rPr sz="1300" b="0">
-                <a:solidFill>
-                  <a:srgbClr val="7F7F7F"/>
-                </a:solidFill>
-                <a:latin typeface="IPAGothic"/>
-              </a:rPr>
-              <a:t>通過率 9%</a:t>
-            </a:r>
-          </a:p>
-        </p:txBody>
-      </p:sp>
-      <p:sp>
-        <p:nvSpPr>
-          <p:cNvPr id="31" name="TextBox 30"/>
-          <p:cNvSpPr txBox="1"/>
-          <p:nvPr/>
-        </p:nvSpPr>
-        <p:spPr>
-          <a:xfrm>
-            <a:off x="365760" y="3401568"/>
-            <a:ext cx="2560320" cy="594360"/>
-          </a:xfrm>
-          <a:prstGeom prst="rect">
-            <a:avLst/>
-          </a:prstGeom>
-          <a:noFill/>
-        </p:spPr>
-        <p:txBody>
-          <a:bodyPr wrap="square">
-            <a:spAutoFit/>
-          </a:bodyPr>
-          <a:lstStyle/>
-          <a:p>
-            <a:pPr algn="ctr"/>
-            <a:r>
-              <a:rPr sz="1300" b="1">
-                <a:solidFill>
-                  <a:srgbClr val="1E3A5F"/>
-                </a:solidFill>
-                <a:latin typeface="IPAGothic"/>
-              </a:rPr>
-              <a:t>応募</a:t>
-            </a:r>
-          </a:p>
-        </p:txBody>
-      </p:sp>
-      <p:sp>
-        <p:nvSpPr>
-          <p:cNvPr id="32" name="TextBox 31"/>
-          <p:cNvSpPr txBox="1"/>
-          <p:nvPr/>
-        </p:nvSpPr>
-        <p:spPr>
-          <a:xfrm>
-            <a:off x="3108960" y="3401568"/>
-            <a:ext cx="502920" cy="594360"/>
-          </a:xfrm>
-          <a:prstGeom prst="rect">
-            <a:avLst/>
-          </a:prstGeom>
-          <a:noFill/>
-        </p:spPr>
-        <p:txBody>
-          <a:bodyPr wrap="square">
-            <a:spAutoFit/>
-          </a:bodyPr>
-          <a:lstStyle/>
-          <a:p>
-            <a:pPr algn="ctr"/>
-            <a:r>
-              <a:rPr sz="2200" b="0">
-                <a:solidFill>
-                  <a:srgbClr val="C9A227"/>
-                </a:solidFill>
-                <a:latin typeface="IPAGothic"/>
-              </a:rPr>
-              <a:t>→</a:t>
-            </a:r>
-          </a:p>
-        </p:txBody>
-      </p:sp>
-      <p:sp>
-        <p:nvSpPr>
-          <p:cNvPr id="33" name="TextBox 32"/>
-          <p:cNvSpPr txBox="1"/>
-          <p:nvPr/>
-        </p:nvSpPr>
-        <p:spPr>
-          <a:xfrm>
-            <a:off x="3474720" y="3401568"/>
-            <a:ext cx="2560320" cy="594360"/>
-          </a:xfrm>
-          <a:prstGeom prst="rect">
-            <a:avLst/>
-          </a:prstGeom>
-          <a:noFill/>
-        </p:spPr>
-        <p:txBody>
-          <a:bodyPr wrap="square">
-            <a:spAutoFit/>
-          </a:bodyPr>
-          <a:lstStyle/>
-          <a:p>
-            <a:pPr algn="ctr"/>
-            <a:r>
-              <a:rPr sz="1300" b="1">
-                <a:solidFill>
-                  <a:srgbClr val="4A90D9"/>
-                </a:solidFill>
-                <a:latin typeface="IPAGothic"/>
-              </a:rPr>
-              <a:t>説明会兼
-面談通過</a:t>
-            </a:r>
-          </a:p>
-        </p:txBody>
-      </p:sp>
-      <p:sp>
-        <p:nvSpPr>
-          <p:cNvPr id="34" name="TextBox 33"/>
-          <p:cNvSpPr txBox="1"/>
-          <p:nvPr/>
-        </p:nvSpPr>
-        <p:spPr>
-          <a:xfrm>
-            <a:off x="6035040" y="3401568"/>
-            <a:ext cx="502920" cy="594360"/>
-          </a:xfrm>
-          <a:prstGeom prst="rect">
-            <a:avLst/>
-          </a:prstGeom>
-          <a:noFill/>
-        </p:spPr>
-        <p:txBody>
-          <a:bodyPr wrap="square">
-            <a:spAutoFit/>
-          </a:bodyPr>
-          <a:lstStyle/>
-          <a:p>
-            <a:pPr algn="ctr"/>
-            <a:r>
-              <a:rPr sz="2200" b="0">
-                <a:solidFill>
-                  <a:srgbClr val="C9A227"/>
-                </a:solidFill>
-                <a:latin typeface="IPAGothic"/>
-              </a:rPr>
-              <a:t>→</a:t>
-            </a:r>
-          </a:p>
-        </p:txBody>
-      </p:sp>
-      <p:sp>
-        <p:nvSpPr>
-          <p:cNvPr id="35" name="TextBox 34"/>
-          <p:cNvSpPr txBox="1"/>
-          <p:nvPr/>
-        </p:nvSpPr>
-        <p:spPr>
-          <a:xfrm>
-            <a:off x="6400800" y="3401568"/>
-            <a:ext cx="2560320" cy="594360"/>
-          </a:xfrm>
-          <a:prstGeom prst="rect">
-            <a:avLst/>
-          </a:prstGeom>
-          <a:noFill/>
-        </p:spPr>
-        <p:txBody>
-          <a:bodyPr wrap="square">
-            <a:spAutoFit/>
-          </a:bodyPr>
-          <a:lstStyle/>
-          <a:p>
-            <a:pPr algn="ctr"/>
-            <a:r>
-              <a:rPr sz="1300" b="1">
-                <a:solidFill>
-                  <a:srgbClr val="C9A227"/>
-                </a:solidFill>
-                <a:latin typeface="IPAGothic"/>
-              </a:rPr>
-              <a:t>一次選考
-通過</a:t>
-            </a:r>
-          </a:p>
-        </p:txBody>
-      </p:sp>
-      <p:sp>
-        <p:nvSpPr>
-          <p:cNvPr id="36" name="TextBox 35"/>
-          <p:cNvSpPr txBox="1"/>
-          <p:nvPr/>
-        </p:nvSpPr>
-        <p:spPr>
-          <a:xfrm>
-            <a:off x="9006840" y="3401568"/>
-            <a:ext cx="502920" cy="594360"/>
-          </a:xfrm>
-          <a:prstGeom prst="rect">
-            <a:avLst/>
-          </a:prstGeom>
-          <a:noFill/>
-        </p:spPr>
-        <p:txBody>
-          <a:bodyPr wrap="square">
-            <a:spAutoFit/>
-          </a:bodyPr>
-          <a:lstStyle/>
-          <a:p>
-            <a:pPr algn="ctr"/>
-            <a:r>
-              <a:rPr sz="2200" b="0">
-                <a:solidFill>
-                  <a:srgbClr val="C9A227"/>
-                </a:solidFill>
-                <a:latin typeface="IPAGothic"/>
-              </a:rPr>
-              <a:t>→</a:t>
-            </a:r>
-          </a:p>
-        </p:txBody>
-      </p:sp>
-      <p:sp>
-        <p:nvSpPr>
-          <p:cNvPr id="37" name="TextBox 36"/>
-          <p:cNvSpPr txBox="1"/>
-          <p:nvPr/>
-        </p:nvSpPr>
-        <p:spPr>
-          <a:xfrm>
-            <a:off x="9372600" y="3401568"/>
-            <a:ext cx="2560320" cy="594360"/>
-          </a:xfrm>
-          <a:prstGeom prst="rect">
-            <a:avLst/>
-          </a:prstGeom>
-          <a:noFill/>
-        </p:spPr>
-        <p:txBody>
-          <a:bodyPr wrap="square">
-            <a:spAutoFit/>
-          </a:bodyPr>
-          <a:lstStyle/>
-          <a:p>
-            <a:pPr algn="ctr"/>
-            <a:r>
-              <a:rPr sz="1300" b="1">
-                <a:solidFill>
-                  <a:srgbClr val="27AE60"/>
-                </a:solidFill>
-                <a:latin typeface="IPAGothic"/>
-              </a:rPr>
-              <a:t>最終選考
-通過</a:t>
-            </a:r>
-          </a:p>
-        </p:txBody>
-      </p:sp>
-      <p:sp>
-        <p:nvSpPr>
-          <p:cNvPr id="38" name="Rectangle 37"/>
-          <p:cNvSpPr/>
-          <p:nvPr/>
-        </p:nvSpPr>
-        <p:spPr>
-          <a:xfrm>
-            <a:off x="365760" y="4133087"/>
-            <a:ext cx="11430000" cy="2423160"/>
-          </a:xfrm>
-          <a:prstGeom prst="rect">
-            <a:avLst/>
-          </a:prstGeom>
-          <a:solidFill>
-            <a:srgbClr val="FFFFFF"/>
-          </a:solidFill>
-          <a:ln>
-            <a:noFill/>
-          </a:ln>
-        </p:spPr>
-        <p:style>
-          <a:lnRef idx="1">
-            <a:schemeClr val="accent1"/>
-          </a:lnRef>
-          <a:fillRef idx="3">
-            <a:schemeClr val="accent1"/>
-          </a:fillRef>
-          <a:effectRef idx="2">
-            <a:schemeClr val="accent1"/>
-          </a:effectRef>
-          <a:fontRef idx="minor">
-            <a:schemeClr val="lt1"/>
-          </a:fontRef>
-        </p:style>
-        <p:txBody>
-          <a:bodyPr rtlCol="0" anchor="ctr"/>
-          <a:lstStyle/>
-          <a:p>
-            <a:pPr algn="ctr"/>
-          </a:p>
-        </p:txBody>
-      </p:sp>
-      <p:sp>
-        <p:nvSpPr>
-          <p:cNvPr id="39" name="Rectangle 38"/>
-          <p:cNvSpPr/>
-          <p:nvPr/>
-        </p:nvSpPr>
-        <p:spPr>
-          <a:xfrm>
-            <a:off x="365760" y="4133087"/>
-            <a:ext cx="82296" cy="2423160"/>
-          </a:xfrm>
-          <a:prstGeom prst="rect">
-            <a:avLst/>
-          </a:prstGeom>
-          <a:solidFill>
-            <a:srgbClr val="1E3A5F"/>
-          </a:solidFill>
-          <a:ln>
-            <a:noFill/>
-          </a:ln>
-        </p:spPr>
-        <p:style>
-          <a:lnRef idx="1">
-            <a:schemeClr val="accent1"/>
-          </a:lnRef>
-          <a:fillRef idx="3">
-            <a:schemeClr val="accent1"/>
-          </a:fillRef>
-          <a:effectRef idx="2">
-            <a:schemeClr val="accent1"/>
-          </a:effectRef>
-          <a:fontRef idx="minor">
-            <a:schemeClr val="lt1"/>
-          </a:fontRef>
-        </p:style>
-        <p:txBody>
-          <a:bodyPr rtlCol="0" anchor="ctr"/>
-          <a:lstStyle/>
-          <a:p>
-            <a:pPr algn="ctr"/>
-          </a:p>
-        </p:txBody>
-      </p:sp>
-      <p:sp>
-        <p:nvSpPr>
-          <p:cNvPr id="40" name="TextBox 39"/>
-          <p:cNvSpPr txBox="1"/>
-          <p:nvPr/>
-        </p:nvSpPr>
-        <p:spPr>
-          <a:xfrm>
-            <a:off x="566928" y="4251960"/>
-            <a:ext cx="10515600" cy="438912"/>
-          </a:xfrm>
-          <a:prstGeom prst="rect">
-            <a:avLst/>
-          </a:prstGeom>
-          <a:noFill/>
-        </p:spPr>
-        <p:txBody>
-          <a:bodyPr wrap="square">
-            <a:spAutoFit/>
-          </a:bodyPr>
-          <a:lstStyle/>
-          <a:p>
-            <a:pPr algn="l"/>
-            <a:r>
-              <a:rPr sz="1600" b="1">
+              <a:rPr sz="1500" b="1">
                 <a:solidFill>
                   <a:srgbClr val="1E3A5F"/>
                 </a:solidFill>
@@ -5241,14 +6838,14 @@
       </p:sp>
       <p:sp>
         <p:nvSpPr>
-          <p:cNvPr id="41" name="TextBox 40"/>
+          <p:cNvPr id="80" name="TextBox 79"/>
           <p:cNvSpPr txBox="1"/>
           <p:nvPr/>
         </p:nvSpPr>
         <p:spPr>
           <a:xfrm>
-            <a:off x="566928" y="4727448"/>
-            <a:ext cx="10972800" cy="411480"/>
+            <a:off x="530352" y="5522976"/>
+            <a:ext cx="10972800" cy="365760"/>
           </a:xfrm>
           <a:prstGeom prst="rect">
             <a:avLst/>
@@ -5263,27 +6860,27 @@
           <a:p>
             <a:pPr algn="l"/>
             <a:r>
-              <a:rPr sz="1300" b="0">
+              <a:rPr sz="1250" b="0">
                 <a:solidFill>
                   <a:srgbClr val="4A4A4A"/>
                 </a:solidFill>
                 <a:latin typeface="IPAGothic"/>
               </a:rPr>
-              <a:t>・ 上位校からの応募59名のうち、説明会兼面談通過は27名（通過率 46%）</a:t>
-            </a:r>
-          </a:p>
-        </p:txBody>
-      </p:sp>
-      <p:sp>
-        <p:nvSpPr>
-          <p:cNvPr id="42" name="TextBox 41"/>
+              <a:t>・ 説明会兼面談での辞退が18名（最大の離脱ポイント）。早期辞退防止が急務</a:t>
+            </a:r>
+          </a:p>
+        </p:txBody>
+      </p:sp>
+      <p:sp>
+        <p:nvSpPr>
+          <p:cNvPr id="81" name="TextBox 80"/>
           <p:cNvSpPr txBox="1"/>
           <p:nvPr/>
         </p:nvSpPr>
         <p:spPr>
           <a:xfrm>
-            <a:off x="566928" y="5157216"/>
-            <a:ext cx="10972800" cy="411480"/>
+            <a:off x="530352" y="5907024"/>
+            <a:ext cx="10972800" cy="365760"/>
           </a:xfrm>
           <a:prstGeom prst="rect">
             <a:avLst/>
@@ -5298,27 +6895,27 @@
           <a:p>
             <a:pPr algn="l"/>
             <a:r>
-              <a:rPr sz="1300" b="0">
+              <a:rPr sz="1250" b="0">
                 <a:solidFill>
                   <a:srgbClr val="4A4A4A"/>
                 </a:solidFill>
                 <a:latin typeface="IPAGothic"/>
               </a:rPr>
-              <a:t>・ 一次選考通過は11名（説明会兼面談通過比 41%）。半数近くが両選考間で離脱</a:t>
-            </a:r>
-          </a:p>
-        </p:txBody>
-      </p:sp>
-      <p:sp>
-        <p:nvSpPr>
-          <p:cNvPr id="43" name="TextBox 42"/>
+              <a:t>・ 一次選考では27名中11名通過（41%）。辞退7名・選考中7名が残存</a:t>
+            </a:r>
+          </a:p>
+        </p:txBody>
+      </p:sp>
+      <p:sp>
+        <p:nvSpPr>
+          <p:cNvPr id="82" name="TextBox 81"/>
           <p:cNvSpPr txBox="1"/>
           <p:nvPr/>
         </p:nvSpPr>
         <p:spPr>
           <a:xfrm>
-            <a:off x="566928" y="5586983"/>
-            <a:ext cx="10972800" cy="411480"/>
+            <a:off x="530352" y="6291072"/>
+            <a:ext cx="10972800" cy="365760"/>
           </a:xfrm>
           <a:prstGeom prst="rect">
             <a:avLst/>
@@ -5333,48 +6930,13 @@
           <a:p>
             <a:pPr algn="l"/>
             <a:r>
-              <a:rPr sz="1300" b="0">
+              <a:rPr sz="1250" b="0">
                 <a:solidFill>
                   <a:srgbClr val="4A4A4A"/>
                 </a:solidFill>
                 <a:latin typeface="IPAGothic"/>
               </a:rPr>
-              <a:t>・ 最終選考通過（内定）は1名（全体の内定率 1.7%）</a:t>
-            </a:r>
-          </a:p>
-        </p:txBody>
-      </p:sp>
-      <p:sp>
-        <p:nvSpPr>
-          <p:cNvPr id="44" name="TextBox 43"/>
-          <p:cNvSpPr txBox="1"/>
-          <p:nvPr/>
-        </p:nvSpPr>
-        <p:spPr>
-          <a:xfrm>
-            <a:off x="566928" y="6016752"/>
-            <a:ext cx="10972800" cy="411480"/>
-          </a:xfrm>
-          <a:prstGeom prst="rect">
-            <a:avLst/>
-          </a:prstGeom>
-          <a:noFill/>
-        </p:spPr>
-        <p:txBody>
-          <a:bodyPr wrap="square">
-            <a:spAutoFit/>
-          </a:bodyPr>
-          <a:lstStyle/>
-          <a:p>
-            <a:pPr algn="l"/>
-            <a:r>
-              <a:rPr sz="1300" b="0">
-                <a:solidFill>
-                  <a:srgbClr val="4A4A4A"/>
-                </a:solidFill>
-                <a:latin typeface="IPAGothic"/>
-              </a:rPr>
-              <a:t>・ 辞退者28名（47.5%）が最大離脱要因 ─ 他社内定・優先が9名と最多</a:t>
+              <a:t>・ 最終選考は11名受験→通過1名（9%）。辞退3名・選考中4名が残る</a:t>
             </a:r>
           </a:p>
         </p:txBody>
@@ -5556,7 +7118,7 @@
                 </a:solidFill>
                 <a:latin typeface="IPAGothic"/>
               </a:rPr>
-              <a:t>選考ファネル</a:t>
+              <a:t>選考ステップ別　内訳</a:t>
             </a:r>
           </a:p>
         </p:txBody>
@@ -5591,14 +7153,14 @@
                 </a:solidFill>
                 <a:latin typeface="IPAGothic"/>
               </a:rPr>
-              <a:t>応募〜最終選考通過までの人数推移</a:t>
+              <a:t>各ステップの通過・辞退・不合格・選考中・未到達の内訳</a:t>
             </a:r>
           </a:p>
         </p:txBody>
       </p:sp>
       <p:pic>
         <p:nvPicPr>
-          <p:cNvPr id="7" name="Picture 6" descr="funnel.png"/>
+          <p:cNvPr id="7" name="Picture 6" descr="funnel_detail.png"/>
           <p:cNvPicPr>
             <a:picLocks noChangeAspect="1"/>
           </p:cNvPicPr>
@@ -5612,8 +7174,8 @@
         </p:blipFill>
         <p:spPr>
           <a:xfrm>
-            <a:off x="914400" y="1143000"/>
-            <a:ext cx="10332720" cy="5486400"/>
+            <a:off x="640080" y="1097280"/>
+            <a:ext cx="10972800" cy="5577840"/>
           </a:xfrm>
           <a:prstGeom prst="rect">
             <a:avLst/>
@@ -5797,7 +7359,7 @@
                 </a:solidFill>
                 <a:latin typeface="IPAGothic"/>
               </a:rPr>
-              <a:t>選考ステータス内訳</a:t>
+              <a:t>選考ファネル</a:t>
             </a:r>
           </a:p>
         </p:txBody>
@@ -5832,14 +7394,14 @@
                 </a:solidFill>
                 <a:latin typeface="IPAGothic"/>
               </a:rPr>
-              <a:t>上位校応募者59名の最終ステータス</a:t>
+              <a:t>応募〜最終選考通過までの人数推移</a:t>
             </a:r>
           </a:p>
         </p:txBody>
       </p:sp>
       <p:pic>
         <p:nvPicPr>
-          <p:cNvPr id="7" name="Picture 6" descr="status_donut.png"/>
+          <p:cNvPr id="7" name="Picture 6" descr="funnel.png"/>
           <p:cNvPicPr>
             <a:picLocks noChangeAspect="1"/>
           </p:cNvPicPr>
@@ -5853,32 +7415,8 @@
         </p:blipFill>
         <p:spPr>
           <a:xfrm>
-            <a:off x="274320" y="1097280"/>
-            <a:ext cx="5029200" cy="5029200"/>
-          </a:xfrm>
-          <a:prstGeom prst="rect">
-            <a:avLst/>
-          </a:prstGeom>
-        </p:spPr>
-      </p:pic>
-      <p:pic>
-        <p:nvPicPr>
-          <p:cNvPr id="8" name="Picture 7" descr="status_by_univ.png"/>
-          <p:cNvPicPr>
-            <a:picLocks noChangeAspect="1"/>
-          </p:cNvPicPr>
-          <p:nvPr/>
-        </p:nvPicPr>
-        <p:blipFill>
-          <a:blip r:embed="rId3"/>
-          <a:stretch>
-            <a:fillRect/>
-          </a:stretch>
-        </p:blipFill>
-        <p:spPr>
-          <a:xfrm>
-            <a:off x="5303520" y="1097280"/>
-            <a:ext cx="6675120" cy="5577840"/>
+            <a:off x="914400" y="1143000"/>
+            <a:ext cx="10332720" cy="5486400"/>
           </a:xfrm>
           <a:prstGeom prst="rect">
             <a:avLst/>
@@ -6062,7 +7600,7 @@
                 </a:solidFill>
                 <a:latin typeface="IPAGothic"/>
               </a:rPr>
-              <a:t>大学グループ別　応募者数</a:t>
+              <a:t>選考ステータス内訳</a:t>
             </a:r>
           </a:p>
         </p:txBody>
@@ -6097,14 +7635,14 @@
                 </a:solidFill>
                 <a:latin typeface="IPAGothic"/>
               </a:rPr>
-              <a:t>上位校59名の大学グループ別内訳</a:t>
+              <a:t>上位校応募者59名の最終ステータス（大学別）</a:t>
             </a:r>
           </a:p>
         </p:txBody>
       </p:sp>
       <p:pic>
         <p:nvPicPr>
-          <p:cNvPr id="7" name="Picture 6" descr="group_bar.png"/>
+          <p:cNvPr id="7" name="Picture 6" descr="status_donut.png"/>
           <p:cNvPicPr>
             <a:picLocks noChangeAspect="1"/>
           </p:cNvPicPr>
@@ -6118,8 +7656,32 @@
         </p:blipFill>
         <p:spPr>
           <a:xfrm>
-            <a:off x="1097280" y="1143000"/>
-            <a:ext cx="9966960" cy="5486400"/>
+            <a:off x="274320" y="1097280"/>
+            <a:ext cx="5029200" cy="5029200"/>
+          </a:xfrm>
+          <a:prstGeom prst="rect">
+            <a:avLst/>
+          </a:prstGeom>
+        </p:spPr>
+      </p:pic>
+      <p:pic>
+        <p:nvPicPr>
+          <p:cNvPr id="8" name="Picture 7" descr="status_by_univ.png"/>
+          <p:cNvPicPr>
+            <a:picLocks noChangeAspect="1"/>
+          </p:cNvPicPr>
+          <p:nvPr/>
+        </p:nvPicPr>
+        <p:blipFill>
+          <a:blip r:embed="rId3"/>
+          <a:stretch>
+            <a:fillRect/>
+          </a:stretch>
+        </p:blipFill>
+        <p:spPr>
+          <a:xfrm>
+            <a:off x="5303520" y="1097280"/>
+            <a:ext cx="6675120" cy="5577840"/>
           </a:xfrm>
           <a:prstGeom prst="rect">
             <a:avLst/>
@@ -6303,7 +7865,7 @@
                 </a:solidFill>
                 <a:latin typeface="IPAGothic"/>
               </a:rPr>
-              <a:t>大学別　応募者数</a:t>
+              <a:t>辞退分析：ステップ別×理由別</a:t>
             </a:r>
           </a:p>
         </p:txBody>
@@ -6338,14 +7900,14 @@
                 </a:solidFill>
                 <a:latin typeface="IPAGothic"/>
               </a:rPr>
-              <a:t>上位校14大学の応募者数</a:t>
+              <a:t>どのステップで、何の理由で辞退したか（計28名）</a:t>
             </a:r>
           </a:p>
         </p:txBody>
       </p:sp>
       <p:pic>
         <p:nvPicPr>
-          <p:cNvPr id="7" name="Picture 6" descr="univ_bar.png"/>
+          <p:cNvPr id="7" name="Picture 6" descr="withdrawal_by_step.png"/>
           <p:cNvPicPr>
             <a:picLocks noChangeAspect="1"/>
           </p:cNvPicPr>
@@ -6359,14 +7921,170 @@
         </p:blipFill>
         <p:spPr>
           <a:xfrm>
-            <a:off x="365760" y="1143000"/>
-            <a:ext cx="11430000" cy="5486400"/>
+            <a:off x="457200" y="1097280"/>
+            <a:ext cx="11247120" cy="4754880"/>
           </a:xfrm>
           <a:prstGeom prst="rect">
             <a:avLst/>
           </a:prstGeom>
         </p:spPr>
       </p:pic>
+      <p:sp>
+        <p:nvSpPr>
+          <p:cNvPr id="8" name="Rectangle 7"/>
+          <p:cNvSpPr/>
+          <p:nvPr/>
+        </p:nvSpPr>
+        <p:spPr>
+          <a:xfrm>
+            <a:off x="457200" y="5897880"/>
+            <a:ext cx="11247120" cy="777240"/>
+          </a:xfrm>
+          <a:prstGeom prst="rect">
+            <a:avLst/>
+          </a:prstGeom>
+          <a:solidFill>
+            <a:srgbClr val="FFFFFF"/>
+          </a:solidFill>
+          <a:ln>
+            <a:noFill/>
+          </a:ln>
+        </p:spPr>
+        <p:style>
+          <a:lnRef idx="1">
+            <a:schemeClr val="accent1"/>
+          </a:lnRef>
+          <a:fillRef idx="3">
+            <a:schemeClr val="accent1"/>
+          </a:fillRef>
+          <a:effectRef idx="2">
+            <a:schemeClr val="accent1"/>
+          </a:effectRef>
+          <a:fontRef idx="minor">
+            <a:schemeClr val="lt1"/>
+          </a:fontRef>
+        </p:style>
+        <p:txBody>
+          <a:bodyPr rtlCol="0" anchor="ctr"/>
+          <a:lstStyle/>
+          <a:p>
+            <a:pPr algn="ctr"/>
+          </a:p>
+        </p:txBody>
+      </p:sp>
+      <p:sp>
+        <p:nvSpPr>
+          <p:cNvPr id="9" name="Rectangle 8"/>
+          <p:cNvSpPr/>
+          <p:nvPr/>
+        </p:nvSpPr>
+        <p:spPr>
+          <a:xfrm>
+            <a:off x="457200" y="5897880"/>
+            <a:ext cx="64008" cy="777240"/>
+          </a:xfrm>
+          <a:prstGeom prst="rect">
+            <a:avLst/>
+          </a:prstGeom>
+          <a:solidFill>
+            <a:srgbClr val="C9A227"/>
+          </a:solidFill>
+          <a:ln>
+            <a:noFill/>
+          </a:ln>
+        </p:spPr>
+        <p:style>
+          <a:lnRef idx="1">
+            <a:schemeClr val="accent1"/>
+          </a:lnRef>
+          <a:fillRef idx="3">
+            <a:schemeClr val="accent1"/>
+          </a:fillRef>
+          <a:effectRef idx="2">
+            <a:schemeClr val="accent1"/>
+          </a:effectRef>
+          <a:fontRef idx="minor">
+            <a:schemeClr val="lt1"/>
+          </a:fontRef>
+        </p:style>
+        <p:txBody>
+          <a:bodyPr rtlCol="0" anchor="ctr"/>
+          <a:lstStyle/>
+          <a:p>
+            <a:pPr algn="ctr"/>
+          </a:p>
+        </p:txBody>
+      </p:sp>
+      <p:sp>
+        <p:nvSpPr>
+          <p:cNvPr id="10" name="TextBox 9"/>
+          <p:cNvSpPr txBox="1"/>
+          <p:nvPr/>
+        </p:nvSpPr>
+        <p:spPr>
+          <a:xfrm>
+            <a:off x="640080" y="5925312"/>
+            <a:ext cx="2286000" cy="320040"/>
+          </a:xfrm>
+          <a:prstGeom prst="rect">
+            <a:avLst/>
+          </a:prstGeom>
+          <a:noFill/>
+        </p:spPr>
+        <p:txBody>
+          <a:bodyPr wrap="square">
+            <a:spAutoFit/>
+          </a:bodyPr>
+          <a:lstStyle/>
+          <a:p>
+            <a:pPr algn="l"/>
+            <a:r>
+              <a:rPr sz="1200" b="1">
+                <a:solidFill>
+                  <a:srgbClr val="1E3A5F"/>
+                </a:solidFill>
+                <a:latin typeface="IPAGothic"/>
+              </a:rPr>
+              <a:t>辞退内訳詳細</a:t>
+            </a:r>
+          </a:p>
+        </p:txBody>
+      </p:sp>
+      <p:sp>
+        <p:nvSpPr>
+          <p:cNvPr id="11" name="TextBox 10"/>
+          <p:cNvSpPr txBox="1"/>
+          <p:nvPr/>
+        </p:nvSpPr>
+        <p:spPr>
+          <a:xfrm>
+            <a:off x="640080" y="6263640"/>
+            <a:ext cx="10972800" cy="365760"/>
+          </a:xfrm>
+          <a:prstGeom prst="rect">
+            <a:avLst/>
+          </a:prstGeom>
+          <a:noFill/>
+        </p:spPr>
+        <p:txBody>
+          <a:bodyPr wrap="square">
+            <a:spAutoFit/>
+          </a:bodyPr>
+          <a:lstStyle/>
+          <a:p>
+            <a:pPr algn="l"/>
+            <a:r>
+              <a:rPr sz="1100" b="0">
+                <a:solidFill>
+                  <a:srgbClr val="4A4A4A"/>
+                </a:solidFill>
+                <a:latin typeface="IPAGothic"/>
+              </a:rPr>
+              <a:t>　説明会兼面談18名：他社内定・優先4、業界不一致4、音信不通4、未収集・不明5、自己就活1　／　一次選考7名：他社内定・優先3、業界不一致2、給与待遇1、不明1　／　最終選考3名：他社内定・優先2、不明1</a:t>
+            </a:r>
+          </a:p>
+        </p:txBody>
+      </p:sp>
     </p:spTree>
   </p:cSld>
   <p:clrMapOvr>
@@ -6544,7 +8262,7 @@
                 </a:solidFill>
                 <a:latin typeface="IPAGothic"/>
               </a:rPr>
-              <a:t>辞退分析</a:t>
+              <a:t>大学グループ別　応募者数</a:t>
             </a:r>
           </a:p>
         </p:txBody>
@@ -6579,14 +8297,14 @@
                 </a:solidFill>
                 <a:latin typeface="IPAGothic"/>
               </a:rPr>
-              <a:t>上位校　辞退者28名の理由内訳</a:t>
+              <a:t>上位校59名の大学グループ別内訳</a:t>
             </a:r>
           </a:p>
         </p:txBody>
       </p:sp>
       <p:pic>
         <p:nvPicPr>
-          <p:cNvPr id="7" name="Picture 6" descr="withdrawal.png"/>
+          <p:cNvPr id="7" name="Picture 6" descr="group_bar.png"/>
           <p:cNvPicPr>
             <a:picLocks noChangeAspect="1"/>
           </p:cNvPicPr>
@@ -6600,135 +8318,14 @@
         </p:blipFill>
         <p:spPr>
           <a:xfrm>
-            <a:off x="640080" y="1143000"/>
-            <a:ext cx="10972800" cy="4846320"/>
+            <a:off x="1097280" y="1143000"/>
+            <a:ext cx="9966960" cy="5486400"/>
           </a:xfrm>
           <a:prstGeom prst="rect">
             <a:avLst/>
           </a:prstGeom>
         </p:spPr>
       </p:pic>
-      <p:sp>
-        <p:nvSpPr>
-          <p:cNvPr id="8" name="Rectangle 7"/>
-          <p:cNvSpPr/>
-          <p:nvPr/>
-        </p:nvSpPr>
-        <p:spPr>
-          <a:xfrm>
-            <a:off x="640080" y="6080760"/>
-            <a:ext cx="10972800" cy="594360"/>
-          </a:xfrm>
-          <a:prstGeom prst="rect">
-            <a:avLst/>
-          </a:prstGeom>
-          <a:solidFill>
-            <a:srgbClr val="FFF8E7"/>
-          </a:solidFill>
-          <a:ln>
-            <a:noFill/>
-          </a:ln>
-        </p:spPr>
-        <p:style>
-          <a:lnRef idx="1">
-            <a:schemeClr val="accent1"/>
-          </a:lnRef>
-          <a:fillRef idx="3">
-            <a:schemeClr val="accent1"/>
-          </a:fillRef>
-          <a:effectRef idx="2">
-            <a:schemeClr val="accent1"/>
-          </a:effectRef>
-          <a:fontRef idx="minor">
-            <a:schemeClr val="lt1"/>
-          </a:fontRef>
-        </p:style>
-        <p:txBody>
-          <a:bodyPr rtlCol="0" anchor="ctr"/>
-          <a:lstStyle/>
-          <a:p>
-            <a:pPr algn="ctr"/>
-          </a:p>
-        </p:txBody>
-      </p:sp>
-      <p:sp>
-        <p:nvSpPr>
-          <p:cNvPr id="9" name="Rectangle 8"/>
-          <p:cNvSpPr/>
-          <p:nvPr/>
-        </p:nvSpPr>
-        <p:spPr>
-          <a:xfrm>
-            <a:off x="640080" y="6080760"/>
-            <a:ext cx="64008" cy="594360"/>
-          </a:xfrm>
-          <a:prstGeom prst="rect">
-            <a:avLst/>
-          </a:prstGeom>
-          <a:solidFill>
-            <a:srgbClr val="C9A227"/>
-          </a:solidFill>
-          <a:ln>
-            <a:noFill/>
-          </a:ln>
-        </p:spPr>
-        <p:style>
-          <a:lnRef idx="1">
-            <a:schemeClr val="accent1"/>
-          </a:lnRef>
-          <a:fillRef idx="3">
-            <a:schemeClr val="accent1"/>
-          </a:fillRef>
-          <a:effectRef idx="2">
-            <a:schemeClr val="accent1"/>
-          </a:effectRef>
-          <a:fontRef idx="minor">
-            <a:schemeClr val="lt1"/>
-          </a:fontRef>
-        </p:style>
-        <p:txBody>
-          <a:bodyPr rtlCol="0" anchor="ctr"/>
-          <a:lstStyle/>
-          <a:p>
-            <a:pPr algn="ctr"/>
-          </a:p>
-        </p:txBody>
-      </p:sp>
-      <p:sp>
-        <p:nvSpPr>
-          <p:cNvPr id="10" name="TextBox 9"/>
-          <p:cNvSpPr txBox="1"/>
-          <p:nvPr/>
-        </p:nvSpPr>
-        <p:spPr>
-          <a:xfrm>
-            <a:off x="804672" y="6126480"/>
-            <a:ext cx="10607040" cy="530352"/>
-          </a:xfrm>
-          <a:prstGeom prst="rect">
-            <a:avLst/>
-          </a:prstGeom>
-          <a:noFill/>
-        </p:spPr>
-        <p:txBody>
-          <a:bodyPr wrap="square">
-            <a:spAutoFit/>
-          </a:bodyPr>
-          <a:lstStyle/>
-          <a:p>
-            <a:pPr algn="l"/>
-            <a:r>
-              <a:rPr sz="1200" b="0">
-                <a:solidFill>
-                  <a:srgbClr val="4A4A4A"/>
-                </a:solidFill>
-                <a:latin typeface="IPAGothic"/>
-              </a:rPr>
-              <a:t>※ 「理由未収集・不明」7名（25%）の解消に向け、辞退時の面談・アンケート実施を推奨</a:t>
-            </a:r>
-          </a:p>
-        </p:txBody>
-      </p:sp>
     </p:spTree>
   </p:cSld>
   <p:clrMapOvr>
@@ -6906,6 +8503,247 @@
                 </a:solidFill>
                 <a:latin typeface="IPAGothic"/>
               </a:rPr>
+              <a:t>大学別　応募者数</a:t>
+            </a:r>
+          </a:p>
+        </p:txBody>
+      </p:sp>
+      <p:sp>
+        <p:nvSpPr>
+          <p:cNvPr id="6" name="TextBox 5"/>
+          <p:cNvSpPr txBox="1"/>
+          <p:nvPr/>
+        </p:nvSpPr>
+        <p:spPr>
+          <a:xfrm>
+            <a:off x="411480" y="685800"/>
+            <a:ext cx="9144000" cy="347472"/>
+          </a:xfrm>
+          <a:prstGeom prst="rect">
+            <a:avLst/>
+          </a:prstGeom>
+          <a:noFill/>
+        </p:spPr>
+        <p:txBody>
+          <a:bodyPr wrap="square">
+            <a:spAutoFit/>
+          </a:bodyPr>
+          <a:lstStyle/>
+          <a:p>
+            <a:pPr algn="l"/>
+            <a:r>
+              <a:rPr sz="1300" b="0">
+                <a:solidFill>
+                  <a:srgbClr val="CCD6E8"/>
+                </a:solidFill>
+                <a:latin typeface="IPAGothic"/>
+              </a:rPr>
+              <a:t>上位校14大学の応募者数</a:t>
+            </a:r>
+          </a:p>
+        </p:txBody>
+      </p:sp>
+      <p:pic>
+        <p:nvPicPr>
+          <p:cNvPr id="7" name="Picture 6" descr="univ_bar.png"/>
+          <p:cNvPicPr>
+            <a:picLocks noChangeAspect="1"/>
+          </p:cNvPicPr>
+          <p:nvPr/>
+        </p:nvPicPr>
+        <p:blipFill>
+          <a:blip r:embed="rId2"/>
+          <a:stretch>
+            <a:fillRect/>
+          </a:stretch>
+        </p:blipFill>
+        <p:spPr>
+          <a:xfrm>
+            <a:off x="365760" y="1143000"/>
+            <a:ext cx="11430000" cy="5486400"/>
+          </a:xfrm>
+          <a:prstGeom prst="rect">
+            <a:avLst/>
+          </a:prstGeom>
+        </p:spPr>
+      </p:pic>
+    </p:spTree>
+  </p:cSld>
+  <p:clrMapOvr>
+    <a:masterClrMapping/>
+  </p:clrMapOvr>
+</p:sld>
+</file>
+
+<file path=ppt/slides/slide9.xml><?xml version="1.0" encoding="utf-8"?>
+<p:sld xmlns:a="http://schemas.openxmlformats.org/drawingml/2006/main" xmlns:p="http://schemas.openxmlformats.org/presentationml/2006/main" xmlns:r="http://schemas.openxmlformats.org/officeDocument/2006/relationships">
+  <p:cSld>
+    <p:spTree>
+      <p:nvGrpSpPr>
+        <p:cNvPr id="1" name=""/>
+        <p:cNvGrpSpPr/>
+        <p:nvPr/>
+      </p:nvGrpSpPr>
+      <p:grpSpPr/>
+      <p:sp>
+        <p:nvSpPr>
+          <p:cNvPr id="2" name="Rectangle 1"/>
+          <p:cNvSpPr/>
+          <p:nvPr/>
+        </p:nvSpPr>
+        <p:spPr>
+          <a:xfrm>
+            <a:off x="0" y="0"/>
+            <a:ext cx="12188952" cy="6858000"/>
+          </a:xfrm>
+          <a:prstGeom prst="rect">
+            <a:avLst/>
+          </a:prstGeom>
+          <a:solidFill>
+            <a:srgbClr val="F8F9FA"/>
+          </a:solidFill>
+          <a:ln>
+            <a:noFill/>
+          </a:ln>
+        </p:spPr>
+        <p:style>
+          <a:lnRef idx="1">
+            <a:schemeClr val="accent1"/>
+          </a:lnRef>
+          <a:fillRef idx="3">
+            <a:schemeClr val="accent1"/>
+          </a:fillRef>
+          <a:effectRef idx="2">
+            <a:schemeClr val="accent1"/>
+          </a:effectRef>
+          <a:fontRef idx="minor">
+            <a:schemeClr val="lt1"/>
+          </a:fontRef>
+        </p:style>
+        <p:txBody>
+          <a:bodyPr rtlCol="0" anchor="ctr"/>
+          <a:lstStyle/>
+          <a:p>
+            <a:pPr algn="ctr"/>
+          </a:p>
+        </p:txBody>
+      </p:sp>
+      <p:sp>
+        <p:nvSpPr>
+          <p:cNvPr id="3" name="Rectangle 2"/>
+          <p:cNvSpPr/>
+          <p:nvPr/>
+        </p:nvSpPr>
+        <p:spPr>
+          <a:xfrm>
+            <a:off x="0" y="0"/>
+            <a:ext cx="12188952" cy="1051560"/>
+          </a:xfrm>
+          <a:prstGeom prst="rect">
+            <a:avLst/>
+          </a:prstGeom>
+          <a:solidFill>
+            <a:srgbClr val="1E3A5F"/>
+          </a:solidFill>
+          <a:ln>
+            <a:noFill/>
+          </a:ln>
+        </p:spPr>
+        <p:style>
+          <a:lnRef idx="1">
+            <a:schemeClr val="accent1"/>
+          </a:lnRef>
+          <a:fillRef idx="3">
+            <a:schemeClr val="accent1"/>
+          </a:fillRef>
+          <a:effectRef idx="2">
+            <a:schemeClr val="accent1"/>
+          </a:effectRef>
+          <a:fontRef idx="minor">
+            <a:schemeClr val="lt1"/>
+          </a:fontRef>
+        </p:style>
+        <p:txBody>
+          <a:bodyPr rtlCol="0" anchor="ctr"/>
+          <a:lstStyle/>
+          <a:p>
+            <a:pPr algn="ctr"/>
+          </a:p>
+        </p:txBody>
+      </p:sp>
+      <p:sp>
+        <p:nvSpPr>
+          <p:cNvPr id="4" name="Rectangle 3"/>
+          <p:cNvSpPr/>
+          <p:nvPr/>
+        </p:nvSpPr>
+        <p:spPr>
+          <a:xfrm>
+            <a:off x="0" y="987552"/>
+            <a:ext cx="12188952" cy="91440"/>
+          </a:xfrm>
+          <a:prstGeom prst="rect">
+            <a:avLst/>
+          </a:prstGeom>
+          <a:solidFill>
+            <a:srgbClr val="C9A227"/>
+          </a:solidFill>
+          <a:ln>
+            <a:noFill/>
+          </a:ln>
+        </p:spPr>
+        <p:style>
+          <a:lnRef idx="1">
+            <a:schemeClr val="accent1"/>
+          </a:lnRef>
+          <a:fillRef idx="3">
+            <a:schemeClr val="accent1"/>
+          </a:fillRef>
+          <a:effectRef idx="2">
+            <a:schemeClr val="accent1"/>
+          </a:effectRef>
+          <a:fontRef idx="minor">
+            <a:schemeClr val="lt1"/>
+          </a:fontRef>
+        </p:style>
+        <p:txBody>
+          <a:bodyPr rtlCol="0" anchor="ctr"/>
+          <a:lstStyle/>
+          <a:p>
+            <a:pPr algn="ctr"/>
+          </a:p>
+        </p:txBody>
+      </p:sp>
+      <p:sp>
+        <p:nvSpPr>
+          <p:cNvPr id="5" name="TextBox 4"/>
+          <p:cNvSpPr txBox="1"/>
+          <p:nvPr/>
+        </p:nvSpPr>
+        <p:spPr>
+          <a:xfrm>
+            <a:off x="411480" y="91440"/>
+            <a:ext cx="10058400" cy="713232"/>
+          </a:xfrm>
+          <a:prstGeom prst="rect">
+            <a:avLst/>
+          </a:prstGeom>
+          <a:noFill/>
+        </p:spPr>
+        <p:txBody>
+          <a:bodyPr wrap="square">
+            <a:spAutoFit/>
+          </a:bodyPr>
+          <a:lstStyle/>
+          <a:p>
+            <a:pPr algn="l"/>
+            <a:r>
+              <a:rPr sz="2600" b="1">
+                <a:solidFill>
+                  <a:srgbClr val="FFFFFF"/>
+                </a:solidFill>
+                <a:latin typeface="IPAGothic"/>
+              </a:rPr>
               <a:t>考察・次のアクション</a:t>
             </a:r>
           </a:p>
@@ -7140,7 +8978,7 @@
                 </a:solidFill>
                 <a:latin typeface="IPAGothic"/>
               </a:rPr>
-              <a:t>辞退防止策の強化</a:t>
+              <a:t>説明会兼面談での辞退防止</a:t>
             </a:r>
           </a:p>
         </p:txBody>
@@ -7175,8 +9013,8 @@
                 </a:solidFill>
                 <a:latin typeface="IPAGothic"/>
               </a:rPr>
-              <a:t>辞退者28名（47.5%）が最大の離脱要因。特に他社内定・優先（9名）が最多。
-選考スピード改善・オファー面談の設計見直しと、辞退理由の詳細収集体制を整備。</a:t>
+              <a:t>最大離脱ポイント（18名辞退）。他社内定・優先4名、音信不通4名が主因。
+選考スピード改善・早期フォロー施策・説明会当日のエンゲージメント向上が急務。</a:t>
             </a:r>
           </a:p>
         </p:txBody>
@@ -7375,7 +9213,7 @@
                 </a:solidFill>
                 <a:latin typeface="IPAGothic"/>
               </a:rPr>
-              <a:t>説明会兼面談→一次選考の歩留まり向上</a:t>
+              <a:t>一次選考の歩留まり向上</a:t>
             </a:r>
           </a:p>
         </p:txBody>
@@ -7410,8 +9248,8 @@
                 </a:solidFill>
                 <a:latin typeface="IPAGothic"/>
               </a:rPr>
-              <a:t>説明会兼面談通過27名のうち一次選考通過は11名（41%）。
-通過後のフォロー強化とエンゲージメント施策で通過率改善を目指す。</a:t>
+              <a:t>通過率41%。辞退7名のうち他社優先3名・業界不一致2名。
+一次選考前のフォロー面談設置や企業理解促進で離脱を抑制する。</a:t>
             </a:r>
           </a:p>
         </p:txBody>
@@ -7845,7 +9683,7 @@
                 </a:solidFill>
                 <a:latin typeface="IPAGothic"/>
               </a:rPr>
-              <a:t>選考データの継続モニタリング</a:t>
+              <a:t>辞退理由の収集体制強化</a:t>
             </a:r>
           </a:p>
         </p:txBody>
@@ -7880,8 +9718,8 @@
                 </a:solidFill>
                 <a:latin typeface="IPAGothic"/>
               </a:rPr>
-              <a:t>現在選考中23名のフォローを継続。通過率・辞退率を月次トラッキングし、
-採用目標達成に向けた定量管理体制を構築する。</a:t>
+              <a:t>全28名中「未収集・不明」が7名（25%）。辞退申告時に理由を必ず収集する
+フロー整備（簡易アンケート・退会時ヒアリング）を導入する。</a:t>
             </a:r>
           </a:p>
         </p:txBody>

</xml_diff>

<commit_message>
Add BY column (withdrawal detail) full list slide
Co-Authored-By: Claude Sonnet 4.6 <noreply@anthropic.com>
Claude-Session: https://claude.ai/code/session_013nk1DEsSGa4nKpUoythx1H
</commit_message>
<xml_diff>
--- a/上位校採用分析レポート_2026.pptx
+++ b/上位校採用分析レポート_2026.pptx
@@ -11,6 +11,7 @@
     <p:sldId id="259" r:id="rId10"/>
     <p:sldId id="260" r:id="rId11"/>
     <p:sldId id="261" r:id="rId12"/>
+    <p:sldId id="265" r:id="rId16"/>
     <p:sldId id="262" r:id="rId13"/>
     <p:sldId id="263" r:id="rId14"/>
     <p:sldId id="264" r:id="rId15"/>
@@ -3747,6 +3748,247 @@
           </a:p>
         </p:txBody>
       </p:sp>
+    </p:spTree>
+  </p:cSld>
+  <p:clrMapOvr>
+    <a:masterClrMapping/>
+  </p:clrMapOvr>
+</p:sld>
+</file>
+
+<file path=ppt/slides/slide10.xml><?xml version="1.0" encoding="utf-8"?>
+<p:sld xmlns:a="http://schemas.openxmlformats.org/drawingml/2006/main" xmlns:p="http://schemas.openxmlformats.org/presentationml/2006/main" xmlns:r="http://schemas.openxmlformats.org/officeDocument/2006/relationships">
+  <p:cSld>
+    <p:spTree>
+      <p:nvGrpSpPr>
+        <p:cNvPr id="1" name=""/>
+        <p:cNvGrpSpPr/>
+        <p:nvPr/>
+      </p:nvGrpSpPr>
+      <p:grpSpPr/>
+      <p:sp>
+        <p:nvSpPr>
+          <p:cNvPr id="2" name="Rectangle 1"/>
+          <p:cNvSpPr/>
+          <p:nvPr/>
+        </p:nvSpPr>
+        <p:spPr>
+          <a:xfrm>
+            <a:off x="0" y="0"/>
+            <a:ext cx="12188952" cy="6858000"/>
+          </a:xfrm>
+          <a:prstGeom prst="rect">
+            <a:avLst/>
+          </a:prstGeom>
+          <a:solidFill>
+            <a:srgbClr val="F8F9FA"/>
+          </a:solidFill>
+          <a:ln>
+            <a:noFill/>
+          </a:ln>
+        </p:spPr>
+        <p:style>
+          <a:lnRef idx="1">
+            <a:schemeClr val="accent1"/>
+          </a:lnRef>
+          <a:fillRef idx="3">
+            <a:schemeClr val="accent1"/>
+          </a:fillRef>
+          <a:effectRef idx="2">
+            <a:schemeClr val="accent1"/>
+          </a:effectRef>
+          <a:fontRef idx="minor">
+            <a:schemeClr val="lt1"/>
+          </a:fontRef>
+        </p:style>
+        <p:txBody>
+          <a:bodyPr rtlCol="0" anchor="ctr"/>
+          <a:lstStyle/>
+          <a:p>
+            <a:pPr algn="ctr"/>
+          </a:p>
+        </p:txBody>
+      </p:sp>
+      <p:sp>
+        <p:nvSpPr>
+          <p:cNvPr id="3" name="Rectangle 2"/>
+          <p:cNvSpPr/>
+          <p:nvPr/>
+        </p:nvSpPr>
+        <p:spPr>
+          <a:xfrm>
+            <a:off x="0" y="0"/>
+            <a:ext cx="12188952" cy="1051560"/>
+          </a:xfrm>
+          <a:prstGeom prst="rect">
+            <a:avLst/>
+          </a:prstGeom>
+          <a:solidFill>
+            <a:srgbClr val="1E3A5F"/>
+          </a:solidFill>
+          <a:ln>
+            <a:noFill/>
+          </a:ln>
+        </p:spPr>
+        <p:style>
+          <a:lnRef idx="1">
+            <a:schemeClr val="accent1"/>
+          </a:lnRef>
+          <a:fillRef idx="3">
+            <a:schemeClr val="accent1"/>
+          </a:fillRef>
+          <a:effectRef idx="2">
+            <a:schemeClr val="accent1"/>
+          </a:effectRef>
+          <a:fontRef idx="minor">
+            <a:schemeClr val="lt1"/>
+          </a:fontRef>
+        </p:style>
+        <p:txBody>
+          <a:bodyPr rtlCol="0" anchor="ctr"/>
+          <a:lstStyle/>
+          <a:p>
+            <a:pPr algn="ctr"/>
+          </a:p>
+        </p:txBody>
+      </p:sp>
+      <p:sp>
+        <p:nvSpPr>
+          <p:cNvPr id="4" name="Rectangle 3"/>
+          <p:cNvSpPr/>
+          <p:nvPr/>
+        </p:nvSpPr>
+        <p:spPr>
+          <a:xfrm>
+            <a:off x="0" y="987552"/>
+            <a:ext cx="12188952" cy="91440"/>
+          </a:xfrm>
+          <a:prstGeom prst="rect">
+            <a:avLst/>
+          </a:prstGeom>
+          <a:solidFill>
+            <a:srgbClr val="C9A227"/>
+          </a:solidFill>
+          <a:ln>
+            <a:noFill/>
+          </a:ln>
+        </p:spPr>
+        <p:style>
+          <a:lnRef idx="1">
+            <a:schemeClr val="accent1"/>
+          </a:lnRef>
+          <a:fillRef idx="3">
+            <a:schemeClr val="accent1"/>
+          </a:fillRef>
+          <a:effectRef idx="2">
+            <a:schemeClr val="accent1"/>
+          </a:effectRef>
+          <a:fontRef idx="minor">
+            <a:schemeClr val="lt1"/>
+          </a:fontRef>
+        </p:style>
+        <p:txBody>
+          <a:bodyPr rtlCol="0" anchor="ctr"/>
+          <a:lstStyle/>
+          <a:p>
+            <a:pPr algn="ctr"/>
+          </a:p>
+        </p:txBody>
+      </p:sp>
+      <p:sp>
+        <p:nvSpPr>
+          <p:cNvPr id="5" name="TextBox 4"/>
+          <p:cNvSpPr txBox="1"/>
+          <p:nvPr/>
+        </p:nvSpPr>
+        <p:spPr>
+          <a:xfrm>
+            <a:off x="411480" y="91440"/>
+            <a:ext cx="10058400" cy="713232"/>
+          </a:xfrm>
+          <a:prstGeom prst="rect">
+            <a:avLst/>
+          </a:prstGeom>
+          <a:noFill/>
+        </p:spPr>
+        <p:txBody>
+          <a:bodyPr wrap="square">
+            <a:spAutoFit/>
+          </a:bodyPr>
+          <a:lstStyle/>
+          <a:p>
+            <a:pPr algn="l"/>
+            <a:r>
+              <a:rPr sz="2600" b="1">
+                <a:solidFill>
+                  <a:srgbClr val="FFFFFF"/>
+                </a:solidFill>
+                <a:latin typeface="IPAGothic"/>
+              </a:rPr>
+              <a:t>辞退理由　全件一覧（BY列：辞退理由詳細）</a:t>
+            </a:r>
+          </a:p>
+        </p:txBody>
+      </p:sp>
+      <p:sp>
+        <p:nvSpPr>
+          <p:cNvPr id="6" name="TextBox 5"/>
+          <p:cNvSpPr txBox="1"/>
+          <p:nvPr/>
+        </p:nvSpPr>
+        <p:spPr>
+          <a:xfrm>
+            <a:off x="411480" y="685800"/>
+            <a:ext cx="9144000" cy="347472"/>
+          </a:xfrm>
+          <a:prstGeom prst="rect">
+            <a:avLst/>
+          </a:prstGeom>
+          <a:noFill/>
+        </p:spPr>
+        <p:txBody>
+          <a:bodyPr wrap="square">
+            <a:spAutoFit/>
+          </a:bodyPr>
+          <a:lstStyle/>
+          <a:p>
+            <a:pPr algn="l"/>
+            <a:r>
+              <a:rPr sz="1300" b="0">
+                <a:solidFill>
+                  <a:srgbClr val="CCD6E8"/>
+                </a:solidFill>
+                <a:latin typeface="IPAGothic"/>
+              </a:rPr>
+              <a:t>辞退者28名　ステップ別・理由カテゴリ別・詳細理由</a:t>
+            </a:r>
+          </a:p>
+        </p:txBody>
+      </p:sp>
+      <p:pic>
+        <p:nvPicPr>
+          <p:cNvPr id="7" name="Picture 6" descr="withdrawal_detail_table.png"/>
+          <p:cNvPicPr>
+            <a:picLocks noChangeAspect="1"/>
+          </p:cNvPicPr>
+          <p:nvPr/>
+        </p:nvPicPr>
+        <p:blipFill>
+          <a:blip r:embed="rId2"/>
+          <a:stretch>
+            <a:fillRect/>
+          </a:stretch>
+        </p:blipFill>
+        <p:spPr>
+          <a:xfrm>
+            <a:off x="137160" y="1078992"/>
+            <a:ext cx="11887200" cy="5669280"/>
+          </a:xfrm>
+          <a:prstGeom prst="rect">
+            <a:avLst/>
+          </a:prstGeom>
+        </p:spPr>
+      </p:pic>
     </p:spTree>
   </p:cSld>
   <p:clrMapOvr>

</xml_diff>